<commit_message>
remove master submission artifacts build script and presentation documents
</commit_message>
<xml_diff>
--- a/final/Project_Presentation_Final.pptx
+++ b/final/Project_Presentation_Final.pptx
@@ -146,7 +146,7 @@
                 </a:solidFill>
                 <a:latin typeface="Calibri"/>
               </a:rPr>
-              <a:t>Share of clean observations by country (%)</a:t>
+              <a:t>Share of clean observations (%)</a:t>
             </a:r>
           </a:p>
         </c:rich>
@@ -213,19 +213,19 @@
                 <c:ptCount val="5"/>
                 <c:lvl>
                   <c:pt idx="0">
-                    <c:v>England</c:v>
+                    <c:v>England 2.13 M</c:v>
                   </c:pt>
                   <c:pt idx="1">
-                    <c:v>USA</c:v>
+                    <c:v>USA 407 k</c:v>
                   </c:pt>
                   <c:pt idx="2">
-                    <c:v>Ireland</c:v>
+                    <c:v>Ireland 234 k</c:v>
                   </c:pt>
                   <c:pt idx="3">
-                    <c:v>China</c:v>
+                    <c:v>China 46 k</c:v>
                   </c:pt>
                   <c:pt idx="4">
-                    <c:v>Canada</c:v>
+                    <c:v>Canada 3.9 k</c:v>
                   </c:pt>
                 </c:lvl>
               </c:multiLvlStrCache>
@@ -331,7 +331,7 @@
         <c:axId val="2094734552"/>
         <c:scaling>
           <c:orientation val="minMax"/>
-          <c:max val="90"/>
+          <c:max val="100"/>
         </c:scaling>
         <c:delete val="0"/>
         <c:axPos val="b"/>
@@ -490,9 +490,9 @@
           </c:dLbls>
           <c:cat>
             <c:multiLvlStrRef>
-              <c:f>Sheet1!$A$2:$A$5</c:f>
+              <c:f>Sheet1!$A$2:$A$4</c:f>
               <c:multiLvlStrCache>
-                <c:ptCount val="4"/>
+                <c:ptCount val="3"/>
                 <c:lvl>
                   <c:pt idx="0">
                     <c:v>Orthophosphate</c:v>
@@ -503,19 +503,16 @@
                   <c:pt idx="2">
                     <c:v>BOD</c:v>
                   </c:pt>
-                  <c:pt idx="3">
-                    <c:v>N:P ratio</c:v>
-                  </c:pt>
                 </c:lvl>
               </c:multiLvlStrCache>
             </c:multiLvlStrRef>
           </c:cat>
           <c:val>
             <c:numRef>
-              <c:f>Sheet1!$B$2:$B$5</c:f>
+              <c:f>Sheet1!$B$2:$B$4</c:f>
               <c:numCache>
                 <c:formatCode>General</c:formatCode>
-                <c:ptCount val="4"/>
+                <c:ptCount val="3"/>
                 <c:pt idx="0">
                   <c:v>-0.66</c:v>
                 </c:pt>
@@ -524,9 +521,6 @@
                 </c:pt>
                 <c:pt idx="2">
                   <c:v>-0.321</c:v>
-                </c:pt>
-                <c:pt idx="3">
-                  <c:v>0.013</c:v>
                 </c:pt>
               </c:numCache>
             </c:numRef>
@@ -579,9 +573,9 @@
           </c:dLbls>
           <c:cat>
             <c:multiLvlStrRef>
-              <c:f>Sheet1!$A$2:$A$5</c:f>
+              <c:f>Sheet1!$A$2:$A$4</c:f>
               <c:multiLvlStrCache>
-                <c:ptCount val="4"/>
+                <c:ptCount val="3"/>
                 <c:lvl>
                   <c:pt idx="0">
                     <c:v>Orthophosphate</c:v>
@@ -592,19 +586,16 @@
                   <c:pt idx="2">
                     <c:v>BOD</c:v>
                   </c:pt>
-                  <c:pt idx="3">
-                    <c:v>N:P ratio</c:v>
-                  </c:pt>
                 </c:lvl>
               </c:multiLvlStrCache>
             </c:multiLvlStrRef>
           </c:cat>
           <c:val>
             <c:numRef>
-              <c:f>Sheet1!$C$2:$C$5</c:f>
+              <c:f>Sheet1!$C$2:$C$4</c:f>
               <c:numCache>
                 <c:formatCode>General</c:formatCode>
-                <c:ptCount val="4"/>
+                <c:ptCount val="3"/>
                 <c:pt idx="0">
                   <c:v>-0.853</c:v>
                 </c:pt>
@@ -613,9 +604,6 @@
                 </c:pt>
                 <c:pt idx="2">
                   <c:v>-0.578</c:v>
-                </c:pt>
-                <c:pt idx="3">
-                  <c:v>0.517</c:v>
                 </c:pt>
               </c:numCache>
             </c:numRef>
@@ -696,7 +684,7 @@
         <c:axId val="2094734552"/>
         <c:scaling>
           <c:orientation val="minMax"/>
-          <c:max val="0.8"/>
+          <c:max val="0"/>
           <c:min val="-1"/>
         </c:scaling>
         <c:delete val="0"/>
@@ -835,7 +823,7 @@
               <c:strCache>
                 <c:ptCount val="1"/>
                 <c:pt idx="0">
-                  <c:v>Validation MAE (WQI points)</c:v>
+                  <c:v>Validation MAE (index points)</c:v>
                 </c:pt>
               </c:strCache>
             </c:strRef>
@@ -881,10 +869,10 @@
                     <c:v>Random Forest</c:v>
                   </c:pt>
                   <c:pt idx="1">
-                    <c:v>XGBoost</c:v>
+                    <c:v>XGBoost (comparison)</c:v>
                   </c:pt>
                   <c:pt idx="2">
-                    <c:v>Dual-head MLP</c:v>
+                    <c:v>XGBoost (saved)</c:v>
                   </c:pt>
                 </c:lvl>
               </c:multiLvlStrCache>
@@ -903,7 +891,7 @@
                   <c:v>0.137</c:v>
                 </c:pt>
                 <c:pt idx="2">
-                  <c:v>0.706</c:v>
+                  <c:v>0.161</c:v>
                 </c:pt>
               </c:numCache>
             </c:numRef>
@@ -984,7 +972,7 @@
         <c:axId val="2094734552"/>
         <c:scaling>
           <c:orientation val="minMax"/>
-          <c:max val="0.9"/>
+          <c:max val="0.2"/>
         </c:scaling>
         <c:delete val="0"/>
         <c:axPos val="l"/>
@@ -1081,7 +1069,7 @@
                 </a:solidFill>
                 <a:latin typeface="Calibri"/>
               </a:rPr>
-              <a:t>Built-in importance (% of total), top features</a:t>
+              <a:t>Built-in importance from the saved models (% of total)</a:t>
             </a:r>
           </a:p>
         </c:rich>
@@ -1105,7 +1093,7 @@
               <c:strCache>
                 <c:ptCount val="1"/>
                 <c:pt idx="0">
-                  <c:v>Random Forest</c:v>
+                  <c:v>Random Forest (impurity)</c:v>
                 </c:pt>
               </c:strCache>
             </c:strRef>
@@ -1160,13 +1148,13 @@
                     <c:v>log1p_ammonia</c:v>
                   </c:pt>
                   <c:pt idx="4">
-                    <c:v>unionized_ammonia</c:v>
+                    <c:v>log1p_bod</c:v>
                   </c:pt>
                   <c:pt idx="5">
-                    <c:v>log1p_bod</c:v>
+                    <c:v>exceedance_counter</c:v>
                   </c:pt>
                   <c:pt idx="6">
-                    <c:v>exceedance_counter</c:v>
+                    <c:v>hist_ortho_lag1</c:v>
                   </c:pt>
                 </c:lvl>
               </c:multiLvlStrCache>
@@ -1191,13 +1179,13 @@
                   <c:v>4.38</c:v>
                 </c:pt>
                 <c:pt idx="4">
+                  <c:v>0.76</c:v>
+                </c:pt>
+                <c:pt idx="5">
                   <c:v>0</c:v>
                 </c:pt>
-                <c:pt idx="5">
-                  <c:v>0.76</c:v>
-                </c:pt>
                 <c:pt idx="6">
-                  <c:v>0.04</c:v>
+                  <c:v>0</c:v>
                 </c:pt>
               </c:numCache>
             </c:numRef>
@@ -1212,7 +1200,7 @@
               <c:strCache>
                 <c:ptCount val="1"/>
                 <c:pt idx="0">
-                  <c:v>XGBoost</c:v>
+                  <c:v>XGBoost (gain share)</c:v>
                 </c:pt>
               </c:strCache>
             </c:strRef>
@@ -1267,13 +1255,13 @@
                     <c:v>log1p_ammonia</c:v>
                   </c:pt>
                   <c:pt idx="4">
-                    <c:v>unionized_ammonia</c:v>
+                    <c:v>log1p_bod</c:v>
                   </c:pt>
                   <c:pt idx="5">
-                    <c:v>log1p_bod</c:v>
+                    <c:v>exceedance_counter</c:v>
                   </c:pt>
                   <c:pt idx="6">
-                    <c:v>exceedance_counter</c:v>
+                    <c:v>hist_ortho_lag1</c:v>
                   </c:pt>
                 </c:lvl>
               </c:multiLvlStrCache>
@@ -1286,25 +1274,25 @@
                 <c:formatCode>General</c:formatCode>
                 <c:ptCount val="7"/>
                 <c:pt idx="0">
-                  <c:v>49.3</c:v>
+                  <c:v>12.35</c:v>
                 </c:pt>
                 <c:pt idx="1">
-                  <c:v>36.73</c:v>
+                  <c:v>64.01</c:v>
                 </c:pt>
                 <c:pt idx="2">
-                  <c:v>5.85</c:v>
+                  <c:v>6.86</c:v>
                 </c:pt>
                 <c:pt idx="3">
-                  <c:v>1.15</c:v>
+                  <c:v>7.78</c:v>
                 </c:pt>
                 <c:pt idx="4">
-                  <c:v>2.04</c:v>
+                  <c:v>1.26</c:v>
                 </c:pt>
                 <c:pt idx="5">
-                  <c:v>1.7</c:v>
+                  <c:v>1.9</c:v>
                 </c:pt>
                 <c:pt idx="6">
-                  <c:v>0.78</c:v>
+                  <c:v>1.53</c:v>
                 </c:pt>
               </c:numCache>
             </c:numRef>
@@ -1385,7 +1373,7 @@
         <c:axId val="2094734552"/>
         <c:scaling>
           <c:orientation val="minMax"/>
-          <c:max val="60"/>
+          <c:max val="80"/>
         </c:scaling>
         <c:delete val="0"/>
         <c:axPos val="b"/>
@@ -1868,7 +1856,7 @@
           <a:p>
             <a:r>
               <a:rPr lang="en-US" dirty="0"/>
-              <a:t>Introduce the project: predicting CCME WQI from eight measured parameters plus engineered features. Say up front that the deck includes an audit of the very high scores — that is deliberate.</a:t>
+              <a:t>Introduce the project: estimating CCME WQI from eight measured parameters plus engineered features. Say up front that the deck includes an audit of the very high scores; that is deliberate.</a:t>
             </a:r>
             <a:endParaRPr lang="en-US" dirty="0"/>
           </a:p>
@@ -1956,7 +1944,7 @@
           <a:p>
             <a:r>
               <a:rPr lang="en-US" dirty="0"/>
-              <a:t>All numbers are validation-set (422,943 rows). RF has the lowest error, XGBoost is close, and the MLP trades about 5x higher MAE for multi-task output with calibrated probabilities (ECE 1.27%, accuracy 96.09%, macro F1 0.9485). Latency figures (0.42 s vs 3.85 s) are deliberately NOT on the slide: hardware, batch setup and RF size are undocumented and the RF configuration is disputed.</a:t>
+              <a:t>RF numbers are identical in model_comparison.csv and training_history.csv (MAE 0.0521, RMSE 0.2081, R2 0.99986; train MAE 0.047, so a small train-val gap). XGBoost has two versions in the repo: model_comparison.csv (from tree_val_predictions.parquet) gives MAE 0.1375, RMSE 0.3740, R2 0.99955, which is what the written report used; the training notebook and the saved model's recorded best_score give MAE 0.1611, RMSE 0.4372, R2 0.99939. The saved predictions file therefore does not match the saved model; re-run notebooks 03 and 04 to settle this. Conclusions are unchanged. Latency numbers are omitted: no timing code or hardware is documented.</a:t>
             </a:r>
             <a:endParaRPr lang="en-US" dirty="0"/>
           </a:p>
@@ -2044,7 +2032,7 @@
           <a:p>
             <a:r>
               <a:rPr lang="en-US" dirty="0"/>
-              <a:t>This is the most important slide for credibility. (1) The team's own viva guide states the WQI is an exact deterministic aggregation of the chemical parameters, so the models emulate the formula. (2) exceedance_counter counts guideline violations, which is the same raw ingredient as F1; its low importance is expected because the raw columns already carry it. We could not read the code, so it is unresolved, not proven leakage. (3) The split is random, with station-lag features, so neighbouring observations cross partitions. Recommend dropping exceedance_counter and re-running, and a station-held-out and time-forward split. None of these experiments has been run.</a:t>
+              <a:t>Updated after reading the code. (1) The target is supplied with the data and is computed from the same eight parameters; the repo's own evaluation notebook concludes the scores measure reconstruction of the index from same-time measurements. (2) exceedance_counter: we previously treated it as a leakage risk. The code shows it uses six input columns and its own thresholds, not the target or F1-F3 (F1-F3 are not columns in the dataset). It is a legitimate, if redundant, feature. An ablation without it has not been run. (3) The split is random, station lags are built on the full data, XGBoost early-stops on validation, and the test set is unscored. Nothing here shows leakage in a pipeline sense; it shows the evaluation cannot support forecasting claims.</a:t>
             </a:r>
             <a:endParaRPr lang="en-US" dirty="0"/>
           </a:p>
@@ -2132,7 +2120,7 @@
           <a:p>
             <a:r>
               <a:rPr lang="en-US" dirty="0"/>
-              <a:t>Importances come from the repo technical report: built-in Gini (RF) and gain (XGBoost) importances, NOT TreeSHAP and NOT split counts as the PDF wording says. Orthophosphate plus its log variant account for 86-88% of importance. A plausible, unverified explanation: the orthophosphate limit (0.05 mg/L) is close to the median reading (0.040), so it is exceeded often and moves the index most. The PDF claim that hist_ortho_lag1 ranks second is not supported by its own beeswarm or the importance table.</a:t>
+              <a:t>Random Forest values: built-in impurity importance read from the saved joblib. XGBoost values: average-gain share computed from the saved xgboost_model.json trees. Orthophosphate plus its log variant: 88.5% (RF) and 76.4% (XGBoost). hist_ortho_lag1 is about 0 in RF and 1.5% (rank 6) in XGBoost, so the older claim that it ranks second is wrong. country_code is about 0 in both. The SHAP beeswarm (repo graph 16) was computed on 250 validation rows; mean |SHAP| for orthophosphate is about 8.3 index points. A plausible, unverified reason for orthophosphate's weight: the guideline sits close to its median value.</a:t>
             </a:r>
             <a:endParaRPr lang="en-US" dirty="0"/>
           </a:p>
@@ -2220,7 +2208,7 @@
           <a:p>
             <a:r>
               <a:rPr lang="en-US" dirty="0"/>
-              <a:t>Be precise about status. The PDF report lists deep learning as future work, but the repo technical report and AGENT.md document a trained dual-head MLP with validation metrics, so it is presented as implemented (validation only; notebook outputs were not independently re-run). Planned items are exactly that: planned.</a:t>
+              <a:t>Be precise about status. Deep learning: the repo has no neural-network code, notebook or results. Older markdown reports quote an MLP table, but it cannot be reproduced from this repo, so it is excluded. The completeness caveat comes from clustered raw values and repo graph 17.</a:t>
             </a:r>
             <a:endParaRPr lang="en-US" dirty="0"/>
           </a:p>
@@ -2307,8 +2295,10 @@
           <a:lstStyle/>
           <a:p>
             <a:r>
-              <a:t>Aman closes: strongest verified result first, then the main limitation, then invite questions.</a:t>
-            </a:r>
+              <a:rPr lang="en-US" dirty="0"/>
+              <a:t>Close with the strongest verified result, then the main caveat. Names and roles are from the team table.</a:t>
+            </a:r>
+            <a:endParaRPr lang="en-US" dirty="0"/>
           </a:p>
         </p:txBody>
       </p:sp>
@@ -2394,7 +2384,7 @@
           <a:p>
             <a:r>
               <a:rPr lang="en-US" dirty="0"/>
-              <a:t>BOD5 needs a five-day incubation (120 h). The model is a surrogate that maps already-measured parameters to an index. Do NOT claim real-time deployment or lab replacement: no deployment was built or tested.</a:t>
+              <a:t>BOD5 needs a five-day incubation (120 h). The model is a surrogate mapping already-measured parameters to an index. Do not claim real-time deployment or lab replacement: nothing like that was built or tested.</a:t>
             </a:r>
             <a:endParaRPr lang="en-US" dirty="0"/>
           </a:p>
@@ -2482,7 +2472,7 @@
           <a:p>
             <a:r>
               <a:rPr lang="en-US" dirty="0"/>
-              <a:t>Walk through F1 scope, F2 frequency, F3 amplitude. Mention that tier thresholds are the standard CCME bands. Note the dataset's index values are pre-computed from the same eight parameters we use as inputs; this matters on slide 11.</a:t>
+              <a:t>Walk through F1 scope, F2 frequency, F3 amplitude. Tier thresholds are the standard CCME bands. Tier shares come from the repo's graph 11. The dataset's index values are supplied with the data and are a function of the same eight parameters used as inputs; this matters on slide 11.</a:t>
             </a:r>
             <a:endParaRPr lang="en-US" dirty="0"/>
           </a:p>
@@ -2570,7 +2560,7 @@
           <a:p>
             <a:r>
               <a:rPr lang="en-US" dirty="0"/>
-              <a:t>KPIs are the audited figures. Stress the imbalance: Canada contributes under 4,000 rows. Mention the discrepancy: report Table I shows England at 83.7% while the EDA figure counts give 75.5%; we use the EDA counts because they sum exactly to 2,819,617.</a:t>
+              <a:t>KPIs are the audited figures from the executed EDA notebook. Stress the imbalance: Canada contributes under 4,000 rows, and almost all records are from after about 2000 (graph 03). Mention that the older report Table I (England 83.7%) was wrong; the notebook counts sum exactly to 2,819,617.</a:t>
             </a:r>
             <a:endParaRPr lang="en-US" dirty="0"/>
           </a:p>
@@ -2658,7 +2648,7 @@
           <a:p>
             <a:r>
               <a:rPr lang="en-US" dirty="0"/>
-              <a:t>Distinguish missingness from implausibility. The audit found 0 nulls in the 14 source columns, so nothing was imputed. Physical screening is a separate step: 8,360 rows (0.296%) were dropped. Per-parameter counts sum to more than 8,360 because rows can violate several bounds; the report says the union was taken.</a:t>
+              <a:t>Executed notebook output: raw 2,827,977 rows x 14 columns, 0 nulls; 8,360 unique impossible rows (union). Per-parameter counts overlap. Completeness caveat: several raw columns cluster at single values (BOD median 2.70, Q3 2.83; nitrate median 4.50, Q3 4.94), and graph 17 in the repo, from an earlier data version, shows 26-34% missing in chemical columns. We cannot tell from the repo whether the 0-null file reflects genuine measurements or upstream filling. Say this plainly.</a:t>
             </a:r>
             <a:endParaRPr lang="en-US" dirty="0"/>
           </a:p>
@@ -2746,7 +2736,7 @@
           <a:p>
             <a:r>
               <a:rPr lang="en-US" dirty="0"/>
-              <a:t>Left: dissolved oxygen against temperature follows the Benson-Krause saturation envelope (figure from the project report). Right: Pearson correlation with the WQI before and after log(1+x) — values from the technical report. Stress the nuance: log(1+x) is monotonic, so it cannot change rank correlation (raw orthophosphate Spearman is already -0.917) and tree models are invariant to it. It helps linear models and the neural network, not the tree accuracy.</a:t>
+              <a:t>Left: repo graph 07, dissolved oxygen against temperature with the Benson-Krause saturation envelope. Right: Pearson correlation with the WQI before and after log(1+x), from the executed preprocessing notebook (orthophosphate -0.6603 to -0.8531; ammonia -0.3922 to -0.6594; BOD -0.3212 to -0.5775; N:P log 0.5169). Nuance, verified in the same notebook table: orthophosphate Spearman is -0.9172 both raw and log, because rank correlation ignores monotone transforms; trees are invariant to them too.</a:t>
             </a:r>
             <a:endParaRPr lang="en-US" dirty="0"/>
           </a:p>
@@ -2834,7 +2824,7 @@
           <a:p>
             <a:r>
               <a:rPr lang="en-US" dirty="0"/>
-              <a:t>Count check: 8+7+7+6+1+2+7 = 38. Point out the amber card: exceedance_counter is a guideline-violation count, which is built from the same quantities as the target; slide 11 treats this as unresolved.</a:t>
+              <a:t>Count check: 8+7+7+6+1+2+7 = 38 (from preprocessing_metadata.json). exceedance_counter is computed in the preprocessing notebook from six input columns with its own thresholds (pH outside 6.5-8.5, DO &lt; 6.5, ammonia &gt; 0.5, BOD &gt; 4, nitrate &gt; 10, orthophosphate &gt; 0.1). It is not a target column and uses only inputs available at prediction time, so it is not target leakage by data flow, but it is redundant with the raw inputs. Lags: previous record within the same Area (sorted by date); the first record of each Area is filled with the global median.</a:t>
             </a:r>
             <a:endParaRPr lang="en-US" dirty="0"/>
           </a:p>
@@ -2922,7 +2912,7 @@
           <a:p>
             <a:r>
               <a:rPr lang="en-US" dirty="0"/>
-              <a:t>Order is taken from the notebook descriptions: preprocessing notebook = cleaning, 38 features, stratified split. Lags therefore exist before partitioning. The split is random, so neighbouring observations of one station can fall in different partitions. Tests: 12 reported (features 4, models 3, leakage 2, metrics 3). They verify those properties only — not scientific validity. We did not re-run them.</a:t>
+              <a:t>Order taken from the preprocessing notebook: load EDA-cleaned data, engineer 38 features (including per-Area lags over the whole dataset), assert targets are not in the feature list, then a stratified random split by WQI tier (seed 42). A StandardScaler is fitted on train, but scaled partitions are not saved or used in Phase 1; trees use raw units. XGBoost early stopping watches the validation set. Tests: 12 test functions (features 4, leakage 2, metrics 3, models 3). We could not execute them here (xgboost missing offline), so pass status is as reported.</a:t>
             </a:r>
             <a:endParaRPr lang="en-US" dirty="0"/>
           </a:p>
@@ -3010,7 +3000,7 @@
           <a:p>
             <a:r>
               <a:rPr lang="en-US" dirty="0"/>
-              <a:t>Show the split bar: random, stratified by WQI tier; no station or time hold-out. The tree configuration differs between the PDF report/viva guide (100 trees, depth 20; 300 rounds, lr 0.05, depth 8) and the repo technical report (30 trees, depth 14; 150 estimators, lr 0.08, depth 6, early stopping). Metrics are identical in both, so one description is wrong. Resolve before presenting configuration details.</a:t>
+              <a:t>Settings are from the executed training notebook and confirmed on the saved artifacts (the RF joblib has 30 trees, depth 14, min leaf 5, all 38 features per split; the XGBoost JSON has 150 trees). These replace the older report text (100 trees depth 20; 300 rounds). XGBoost early stopping used the validation set, so its validation score is slightly optimistic. Deep learning is planned for Phase 2: no neural-network code exists in this repo version.</a:t>
             </a:r>
             <a:endParaRPr lang="en-US" dirty="0"/>
           </a:p>
@@ -3617,7 +3607,7 @@
                 <a:ea typeface="Calibri" pitchFamily="34" charset="-122"/>
                 <a:cs typeface="Calibri" pitchFamily="34" charset="-120"/>
               </a:rPr>
-              <a:t>Estimating the CCME Water Quality Index with gradient-tree ensembles, aquatic-chemistry features and a dual-head neural network — and an honest audit of what the scores mean</a:t>
+              <a:t>Estimating the CCME Water Quality Index with gradient-tree ensembles and aquatic-chemistry features — plus an honest audit of what the scores mean</a:t>
             </a:r>
             <a:endParaRPr lang="en-US" sz="1800" dirty="0"/>
           </a:p>
@@ -3631,64 +3621,64 @@
         </p:nvSpPr>
         <p:spPr>
           <a:xfrm>
-            <a:off x="548640" y="5120640"/>
+            <a:off x="548640" y="4892040"/>
+            <a:ext cx="7315200" cy="640080"/>
+          </a:xfrm>
+          <a:prstGeom prst="rect">
+            <a:avLst/>
+          </a:prstGeom>
+          <a:noFill/>
+          <a:ln/>
+        </p:spPr>
+        <p:txBody>
+          <a:bodyPr wrap="square" lIns="0" tIns="0" rIns="0" bIns="0" rtlCol="0" anchor="t"/>
+          <a:lstStyle/>
+          <a:p>
+            <a:pPr indent="0" marL="0">
+              <a:buNone/>
+            </a:pPr>
+            <a:r>
+              <a:rPr lang="en-US" sz="1500" b="1" dirty="0">
+                <a:solidFill>
+                  <a:srgbClr val="FFFFFF"/>
+                </a:solidFill>
+                <a:latin typeface="Calibri" pitchFamily="34" charset="0"/>
+                <a:ea typeface="Calibri" pitchFamily="34" charset="-122"/>
+                <a:cs typeface="Calibri" pitchFamily="34" charset="-120"/>
+              </a:rPr>
+              <a:t>Mayank Sharma · Aman Soni · Aaryan Gera</a:t>
+            </a:r>
+            <a:endParaRPr lang="en-US" sz="1500" dirty="0"/>
+          </a:p>
+          <a:p>
+            <a:pPr indent="0" marL="0">
+              <a:buNone/>
+            </a:pPr>
+            <a:r>
+              <a:rPr lang="en-US" sz="1500" b="1" dirty="0">
+                <a:solidFill>
+                  <a:srgbClr val="FFFFFF"/>
+                </a:solidFill>
+                <a:latin typeface="Calibri" pitchFamily="34" charset="0"/>
+                <a:ea typeface="Calibri" pitchFamily="34" charset="-122"/>
+                <a:cs typeface="Calibri" pitchFamily="34" charset="-120"/>
+              </a:rPr>
+              <a:t>Chaitanya Kumar · Ankit Kumar Pandey · Pranav Sehgal</a:t>
+            </a:r>
+            <a:endParaRPr lang="en-US" sz="1500" dirty="0"/>
+          </a:p>
+        </p:txBody>
+      </p:sp>
+      <p:sp>
+        <p:nvSpPr>
+          <p:cNvPr id="9" name="Text 7"/>
+          <p:cNvSpPr txBox="1"/>
+          <p:nvPr/>
+        </p:nvSpPr>
+        <p:spPr>
+          <a:xfrm>
+            <a:off x="548640" y="5623560"/>
             <a:ext cx="7315200" cy="457200"/>
-          </a:xfrm>
-          <a:prstGeom prst="rect">
-            <a:avLst/>
-          </a:prstGeom>
-          <a:noFill/>
-          <a:ln/>
-        </p:spPr>
-        <p:txBody>
-          <a:bodyPr wrap="square" lIns="0" tIns="0" rIns="0" bIns="0" rtlCol="0" anchor="t"/>
-          <a:lstStyle/>
-          <a:p>
-            <a:pPr indent="0" marL="0">
-              <a:buNone/>
-            </a:pPr>
-            <a:r>
-              <a:rPr lang="en-US" sz="1500" b="1" dirty="0">
-                <a:solidFill>
-                  <a:srgbClr val="FFFFFF"/>
-                </a:solidFill>
-                <a:latin typeface="Calibri" pitchFamily="34" charset="0"/>
-                <a:ea typeface="Calibri" pitchFamily="34" charset="-122"/>
-                <a:cs typeface="Calibri" pitchFamily="34" charset="-120"/>
-              </a:rPr>
-              <a:t>Mayank Sharma · Aman Soni · Aaryan Gera</a:t>
-            </a:r>
-            <a:endParaRPr lang="en-US" sz="1500" dirty="0"/>
-          </a:p>
-          <a:p>
-            <a:pPr indent="0" marL="0">
-              <a:buNone/>
-            </a:pPr>
-            <a:r>
-              <a:rPr lang="en-US" sz="1500" b="1" dirty="0">
-                <a:solidFill>
-                  <a:srgbClr val="FFFFFF"/>
-                </a:solidFill>
-                <a:latin typeface="Calibri" pitchFamily="34" charset="0"/>
-                <a:ea typeface="Calibri" pitchFamily="34" charset="-122"/>
-                <a:cs typeface="Calibri" pitchFamily="34" charset="-120"/>
-              </a:rPr>
-              <a:t>Chaitanya Kumar · Ankit Kumar Pandey · Pranav</a:t>
-            </a:r>
-            <a:endParaRPr lang="en-US" sz="1500" dirty="0"/>
-          </a:p>
-        </p:txBody>
-      </p:sp>
-      <p:sp>
-        <p:nvSpPr>
-          <p:cNvPr id="9" name="Text 7"/>
-          <p:cNvSpPr txBox="1"/>
-          <p:nvPr/>
-        </p:nvSpPr>
-        <p:spPr>
-          <a:xfrm>
-            <a:off x="548640" y="5623560"/>
-            <a:ext cx="7315200" cy="502920"/>
           </a:xfrm>
           <a:prstGeom prst="rect">
             <a:avLst/>
@@ -3961,7 +3951,7 @@
                 <a:ea typeface="Cambria" pitchFamily="34" charset="-122"/>
                 <a:cs typeface="Cambria" pitchFamily="34" charset="-120"/>
               </a:rPr>
-              <a:t>Tree ensembles reproduce the index almost exactly; the MLP is close but less precise</a:t>
+              <a:t>Tree ensembles reproduce the index almost exactly on validation rows</a:t>
             </a:r>
             <a:endParaRPr lang="en-US" sz="3000" dirty="0"/>
           </a:p>
@@ -4061,17 +4051,17 @@
         </p:nvGraphicFramePr>
         <p:xfrm>
           <a:off x="548640" y="1783080"/>
-          <a:ext cx="5669280" cy="914400"/>
+          <a:ext cx="5852160" cy="914400"/>
         </p:xfrm>
         <a:graphic>
           <a:graphicData uri="http://schemas.openxmlformats.org/drawingml/2006/table">
             <a:tbl>
               <a:tblPr/>
               <a:tblGrid>
-                <a:gridCol w="2103120"/>
-                <a:gridCol w="1188720"/>
-                <a:gridCol w="1188720"/>
-                <a:gridCol w="1188720"/>
+                <a:gridCol w="2651760"/>
+                <a:gridCol w="1005840"/>
+                <a:gridCol w="1097280"/>
+                <a:gridCol w="1097280"/>
               </a:tblGrid>
               <a:tr h="457200">
                 <a:tc>
@@ -4083,7 +4073,7 @@
                         <a:buNone/>
                       </a:pPr>
                       <a:r>
-                        <a:rPr lang="en-US" sz="1500" b="1" dirty="0">
+                        <a:rPr lang="en-US" sz="1400" b="1" dirty="0">
                           <a:solidFill>
                             <a:srgbClr val="FFFFFF"/>
                           </a:solidFill>
@@ -4093,7 +4083,7 @@
                         </a:rPr>
                         <a:t>Model</a:t>
                       </a:r>
-                      <a:endParaRPr lang="en-US" sz="1500" dirty="0">
+                      <a:endParaRPr lang="en-US" sz="1400" dirty="0">
                         <a:latin typeface="Calibri" charset="0"/>
                         <a:ea typeface="Calibri" charset="0"/>
                         <a:cs typeface="Calibri" charset="0"/>
@@ -4151,7 +4141,7 @@
                         <a:buNone/>
                       </a:pPr>
                       <a:r>
-                        <a:rPr lang="en-US" sz="1500" b="1" dirty="0">
+                        <a:rPr lang="en-US" sz="1400" b="1" dirty="0">
                           <a:solidFill>
                             <a:srgbClr val="FFFFFF"/>
                           </a:solidFill>
@@ -4161,7 +4151,7 @@
                         </a:rPr>
                         <a:t>MAE</a:t>
                       </a:r>
-                      <a:endParaRPr lang="en-US" sz="1500" dirty="0">
+                      <a:endParaRPr lang="en-US" sz="1400" dirty="0">
                         <a:latin typeface="Calibri" charset="0"/>
                         <a:ea typeface="Calibri" charset="0"/>
                         <a:cs typeface="Calibri" charset="0"/>
@@ -4219,7 +4209,7 @@
                         <a:buNone/>
                       </a:pPr>
                       <a:r>
-                        <a:rPr lang="en-US" sz="1500" b="1" dirty="0">
+                        <a:rPr lang="en-US" sz="1400" b="1" dirty="0">
                           <a:solidFill>
                             <a:srgbClr val="FFFFFF"/>
                           </a:solidFill>
@@ -4229,7 +4219,7 @@
                         </a:rPr>
                         <a:t>RMSE</a:t>
                       </a:r>
-                      <a:endParaRPr lang="en-US" sz="1500" dirty="0">
+                      <a:endParaRPr lang="en-US" sz="1400" dirty="0">
                         <a:latin typeface="Calibri" charset="0"/>
                         <a:ea typeface="Calibri" charset="0"/>
                         <a:cs typeface="Calibri" charset="0"/>
@@ -4287,7 +4277,7 @@
                         <a:buNone/>
                       </a:pPr>
                       <a:r>
-                        <a:rPr lang="en-US" sz="1500" b="1" dirty="0">
+                        <a:rPr lang="en-US" sz="1400" b="1" dirty="0">
                           <a:solidFill>
                             <a:srgbClr val="FFFFFF"/>
                           </a:solidFill>
@@ -4297,7 +4287,7 @@
                         </a:rPr>
                         <a:t>R²</a:t>
                       </a:r>
-                      <a:endParaRPr lang="en-US" sz="1500" dirty="0">
+                      <a:endParaRPr lang="en-US" sz="1400" dirty="0">
                         <a:latin typeface="Calibri" charset="0"/>
                         <a:ea typeface="Calibri" charset="0"/>
                         <a:cs typeface="Calibri" charset="0"/>
@@ -4357,7 +4347,7 @@
                         <a:buNone/>
                       </a:pPr>
                       <a:r>
-                        <a:rPr lang="en-US" sz="1500" dirty="0">
+                        <a:rPr lang="en-US" sz="1400" dirty="0">
                           <a:solidFill>
                             <a:srgbClr val="12202E"/>
                           </a:solidFill>
@@ -4367,7 +4357,7 @@
                         </a:rPr>
                         <a:t>Mean baseline</a:t>
                       </a:r>
-                      <a:endParaRPr lang="en-US" sz="1500" dirty="0">
+                      <a:endParaRPr lang="en-US" sz="1400" dirty="0">
                         <a:latin typeface="Calibri" charset="0"/>
                         <a:ea typeface="Calibri" charset="0"/>
                         <a:cs typeface="Calibri" charset="0"/>
@@ -4425,7 +4415,7 @@
                         <a:buNone/>
                       </a:pPr>
                       <a:r>
-                        <a:rPr lang="en-US" sz="1500" dirty="0">
+                        <a:rPr lang="en-US" sz="1400" dirty="0">
                           <a:solidFill>
                             <a:srgbClr val="12202E"/>
                           </a:solidFill>
@@ -4435,7 +4425,7 @@
                         </a:rPr>
                         <a:t>14.130</a:t>
                       </a:r>
-                      <a:endParaRPr lang="en-US" sz="1500" dirty="0">
+                      <a:endParaRPr lang="en-US" sz="1400" dirty="0">
                         <a:latin typeface="Calibri" charset="0"/>
                         <a:ea typeface="Calibri" charset="0"/>
                         <a:cs typeface="Calibri" charset="0"/>
@@ -4493,7 +4483,7 @@
                         <a:buNone/>
                       </a:pPr>
                       <a:r>
-                        <a:rPr lang="en-US" sz="1500" dirty="0">
+                        <a:rPr lang="en-US" sz="1400" dirty="0">
                           <a:solidFill>
                             <a:srgbClr val="12202E"/>
                           </a:solidFill>
@@ -4503,7 +4493,7 @@
                         </a:rPr>
                         <a:t>17.656</a:t>
                       </a:r>
-                      <a:endParaRPr lang="en-US" sz="1500" dirty="0">
+                      <a:endParaRPr lang="en-US" sz="1400" dirty="0">
                         <a:latin typeface="Calibri" charset="0"/>
                         <a:ea typeface="Calibri" charset="0"/>
                         <a:cs typeface="Calibri" charset="0"/>
@@ -4561,7 +4551,7 @@
                         <a:buNone/>
                       </a:pPr>
                       <a:r>
-                        <a:rPr lang="en-US" sz="1500" dirty="0">
+                        <a:rPr lang="en-US" sz="1400" dirty="0">
                           <a:solidFill>
                             <a:srgbClr val="12202E"/>
                           </a:solidFill>
@@ -4571,7 +4561,7 @@
                         </a:rPr>
                         <a:t>0.0000</a:t>
                       </a:r>
-                      <a:endParaRPr lang="en-US" sz="1500" dirty="0">
+                      <a:endParaRPr lang="en-US" sz="1400" dirty="0">
                         <a:latin typeface="Calibri" charset="0"/>
                         <a:ea typeface="Calibri" charset="0"/>
                         <a:cs typeface="Calibri" charset="0"/>
@@ -4631,7 +4621,7 @@
                         <a:buNone/>
                       </a:pPr>
                       <a:r>
-                        <a:rPr lang="en-US" sz="1500" b="1" dirty="0">
+                        <a:rPr lang="en-US" sz="1400" b="1" dirty="0">
                           <a:solidFill>
                             <a:srgbClr val="12202E"/>
                           </a:solidFill>
@@ -4641,7 +4631,7 @@
                         </a:rPr>
                         <a:t>Random Forest</a:t>
                       </a:r>
-                      <a:endParaRPr lang="en-US" sz="1500" dirty="0">
+                      <a:endParaRPr lang="en-US" sz="1400" dirty="0">
                         <a:latin typeface="Calibri" charset="0"/>
                         <a:ea typeface="Calibri" charset="0"/>
                         <a:cs typeface="Calibri" charset="0"/>
@@ -4699,7 +4689,7 @@
                         <a:buNone/>
                       </a:pPr>
                       <a:r>
-                        <a:rPr lang="en-US" sz="1500" b="1" dirty="0">
+                        <a:rPr lang="en-US" sz="1400" b="1" dirty="0">
                           <a:solidFill>
                             <a:srgbClr val="12202E"/>
                           </a:solidFill>
@@ -4709,7 +4699,7 @@
                         </a:rPr>
                         <a:t>0.052</a:t>
                       </a:r>
-                      <a:endParaRPr lang="en-US" sz="1500" dirty="0">
+                      <a:endParaRPr lang="en-US" sz="1400" dirty="0">
                         <a:latin typeface="Calibri" charset="0"/>
                         <a:ea typeface="Calibri" charset="0"/>
                         <a:cs typeface="Calibri" charset="0"/>
@@ -4767,7 +4757,7 @@
                         <a:buNone/>
                       </a:pPr>
                       <a:r>
-                        <a:rPr lang="en-US" sz="1500" b="1" dirty="0">
+                        <a:rPr lang="en-US" sz="1400" b="1" dirty="0">
                           <a:solidFill>
                             <a:srgbClr val="12202E"/>
                           </a:solidFill>
@@ -4777,7 +4767,7 @@
                         </a:rPr>
                         <a:t>0.208</a:t>
                       </a:r>
-                      <a:endParaRPr lang="en-US" sz="1500" dirty="0">
+                      <a:endParaRPr lang="en-US" sz="1400" dirty="0">
                         <a:latin typeface="Calibri" charset="0"/>
                         <a:ea typeface="Calibri" charset="0"/>
                         <a:cs typeface="Calibri" charset="0"/>
@@ -4835,7 +4825,7 @@
                         <a:buNone/>
                       </a:pPr>
                       <a:r>
-                        <a:rPr lang="en-US" sz="1500" b="1" dirty="0">
+                        <a:rPr lang="en-US" sz="1400" b="1" dirty="0">
                           <a:solidFill>
                             <a:srgbClr val="12202E"/>
                           </a:solidFill>
@@ -4845,7 +4835,7 @@
                         </a:rPr>
                         <a:t>0.9999</a:t>
                       </a:r>
-                      <a:endParaRPr lang="en-US" sz="1500" dirty="0">
+                      <a:endParaRPr lang="en-US" sz="1400" dirty="0">
                         <a:latin typeface="Calibri" charset="0"/>
                         <a:ea typeface="Calibri" charset="0"/>
                         <a:cs typeface="Calibri" charset="0"/>
@@ -4905,7 +4895,7 @@
                         <a:buNone/>
                       </a:pPr>
                       <a:r>
-                        <a:rPr lang="en-US" sz="1500" dirty="0">
+                        <a:rPr lang="en-US" sz="1400" dirty="0">
                           <a:solidFill>
                             <a:srgbClr val="12202E"/>
                           </a:solidFill>
@@ -4913,9 +4903,9 @@
                           <a:ea typeface="Calibri" pitchFamily="34" charset="-122"/>
                           <a:cs typeface="Calibri" pitchFamily="34" charset="-120"/>
                         </a:rPr>
-                        <a:t>XGBoost</a:t>
+                        <a:t>XGBoost (comparison file)</a:t>
                       </a:r>
-                      <a:endParaRPr lang="en-US" sz="1500" dirty="0">
+                      <a:endParaRPr lang="en-US" sz="1400" dirty="0">
                         <a:latin typeface="Calibri" charset="0"/>
                         <a:ea typeface="Calibri" charset="0"/>
                         <a:cs typeface="Calibri" charset="0"/>
@@ -4973,7 +4963,7 @@
                         <a:buNone/>
                       </a:pPr>
                       <a:r>
-                        <a:rPr lang="en-US" sz="1500" dirty="0">
+                        <a:rPr lang="en-US" sz="1400" dirty="0">
                           <a:solidFill>
                             <a:srgbClr val="12202E"/>
                           </a:solidFill>
@@ -4983,7 +4973,7 @@
                         </a:rPr>
                         <a:t>0.137</a:t>
                       </a:r>
-                      <a:endParaRPr lang="en-US" sz="1500" dirty="0">
+                      <a:endParaRPr lang="en-US" sz="1400" dirty="0">
                         <a:latin typeface="Calibri" charset="0"/>
                         <a:ea typeface="Calibri" charset="0"/>
                         <a:cs typeface="Calibri" charset="0"/>
@@ -5041,7 +5031,7 @@
                         <a:buNone/>
                       </a:pPr>
                       <a:r>
-                        <a:rPr lang="en-US" sz="1500" dirty="0">
+                        <a:rPr lang="en-US" sz="1400" dirty="0">
                           <a:solidFill>
                             <a:srgbClr val="12202E"/>
                           </a:solidFill>
@@ -5051,7 +5041,7 @@
                         </a:rPr>
                         <a:t>0.374</a:t>
                       </a:r>
-                      <a:endParaRPr lang="en-US" sz="1500" dirty="0">
+                      <a:endParaRPr lang="en-US" sz="1400" dirty="0">
                         <a:latin typeface="Calibri" charset="0"/>
                         <a:ea typeface="Calibri" charset="0"/>
                         <a:cs typeface="Calibri" charset="0"/>
@@ -5109,7 +5099,7 @@
                         <a:buNone/>
                       </a:pPr>
                       <a:r>
-                        <a:rPr lang="en-US" sz="1500" dirty="0">
+                        <a:rPr lang="en-US" sz="1400" dirty="0">
                           <a:solidFill>
                             <a:srgbClr val="12202E"/>
                           </a:solidFill>
@@ -5119,7 +5109,7 @@
                         </a:rPr>
                         <a:t>0.9996</a:t>
                       </a:r>
-                      <a:endParaRPr lang="en-US" sz="1500" dirty="0">
+                      <a:endParaRPr lang="en-US" sz="1400" dirty="0">
                         <a:latin typeface="Calibri" charset="0"/>
                         <a:ea typeface="Calibri" charset="0"/>
                         <a:cs typeface="Calibri" charset="0"/>
@@ -5179,7 +5169,7 @@
                         <a:buNone/>
                       </a:pPr>
                       <a:r>
-                        <a:rPr lang="en-US" sz="1500" dirty="0">
+                        <a:rPr lang="en-US" sz="1400" dirty="0">
                           <a:solidFill>
                             <a:srgbClr val="12202E"/>
                           </a:solidFill>
@@ -5187,9 +5177,9 @@
                           <a:ea typeface="Calibri" pitchFamily="34" charset="-122"/>
                           <a:cs typeface="Calibri" pitchFamily="34" charset="-120"/>
                         </a:rPr>
-                        <a:t>Dual-head MLP</a:t>
+                        <a:t>XGBoost (saved model run)†</a:t>
                       </a:r>
-                      <a:endParaRPr lang="en-US" sz="1500" dirty="0">
+                      <a:endParaRPr lang="en-US" sz="1400" dirty="0">
                         <a:latin typeface="Calibri" charset="0"/>
                         <a:ea typeface="Calibri" charset="0"/>
                         <a:cs typeface="Calibri" charset="0"/>
@@ -5247,7 +5237,7 @@
                         <a:buNone/>
                       </a:pPr>
                       <a:r>
-                        <a:rPr lang="en-US" sz="1500" dirty="0">
+                        <a:rPr lang="en-US" sz="1400" dirty="0">
                           <a:solidFill>
                             <a:srgbClr val="12202E"/>
                           </a:solidFill>
@@ -5255,9 +5245,9 @@
                           <a:ea typeface="Calibri" pitchFamily="34" charset="-122"/>
                           <a:cs typeface="Calibri" pitchFamily="34" charset="-120"/>
                         </a:rPr>
-                        <a:t>0.706</a:t>
+                        <a:t>0.161</a:t>
                       </a:r>
-                      <a:endParaRPr lang="en-US" sz="1500" dirty="0">
+                      <a:endParaRPr lang="en-US" sz="1400" dirty="0">
                         <a:latin typeface="Calibri" charset="0"/>
                         <a:ea typeface="Calibri" charset="0"/>
                         <a:cs typeface="Calibri" charset="0"/>
@@ -5315,7 +5305,7 @@
                         <a:buNone/>
                       </a:pPr>
                       <a:r>
-                        <a:rPr lang="en-US" sz="1500" dirty="0">
+                        <a:rPr lang="en-US" sz="1400" dirty="0">
                           <a:solidFill>
                             <a:srgbClr val="12202E"/>
                           </a:solidFill>
@@ -5323,9 +5313,9 @@
                           <a:ea typeface="Calibri" pitchFamily="34" charset="-122"/>
                           <a:cs typeface="Calibri" pitchFamily="34" charset="-120"/>
                         </a:rPr>
-                        <a:t>1.156</a:t>
+                        <a:t>0.437</a:t>
                       </a:r>
-                      <a:endParaRPr lang="en-US" sz="1500" dirty="0">
+                      <a:endParaRPr lang="en-US" sz="1400" dirty="0">
                         <a:latin typeface="Calibri" charset="0"/>
                         <a:ea typeface="Calibri" charset="0"/>
                         <a:cs typeface="Calibri" charset="0"/>
@@ -5383,7 +5373,7 @@
                         <a:buNone/>
                       </a:pPr>
                       <a:r>
-                        <a:rPr lang="en-US" sz="1500" dirty="0">
+                        <a:rPr lang="en-US" sz="1400" dirty="0">
                           <a:solidFill>
                             <a:srgbClr val="12202E"/>
                           </a:solidFill>
@@ -5391,9 +5381,9 @@
                           <a:ea typeface="Calibri" pitchFamily="34" charset="-122"/>
                           <a:cs typeface="Calibri" pitchFamily="34" charset="-120"/>
                         </a:rPr>
-                        <a:t>0.9957</a:t>
+                        <a:t>0.9994</a:t>
                       </a:r>
-                      <a:endParaRPr lang="en-US" sz="1500" dirty="0">
+                      <a:endParaRPr lang="en-US" sz="1400" dirty="0">
                         <a:latin typeface="Calibri" charset="0"/>
                         <a:ea typeface="Calibri" charset="0"/>
                         <a:cs typeface="Calibri" charset="0"/>
@@ -5455,8 +5445,8 @@
         </p:nvSpPr>
         <p:spPr>
           <a:xfrm>
-            <a:off x="548640" y="4251960"/>
-            <a:ext cx="5669280" cy="640080"/>
+            <a:off x="548640" y="4206240"/>
+            <a:ext cx="5852160" cy="822960"/>
           </a:xfrm>
           <a:prstGeom prst="rect">
             <a:avLst/>
@@ -5472,7 +5462,7 @@
               <a:buNone/>
             </a:pPr>
             <a:r>
-              <a:rPr lang="en-US" sz="1300" dirty="0">
+              <a:rPr lang="en-US" sz="1200" dirty="0">
                 <a:solidFill>
                   <a:srgbClr val="5B6B7A"/>
                 </a:solidFill>
@@ -5480,9 +5470,9 @@
                 <a:ea typeface="Calibri" pitchFamily="34" charset="-122"/>
                 <a:cs typeface="Calibri" pitchFamily="34" charset="-120"/>
               </a:rPr>
-              <a:t>MLP also classifies the 5 tiers: accuracy 96.09%, macro-F1 0.9485, Brier 0.0533, ECE 1.27% (validation).</a:t>
-            </a:r>
-            <a:endParaRPr lang="en-US" sz="1300" dirty="0"/>
+              <a:t>† Training notebook and the saved XGBoost model’s recorded validation RMSE (0.4372). The saved predictions file behind the comparison table disagrees; provenance unresolved. All values: validation set, 422,943 rows.</a:t>
+            </a:r>
+            <a:endParaRPr lang="en-US" sz="1200" dirty="0"/>
           </a:p>
         </p:txBody>
       </p:sp>
@@ -5493,8 +5483,8 @@
           <p:nvPr/>
         </p:nvGraphicFramePr>
         <p:xfrm>
-          <a:off x="6583680" y="1691640"/>
-          <a:ext cx="5056632" cy="3200400"/>
+          <a:off x="6675120" y="1691640"/>
+          <a:ext cx="4965192" cy="3291840"/>
         </p:xfrm>
         <a:graphic xmlns:a="http://schemas.openxmlformats.org/drawingml/2006/main">
           <a:graphicData uri="http://schemas.openxmlformats.org/drawingml/2006/chart">
@@ -5510,7 +5500,7 @@
         </p:nvSpPr>
         <p:spPr>
           <a:xfrm>
-            <a:off x="548640" y="5166360"/>
+            <a:off x="548640" y="5212080"/>
             <a:ext cx="11091672" cy="868680"/>
           </a:xfrm>
           <a:prstGeom prst="rect">
@@ -5535,7 +5525,7 @@
         </p:nvSpPr>
         <p:spPr>
           <a:xfrm>
-            <a:off x="777240" y="5166360"/>
+            <a:off x="777240" y="5212080"/>
             <a:ext cx="10698480" cy="868680"/>
           </a:xfrm>
           <a:prstGeom prst="rect">
@@ -5574,7 +5564,7 @@
                 <a:ea typeface="Calibri" pitchFamily="34" charset="-122"/>
                 <a:cs typeface="Calibri" pitchFamily="34" charset="-120"/>
               </a:rPr>
-              <a:t>These scores measure how well each model re-computes a deterministic formula on randomly held-out rows. They are not evidence of independent forecasting skill (slide 11). Latency claims omitted: provenance unverified.</a:t>
+              <a:t>These scores measure how well each model reconstructs the CCME index from same-time measurements on randomly held-out rows (the repo’s own notebook says so). They do not show forecasting skill. Latency omitted: not measured in the repo.</a:t>
             </a:r>
             <a:endParaRPr lang="en-US" sz="1300" dirty="0"/>
           </a:p>
@@ -5684,7 +5674,7 @@
                 <a:ea typeface="Cambria" pitchFamily="34" charset="-122"/>
                 <a:cs typeface="Cambria" pitchFamily="34" charset="-120"/>
               </a:rPr>
-              <a:t>Why R² ≈ 0.9999 needs careful reading: three open audit findings</a:t>
+              <a:t>Why R² ≈ 0.9999 needs careful reading: what the code shows</a:t>
             </a:r>
             <a:endParaRPr lang="en-US" sz="3000" dirty="0"/>
           </a:p>
@@ -5802,7 +5792,7 @@
         <p:spPr>
           <a:xfrm>
             <a:off x="731520" y="1847088"/>
-            <a:ext cx="3291840" cy="365760"/>
+            <a:ext cx="3291840" cy="640080"/>
           </a:xfrm>
           <a:prstGeom prst="rect">
             <a:avLst/>
@@ -5818,7 +5808,7 @@
               <a:buNone/>
             </a:pPr>
             <a:r>
-              <a:rPr lang="en-US" sz="1700" b="1" dirty="0">
+              <a:rPr lang="en-US" sz="1600" b="1" dirty="0">
                 <a:solidFill>
                   <a:srgbClr val="0E7C86"/>
                 </a:solidFill>
@@ -5826,9 +5816,9 @@
                 <a:ea typeface="Cambria" pitchFamily="34" charset="-122"/>
                 <a:cs typeface="Cambria" pitchFamily="34" charset="-120"/>
               </a:rPr>
-              <a:t>1  Deterministic target</a:t>
-            </a:r>
-            <a:endParaRPr lang="en-US" sz="1700" dirty="0"/>
+              <a:t>1  Target is a formula of the inputs</a:t>
+            </a:r>
+            <a:endParaRPr lang="en-US" sz="1600" dirty="0"/>
           </a:p>
         </p:txBody>
       </p:sp>
@@ -5840,8 +5830,8 @@
         </p:nvSpPr>
         <p:spPr>
           <a:xfrm>
-            <a:off x="731520" y="2286000"/>
-            <a:ext cx="3291840" cy="2011680"/>
+            <a:off x="731520" y="2514600"/>
+            <a:ext cx="3291840" cy="1783080"/>
           </a:xfrm>
           <a:prstGeom prst="rect">
             <a:avLst/>
@@ -5865,7 +5855,7 @@
                 <a:ea typeface="Calibri" pitchFamily="34" charset="-122"/>
                 <a:cs typeface="Calibri" pitchFamily="34" charset="-120"/>
               </a:rPr>
-              <a:t>The index is computed from the same eight measurements used as inputs, against fixed guideline limits. The team’s viva guide calls it an “exact deterministic mathematical aggregation”. High R² = the model learned the formula.</a:t>
+              <a:t>CCME_Values ships with the data and is a composite of the same eight measurements. High R² means the model learned the formula. The repo’s evaluation notebook says exactly this.</a:t>
             </a:r>
             <a:endParaRPr lang="en-US" sz="1300" dirty="0"/>
           </a:p>
@@ -5904,7 +5894,7 @@
                 <a:ea typeface="Calibri" pitchFamily="34" charset="-122"/>
                 <a:cs typeface="Calibri" pitchFamily="34" charset="-120"/>
               </a:rPr>
-              <a:t>Confirmed from docs</a:t>
+              <a:t>Confirmed in repo</a:t>
             </a:r>
             <a:endParaRPr lang="en-US" sz="1200" dirty="0"/>
           </a:p>
@@ -5920,6 +5910,371 @@
           <a:xfrm>
             <a:off x="4297680" y="1737360"/>
             <a:ext cx="3611880" cy="3063240"/>
+          </a:xfrm>
+          <a:prstGeom prst="rect">
+            <a:avLst/>
+          </a:prstGeom>
+          <a:solidFill>
+            <a:srgbClr val="EAF4F6"/>
+          </a:solidFill>
+          <a:ln w="12700">
+            <a:solidFill>
+              <a:srgbClr val="EAF4F6"/>
+            </a:solidFill>
+            <a:prstDash val="solid"/>
+          </a:ln>
+        </p:spPr>
+      </p:sp>
+      <p:sp>
+        <p:nvSpPr>
+          <p:cNvPr id="12" name="Text 9"/>
+          <p:cNvSpPr txBox="1"/>
+          <p:nvPr/>
+        </p:nvSpPr>
+        <p:spPr>
+          <a:xfrm>
+            <a:off x="4480560" y="1847088"/>
+            <a:ext cx="3291840" cy="640080"/>
+          </a:xfrm>
+          <a:prstGeom prst="rect">
+            <a:avLst/>
+          </a:prstGeom>
+          <a:noFill/>
+          <a:ln/>
+        </p:spPr>
+        <p:txBody>
+          <a:bodyPr wrap="square" lIns="0" tIns="0" rIns="0" bIns="0" rtlCol="0" anchor="t"/>
+          <a:lstStyle/>
+          <a:p>
+            <a:pPr indent="0" marL="0">
+              <a:buNone/>
+            </a:pPr>
+            <a:r>
+              <a:rPr lang="en-US" sz="1600" b="1" dirty="0">
+                <a:solidFill>
+                  <a:srgbClr val="0E7C86"/>
+                </a:solidFill>
+                <a:latin typeface="Cambria" pitchFamily="34" charset="0"/>
+                <a:ea typeface="Cambria" pitchFamily="34" charset="-122"/>
+                <a:cs typeface="Cambria" pitchFamily="34" charset="-120"/>
+              </a:rPr>
+              <a:t>2  exceedance_counter re-checked</a:t>
+            </a:r>
+            <a:endParaRPr lang="en-US" sz="1600" dirty="0"/>
+          </a:p>
+        </p:txBody>
+      </p:sp>
+      <p:sp>
+        <p:nvSpPr>
+          <p:cNvPr id="13" name="Text 10"/>
+          <p:cNvSpPr txBox="1"/>
+          <p:nvPr/>
+        </p:nvSpPr>
+        <p:spPr>
+          <a:xfrm>
+            <a:off x="4480560" y="2514600"/>
+            <a:ext cx="3291840" cy="1783080"/>
+          </a:xfrm>
+          <a:prstGeom prst="rect">
+            <a:avLst/>
+          </a:prstGeom>
+          <a:noFill/>
+          <a:ln/>
+        </p:spPr>
+        <p:txBody>
+          <a:bodyPr wrap="square" lIns="0" tIns="0" rIns="0" bIns="0" rtlCol="0" anchor="t"/>
+          <a:lstStyle/>
+          <a:p>
+            <a:pPr indent="0" marL="0">
+              <a:buNone/>
+            </a:pPr>
+            <a:r>
+              <a:rPr lang="en-US" sz="1300" dirty="0">
+                <a:solidFill>
+                  <a:srgbClr val="12202E"/>
+                </a:solidFill>
+                <a:latin typeface="Calibri" pitchFamily="34" charset="0"/>
+                <a:ea typeface="Calibri" pitchFamily="34" charset="-122"/>
+                <a:cs typeface="Calibri" pitchFamily="34" charset="-120"/>
+              </a:rPr>
+              <a:t>Built only from six input columns with its own thresholds; not a target column, not F₁–F₃ (not in the data). Legitimate but redundant. Ablation not yet run.</a:t>
+            </a:r>
+            <a:endParaRPr lang="en-US" sz="1300" dirty="0"/>
+          </a:p>
+        </p:txBody>
+      </p:sp>
+      <p:sp>
+        <p:nvSpPr>
+          <p:cNvPr id="14" name="Text 11"/>
+          <p:cNvSpPr txBox="1"/>
+          <p:nvPr/>
+        </p:nvSpPr>
+        <p:spPr>
+          <a:xfrm>
+            <a:off x="4480560" y="4389120"/>
+            <a:ext cx="3291840" cy="274320"/>
+          </a:xfrm>
+          <a:prstGeom prst="rect">
+            <a:avLst/>
+          </a:prstGeom>
+          <a:noFill/>
+          <a:ln/>
+        </p:spPr>
+        <p:txBody>
+          <a:bodyPr wrap="square" lIns="0" tIns="0" rIns="0" bIns="0" rtlCol="0" anchor="t"/>
+          <a:lstStyle/>
+          <a:p>
+            <a:pPr indent="0" marL="0">
+              <a:buNone/>
+            </a:pPr>
+            <a:r>
+              <a:rPr lang="en-US" sz="1200" b="1" dirty="0">
+                <a:solidFill>
+                  <a:srgbClr val="5B6B7A"/>
+                </a:solidFill>
+                <a:latin typeface="Calibri" pitchFamily="34" charset="0"/>
+                <a:ea typeface="Calibri" pitchFamily="34" charset="-122"/>
+                <a:cs typeface="Calibri" pitchFamily="34" charset="-120"/>
+              </a:rPr>
+              <a:t>Re-assessed: no data-flow leak</a:t>
+            </a:r>
+            <a:endParaRPr lang="en-US" sz="1200" dirty="0"/>
+          </a:p>
+        </p:txBody>
+      </p:sp>
+      <p:sp>
+        <p:nvSpPr>
+          <p:cNvPr id="15" name="Shape 12"/>
+          <p:cNvSpPr/>
+          <p:nvPr/>
+        </p:nvSpPr>
+        <p:spPr>
+          <a:xfrm>
+            <a:off x="8046720" y="1737360"/>
+            <a:ext cx="3611880" cy="3063240"/>
+          </a:xfrm>
+          <a:prstGeom prst="rect">
+            <a:avLst/>
+          </a:prstGeom>
+          <a:solidFill>
+            <a:srgbClr val="F4F8FA"/>
+          </a:solidFill>
+          <a:ln w="12700">
+            <a:solidFill>
+              <a:srgbClr val="F4F8FA"/>
+            </a:solidFill>
+            <a:prstDash val="solid"/>
+          </a:ln>
+        </p:spPr>
+      </p:sp>
+      <p:sp>
+        <p:nvSpPr>
+          <p:cNvPr id="16" name="Text 13"/>
+          <p:cNvSpPr txBox="1"/>
+          <p:nvPr/>
+        </p:nvSpPr>
+        <p:spPr>
+          <a:xfrm>
+            <a:off x="8229600" y="1847088"/>
+            <a:ext cx="3291840" cy="640080"/>
+          </a:xfrm>
+          <a:prstGeom prst="rect">
+            <a:avLst/>
+          </a:prstGeom>
+          <a:noFill/>
+          <a:ln/>
+        </p:spPr>
+        <p:txBody>
+          <a:bodyPr wrap="square" lIns="0" tIns="0" rIns="0" bIns="0" rtlCol="0" anchor="t"/>
+          <a:lstStyle/>
+          <a:p>
+            <a:pPr indent="0" marL="0">
+              <a:buNone/>
+            </a:pPr>
+            <a:r>
+              <a:rPr lang="en-US" sz="1600" b="1" dirty="0">
+                <a:solidFill>
+                  <a:srgbClr val="0E7C86"/>
+                </a:solidFill>
+                <a:latin typeface="Cambria" pitchFamily="34" charset="0"/>
+                <a:ea typeface="Cambria" pitchFamily="34" charset="-122"/>
+                <a:cs typeface="Cambria" pitchFamily="34" charset="-120"/>
+              </a:rPr>
+              <a:t>3  Random split, early stopping</a:t>
+            </a:r>
+            <a:endParaRPr lang="en-US" sz="1600" dirty="0"/>
+          </a:p>
+        </p:txBody>
+      </p:sp>
+      <p:sp>
+        <p:nvSpPr>
+          <p:cNvPr id="17" name="Text 14"/>
+          <p:cNvSpPr txBox="1"/>
+          <p:nvPr/>
+        </p:nvSpPr>
+        <p:spPr>
+          <a:xfrm>
+            <a:off x="8229600" y="2514600"/>
+            <a:ext cx="3291840" cy="1783080"/>
+          </a:xfrm>
+          <a:prstGeom prst="rect">
+            <a:avLst/>
+          </a:prstGeom>
+          <a:noFill/>
+          <a:ln/>
+        </p:spPr>
+        <p:txBody>
+          <a:bodyPr wrap="square" lIns="0" tIns="0" rIns="0" bIns="0" rtlCol="0" anchor="t"/>
+          <a:lstStyle/>
+          <a:p>
+            <a:pPr indent="0" marL="0">
+              <a:buNone/>
+            </a:pPr>
+            <a:r>
+              <a:rPr lang="en-US" sz="1300" dirty="0">
+                <a:solidFill>
+                  <a:srgbClr val="12202E"/>
+                </a:solidFill>
+                <a:latin typeface="Calibri" pitchFamily="34" charset="0"/>
+                <a:ea typeface="Calibri" pitchFamily="34" charset="-122"/>
+                <a:cs typeface="Calibri" pitchFamily="34" charset="-120"/>
+              </a:rPr>
+              <a:t>Stratified random split; per-Area lags built on full data, so neighbours cross partitions; XGBoost stops on validation; test set unscored.</a:t>
+            </a:r>
+            <a:endParaRPr lang="en-US" sz="1300" dirty="0"/>
+          </a:p>
+        </p:txBody>
+      </p:sp>
+      <p:sp>
+        <p:nvSpPr>
+          <p:cNvPr id="18" name="Text 15"/>
+          <p:cNvSpPr txBox="1"/>
+          <p:nvPr/>
+        </p:nvSpPr>
+        <p:spPr>
+          <a:xfrm>
+            <a:off x="8229600" y="4389120"/>
+            <a:ext cx="3291840" cy="274320"/>
+          </a:xfrm>
+          <a:prstGeom prst="rect">
+            <a:avLst/>
+          </a:prstGeom>
+          <a:noFill/>
+          <a:ln/>
+        </p:spPr>
+        <p:txBody>
+          <a:bodyPr wrap="square" lIns="0" tIns="0" rIns="0" bIns="0" rtlCol="0" anchor="t"/>
+          <a:lstStyle/>
+          <a:p>
+            <a:pPr indent="0" marL="0">
+              <a:buNone/>
+            </a:pPr>
+            <a:r>
+              <a:rPr lang="en-US" sz="1200" b="1" dirty="0">
+                <a:solidFill>
+                  <a:srgbClr val="5B6B7A"/>
+                </a:solidFill>
+                <a:latin typeface="Calibri" pitchFamily="34" charset="0"/>
+                <a:ea typeface="Calibri" pitchFamily="34" charset="-122"/>
+                <a:cs typeface="Calibri" pitchFamily="34" charset="-120"/>
+              </a:rPr>
+              <a:t>Confirmed in code</a:t>
+            </a:r>
+            <a:endParaRPr lang="en-US" sz="1200" dirty="0"/>
+          </a:p>
+        </p:txBody>
+      </p:sp>
+      <p:sp>
+        <p:nvSpPr>
+          <p:cNvPr id="19" name="Shape 16"/>
+          <p:cNvSpPr/>
+          <p:nvPr/>
+        </p:nvSpPr>
+        <p:spPr>
+          <a:xfrm>
+            <a:off x="548640" y="4983480"/>
+            <a:ext cx="5440680" cy="1234440"/>
+          </a:xfrm>
+          <a:prstGeom prst="rect">
+            <a:avLst/>
+          </a:prstGeom>
+          <a:solidFill>
+            <a:srgbClr val="EAF4F6"/>
+          </a:solidFill>
+          <a:ln w="12700">
+            <a:solidFill>
+              <a:srgbClr val="EAF4F6"/>
+            </a:solidFill>
+            <a:prstDash val="solid"/>
+          </a:ln>
+        </p:spPr>
+      </p:sp>
+      <p:sp>
+        <p:nvSpPr>
+          <p:cNvPr id="20" name="Text 17"/>
+          <p:cNvSpPr txBox="1"/>
+          <p:nvPr/>
+        </p:nvSpPr>
+        <p:spPr>
+          <a:xfrm>
+            <a:off x="731520" y="5074920"/>
+            <a:ext cx="5120640" cy="1097280"/>
+          </a:xfrm>
+          <a:prstGeom prst="rect">
+            <a:avLst/>
+          </a:prstGeom>
+          <a:noFill/>
+          <a:ln/>
+        </p:spPr>
+        <p:txBody>
+          <a:bodyPr wrap="square" lIns="0" tIns="0" rIns="0" bIns="0" rtlCol="0" anchor="t"/>
+          <a:lstStyle/>
+          <a:p>
+            <a:pPr indent="0" marL="0">
+              <a:buNone/>
+            </a:pPr>
+            <a:r>
+              <a:rPr lang="en-US" sz="1300" b="1" dirty="0">
+                <a:solidFill>
+                  <a:srgbClr val="0E7C86"/>
+                </a:solidFill>
+                <a:latin typeface="Calibri" pitchFamily="34" charset="0"/>
+                <a:ea typeface="Calibri" pitchFamily="34" charset="-122"/>
+                <a:cs typeface="Calibri" pitchFamily="34" charset="-120"/>
+              </a:rPr>
+              <a:t>Can claim</a:t>
+            </a:r>
+            <a:endParaRPr lang="en-US" sz="1300" dirty="0"/>
+          </a:p>
+          <a:p>
+            <a:pPr indent="0" marL="0">
+              <a:buNone/>
+            </a:pPr>
+            <a:r>
+              <a:rPr lang="en-US" sz="1300" dirty="0">
+                <a:solidFill>
+                  <a:srgbClr val="12202E"/>
+                </a:solidFill>
+                <a:latin typeface="Calibri" pitchFamily="34" charset="0"/>
+                <a:ea typeface="Calibri" pitchFamily="34" charset="-122"/>
+                <a:cs typeface="Calibri" pitchFamily="34" charset="-120"/>
+              </a:rPr>
+              <a:t>A fast, accurate surrogate of the CCME computation on this dataset (validation rows).</a:t>
+            </a:r>
+            <a:endParaRPr lang="en-US" sz="1300" dirty="0"/>
+          </a:p>
+        </p:txBody>
+      </p:sp>
+      <p:sp>
+        <p:nvSpPr>
+          <p:cNvPr id="21" name="Shape 18"/>
+          <p:cNvSpPr/>
+          <p:nvPr/>
+        </p:nvSpPr>
+        <p:spPr>
+          <a:xfrm>
+            <a:off x="6199632" y="4983480"/>
+            <a:ext cx="5440680" cy="1234440"/>
           </a:xfrm>
           <a:prstGeom prst="rect">
             <a:avLst/>
@@ -5937,371 +6292,6 @@
       </p:sp>
       <p:sp>
         <p:nvSpPr>
-          <p:cNvPr id="12" name="Text 9"/>
-          <p:cNvSpPr txBox="1"/>
-          <p:nvPr/>
-        </p:nvSpPr>
-        <p:spPr>
-          <a:xfrm>
-            <a:off x="4480560" y="1847088"/>
-            <a:ext cx="3291840" cy="365760"/>
-          </a:xfrm>
-          <a:prstGeom prst="rect">
-            <a:avLst/>
-          </a:prstGeom>
-          <a:noFill/>
-          <a:ln/>
-        </p:spPr>
-        <p:txBody>
-          <a:bodyPr wrap="square" lIns="0" tIns="0" rIns="0" bIns="0" rtlCol="0" anchor="t"/>
-          <a:lstStyle/>
-          <a:p>
-            <a:pPr indent="0" marL="0">
-              <a:buNone/>
-            </a:pPr>
-            <a:r>
-              <a:rPr lang="en-US" sz="1700" b="1" dirty="0">
-                <a:solidFill>
-                  <a:srgbClr val="D98A1F"/>
-                </a:solidFill>
-                <a:latin typeface="Cambria" pitchFamily="34" charset="0"/>
-                <a:ea typeface="Cambria" pitchFamily="34" charset="-122"/>
-                <a:cs typeface="Cambria" pitchFamily="34" charset="-120"/>
-              </a:rPr>
-              <a:t>2  exceedance_counter</a:t>
-            </a:r>
-            <a:endParaRPr lang="en-US" sz="1700" dirty="0"/>
-          </a:p>
-        </p:txBody>
-      </p:sp>
-      <p:sp>
-        <p:nvSpPr>
-          <p:cNvPr id="13" name="Text 10"/>
-          <p:cNvSpPr txBox="1"/>
-          <p:nvPr/>
-        </p:nvSpPr>
-        <p:spPr>
-          <a:xfrm>
-            <a:off x="4480560" y="2286000"/>
-            <a:ext cx="3291840" cy="2011680"/>
-          </a:xfrm>
-          <a:prstGeom prst="rect">
-            <a:avLst/>
-          </a:prstGeom>
-          <a:noFill/>
-          <a:ln/>
-        </p:spPr>
-        <p:txBody>
-          <a:bodyPr wrap="square" lIns="0" tIns="0" rIns="0" bIns="0" rtlCol="0" anchor="t"/>
-          <a:lstStyle/>
-          <a:p>
-            <a:pPr indent="0" marL="0">
-              <a:buNone/>
-            </a:pPr>
-            <a:r>
-              <a:rPr lang="en-US" sz="1300" dirty="0">
-                <a:solidFill>
-                  <a:srgbClr val="12202E"/>
-                </a:solidFill>
-                <a:latin typeface="Calibri" pitchFamily="34" charset="0"/>
-                <a:ea typeface="Calibri" pitchFamily="34" charset="-122"/>
-                <a:cs typeface="Calibri" pitchFamily="34" charset="-120"/>
-              </a:rPr>
-              <a:t>A guideline-violation count sits in the 38 inputs. It uses the same exceedance information that builds F₁. Tests name only 3 quarantined target columns. Source code could not be read.</a:t>
-            </a:r>
-            <a:endParaRPr lang="en-US" sz="1300" dirty="0"/>
-          </a:p>
-        </p:txBody>
-      </p:sp>
-      <p:sp>
-        <p:nvSpPr>
-          <p:cNvPr id="14" name="Text 11"/>
-          <p:cNvSpPr txBox="1"/>
-          <p:nvPr/>
-        </p:nvSpPr>
-        <p:spPr>
-          <a:xfrm>
-            <a:off x="4480560" y="4389120"/>
-            <a:ext cx="3291840" cy="274320"/>
-          </a:xfrm>
-          <a:prstGeom prst="rect">
-            <a:avLst/>
-          </a:prstGeom>
-          <a:noFill/>
-          <a:ln/>
-        </p:spPr>
-        <p:txBody>
-          <a:bodyPr wrap="square" lIns="0" tIns="0" rIns="0" bIns="0" rtlCol="0" anchor="t"/>
-          <a:lstStyle/>
-          <a:p>
-            <a:pPr indent="0" marL="0">
-              <a:buNone/>
-            </a:pPr>
-            <a:r>
-              <a:rPr lang="en-US" sz="1200" b="1" dirty="0">
-                <a:solidFill>
-                  <a:srgbClr val="5B6B7A"/>
-                </a:solidFill>
-                <a:latin typeface="Calibri" pitchFamily="34" charset="0"/>
-                <a:ea typeface="Calibri" pitchFamily="34" charset="-122"/>
-                <a:cs typeface="Calibri" pitchFamily="34" charset="-120"/>
-              </a:rPr>
-              <a:t>Unresolved risk</a:t>
-            </a:r>
-            <a:endParaRPr lang="en-US" sz="1200" dirty="0"/>
-          </a:p>
-        </p:txBody>
-      </p:sp>
-      <p:sp>
-        <p:nvSpPr>
-          <p:cNvPr id="15" name="Shape 12"/>
-          <p:cNvSpPr/>
-          <p:nvPr/>
-        </p:nvSpPr>
-        <p:spPr>
-          <a:xfrm>
-            <a:off x="8046720" y="1737360"/>
-            <a:ext cx="3611880" cy="3063240"/>
-          </a:xfrm>
-          <a:prstGeom prst="rect">
-            <a:avLst/>
-          </a:prstGeom>
-          <a:solidFill>
-            <a:srgbClr val="F4F8FA"/>
-          </a:solidFill>
-          <a:ln w="12700">
-            <a:solidFill>
-              <a:srgbClr val="F4F8FA"/>
-            </a:solidFill>
-            <a:prstDash val="solid"/>
-          </a:ln>
-        </p:spPr>
-      </p:sp>
-      <p:sp>
-        <p:nvSpPr>
-          <p:cNvPr id="16" name="Text 13"/>
-          <p:cNvSpPr txBox="1"/>
-          <p:nvPr/>
-        </p:nvSpPr>
-        <p:spPr>
-          <a:xfrm>
-            <a:off x="8229600" y="1847088"/>
-            <a:ext cx="3291840" cy="365760"/>
-          </a:xfrm>
-          <a:prstGeom prst="rect">
-            <a:avLst/>
-          </a:prstGeom>
-          <a:noFill/>
-          <a:ln/>
-        </p:spPr>
-        <p:txBody>
-          <a:bodyPr wrap="square" lIns="0" tIns="0" rIns="0" bIns="0" rtlCol="0" anchor="t"/>
-          <a:lstStyle/>
-          <a:p>
-            <a:pPr indent="0" marL="0">
-              <a:buNone/>
-            </a:pPr>
-            <a:r>
-              <a:rPr lang="en-US" sz="1700" b="1" dirty="0">
-                <a:solidFill>
-                  <a:srgbClr val="0E7C86"/>
-                </a:solidFill>
-                <a:latin typeface="Cambria" pitchFamily="34" charset="0"/>
-                <a:ea typeface="Cambria" pitchFamily="34" charset="-122"/>
-                <a:cs typeface="Cambria" pitchFamily="34" charset="-120"/>
-              </a:rPr>
-              <a:t>3  Random split</a:t>
-            </a:r>
-            <a:endParaRPr lang="en-US" sz="1700" dirty="0"/>
-          </a:p>
-        </p:txBody>
-      </p:sp>
-      <p:sp>
-        <p:nvSpPr>
-          <p:cNvPr id="17" name="Text 14"/>
-          <p:cNvSpPr txBox="1"/>
-          <p:nvPr/>
-        </p:nvSpPr>
-        <p:spPr>
-          <a:xfrm>
-            <a:off x="8229600" y="2286000"/>
-            <a:ext cx="3291840" cy="2011680"/>
-          </a:xfrm>
-          <a:prstGeom prst="rect">
-            <a:avLst/>
-          </a:prstGeom>
-          <a:noFill/>
-          <a:ln/>
-        </p:spPr>
-        <p:txBody>
-          <a:bodyPr wrap="square" lIns="0" tIns="0" rIns="0" bIns="0" rtlCol="0" anchor="t"/>
-          <a:lstStyle/>
-          <a:p>
-            <a:pPr indent="0" marL="0">
-              <a:buNone/>
-            </a:pPr>
-            <a:r>
-              <a:rPr lang="en-US" sz="1300" dirty="0">
-                <a:solidFill>
-                  <a:srgbClr val="12202E"/>
-                </a:solidFill>
-                <a:latin typeface="Calibri" pitchFamily="34" charset="0"/>
-                <a:ea typeface="Calibri" pitchFamily="34" charset="-122"/>
-                <a:cs typeface="Calibri" pitchFamily="34" charset="-120"/>
-              </a:rPr>
-              <a:t>Rows are split at random within WQI tiers. Station lags are built before splitting, so a row’s neighbours can sit in training. No station-held-out or time-forward check; test set unreported.</a:t>
-            </a:r>
-            <a:endParaRPr lang="en-US" sz="1300" dirty="0"/>
-          </a:p>
-        </p:txBody>
-      </p:sp>
-      <p:sp>
-        <p:nvSpPr>
-          <p:cNvPr id="18" name="Text 15"/>
-          <p:cNvSpPr txBox="1"/>
-          <p:nvPr/>
-        </p:nvSpPr>
-        <p:spPr>
-          <a:xfrm>
-            <a:off x="8229600" y="4389120"/>
-            <a:ext cx="3291840" cy="274320"/>
-          </a:xfrm>
-          <a:prstGeom prst="rect">
-            <a:avLst/>
-          </a:prstGeom>
-          <a:noFill/>
-          <a:ln/>
-        </p:spPr>
-        <p:txBody>
-          <a:bodyPr wrap="square" lIns="0" tIns="0" rIns="0" bIns="0" rtlCol="0" anchor="t"/>
-          <a:lstStyle/>
-          <a:p>
-            <a:pPr indent="0" marL="0">
-              <a:buNone/>
-            </a:pPr>
-            <a:r>
-              <a:rPr lang="en-US" sz="1200" b="1" dirty="0">
-                <a:solidFill>
-                  <a:srgbClr val="5B6B7A"/>
-                </a:solidFill>
-                <a:latin typeface="Calibri" pitchFamily="34" charset="0"/>
-                <a:ea typeface="Calibri" pitchFamily="34" charset="-122"/>
-                <a:cs typeface="Calibri" pitchFamily="34" charset="-120"/>
-              </a:rPr>
-              <a:t>Confirmed from docs</a:t>
-            </a:r>
-            <a:endParaRPr lang="en-US" sz="1200" dirty="0"/>
-          </a:p>
-        </p:txBody>
-      </p:sp>
-      <p:sp>
-        <p:nvSpPr>
-          <p:cNvPr id="19" name="Shape 16"/>
-          <p:cNvSpPr/>
-          <p:nvPr/>
-        </p:nvSpPr>
-        <p:spPr>
-          <a:xfrm>
-            <a:off x="548640" y="4983480"/>
-            <a:ext cx="5440680" cy="1234440"/>
-          </a:xfrm>
-          <a:prstGeom prst="rect">
-            <a:avLst/>
-          </a:prstGeom>
-          <a:solidFill>
-            <a:srgbClr val="EAF4F6"/>
-          </a:solidFill>
-          <a:ln w="12700">
-            <a:solidFill>
-              <a:srgbClr val="EAF4F6"/>
-            </a:solidFill>
-            <a:prstDash val="solid"/>
-          </a:ln>
-        </p:spPr>
-      </p:sp>
-      <p:sp>
-        <p:nvSpPr>
-          <p:cNvPr id="20" name="Text 17"/>
-          <p:cNvSpPr txBox="1"/>
-          <p:nvPr/>
-        </p:nvSpPr>
-        <p:spPr>
-          <a:xfrm>
-            <a:off x="731520" y="5074920"/>
-            <a:ext cx="5120640" cy="1097280"/>
-          </a:xfrm>
-          <a:prstGeom prst="rect">
-            <a:avLst/>
-          </a:prstGeom>
-          <a:noFill/>
-          <a:ln/>
-        </p:spPr>
-        <p:txBody>
-          <a:bodyPr wrap="square" lIns="0" tIns="0" rIns="0" bIns="0" rtlCol="0" anchor="t"/>
-          <a:lstStyle/>
-          <a:p>
-            <a:pPr indent="0" marL="0">
-              <a:buNone/>
-            </a:pPr>
-            <a:r>
-              <a:rPr lang="en-US" sz="1300" b="1" dirty="0">
-                <a:solidFill>
-                  <a:srgbClr val="0E7C86"/>
-                </a:solidFill>
-                <a:latin typeface="Calibri" pitchFamily="34" charset="0"/>
-                <a:ea typeface="Calibri" pitchFamily="34" charset="-122"/>
-                <a:cs typeface="Calibri" pitchFamily="34" charset="-120"/>
-              </a:rPr>
-              <a:t>Can claim</a:t>
-            </a:r>
-            <a:endParaRPr lang="en-US" sz="1300" dirty="0"/>
-          </a:p>
-          <a:p>
-            <a:pPr indent="0" marL="0">
-              <a:buNone/>
-            </a:pPr>
-            <a:r>
-              <a:rPr lang="en-US" sz="1300" dirty="0">
-                <a:solidFill>
-                  <a:srgbClr val="12202E"/>
-                </a:solidFill>
-                <a:latin typeface="Calibri" pitchFamily="34" charset="0"/>
-                <a:ea typeface="Calibri" pitchFamily="34" charset="-122"/>
-                <a:cs typeface="Calibri" pitchFamily="34" charset="-120"/>
-              </a:rPr>
-              <a:t>Fast, accurate surrogate of the CCME computation on this dataset (validation).</a:t>
-            </a:r>
-            <a:endParaRPr lang="en-US" sz="1300" dirty="0"/>
-          </a:p>
-        </p:txBody>
-      </p:sp>
-      <p:sp>
-        <p:nvSpPr>
-          <p:cNvPr id="21" name="Shape 18"/>
-          <p:cNvSpPr/>
-          <p:nvPr/>
-        </p:nvSpPr>
-        <p:spPr>
-          <a:xfrm>
-            <a:off x="6199632" y="4983480"/>
-            <a:ext cx="5440680" cy="1234440"/>
-          </a:xfrm>
-          <a:prstGeom prst="rect">
-            <a:avLst/>
-          </a:prstGeom>
-          <a:solidFill>
-            <a:srgbClr val="FFF3DC"/>
-          </a:solidFill>
-          <a:ln w="12700">
-            <a:solidFill>
-              <a:srgbClr val="FFF3DC"/>
-            </a:solidFill>
-            <a:prstDash val="solid"/>
-          </a:ln>
-        </p:spPr>
-      </p:sp>
-      <p:sp>
-        <p:nvSpPr>
           <p:cNvPr id="22" name="Text 19"/>
           <p:cNvSpPr txBox="1"/>
           <p:nvPr/>
@@ -6350,7 +6340,7 @@
                 <a:ea typeface="Calibri" pitchFamily="34" charset="-122"/>
                 <a:cs typeface="Calibri" pitchFamily="34" charset="-120"/>
               </a:rPr>
-              <a:t>Leakage-free generalisation to new stations or future years; independent water-quality forecasting.</a:t>
+              <a:t>Performance on unseen stations or future dates; independent water-quality forecasting.</a:t>
             </a:r>
             <a:endParaRPr lang="en-US" sz="1300" dirty="0"/>
           </a:p>
@@ -6460,7 +6450,7 @@
                 <a:ea typeface="Cambria" pitchFamily="34" charset="-122"/>
                 <a:cs typeface="Cambria" pitchFamily="34" charset="-120"/>
               </a:rPr>
-              <a:t>Orthophosphate dominates the model — a property of the index and data, not a causal finding</a:t>
+              <a:t>Orthophosphate dominates the models — a property of the index and data, not a causal finding</a:t>
             </a:r>
             <a:endParaRPr lang="en-US" sz="3000" dirty="0"/>
           </a:p>
@@ -6562,7 +6552,7 @@
       </p:graphicFrame>
       <p:pic>
         <p:nvPicPr>
-          <p:cNvPr id="8" name="Image 0" descr="/home/claude/w/img/r-004.png">    </p:cNvPr>
+          <p:cNvPr id="8" name="Image 0" descr="/home/claude/w/img2/16_MODEL_shap_summary_beeswarm.png">    </p:cNvPr>
           <p:cNvPicPr>
             <a:picLocks noChangeAspect="1"/>
           </p:cNvPicPr>
@@ -6617,7 +6607,7 @@
                 <a:ea typeface="Calibri" pitchFamily="34" charset="-122"/>
                 <a:cs typeface="Calibri" pitchFamily="34" charset="-120"/>
               </a:rPr>
-              <a:t>TreeSHAP beeswarm, XGBoost (project report Fig. 5)</a:t>
+              <a:t>TreeSHAP beeswarm, XGBoost, 250 validation rows (repo graph 16)</a:t>
             </a:r>
             <a:endParaRPr lang="en-US" sz="1100" dirty="0"/>
           </a:p>
@@ -6695,7 +6685,7 @@
                 <a:ea typeface="Calibri" pitchFamily="34" charset="-122"/>
                 <a:cs typeface="Calibri" pitchFamily="34" charset="-120"/>
               </a:rPr>
-              <a:t>Importance describes the model, not the river. Orthophosphate’s share is 88% (RF) / 86% (XGB) of gain/impurity importance, not “88% of splits”.</a:t>
+              <a:t>Importance describes the model, not the river. Orthophosphate + log variant: 88.5% of RF impurity, 76.4% of XGBoost gain; not “88% of split decisions”. The station lag ranks 6th in XGBoost (1.5%).</a:t>
             </a:r>
             <a:endParaRPr lang="en-US" sz="1300" dirty="0"/>
           </a:p>
@@ -6805,7 +6795,7 @@
                 <a:ea typeface="Cambria" pitchFamily="34" charset="-122"/>
                 <a:cs typeface="Cambria" pitchFamily="34" charset="-120"/>
               </a:rPr>
-              <a:t>Phase 1 is complete; the deep-learning model exists, and stricter validation comes next</a:t>
+              <a:t>Phase 1 delivers a tested tree baseline; stricter validation and deep learning come next</a:t>
             </a:r>
             <a:endParaRPr lang="en-US" sz="3000" dirty="0"/>
           </a:p>
@@ -6898,7 +6888,7 @@
         <p:spPr>
           <a:xfrm>
             <a:off x="548640" y="1737360"/>
-            <a:ext cx="3611880" cy="3429000"/>
+            <a:ext cx="3611880" cy="3611880"/>
           </a:xfrm>
           <a:prstGeom prst="rect">
             <a:avLst/>
@@ -6939,7 +6929,7 @@
               <a:buNone/>
             </a:pPr>
             <a:r>
-              <a:rPr lang="en-US" sz="1800" b="1" dirty="0">
+              <a:rPr lang="en-US" sz="1700" b="1" dirty="0">
                 <a:solidFill>
                   <a:srgbClr val="0E7C86"/>
                 </a:solidFill>
@@ -6947,9 +6937,9 @@
                 <a:ea typeface="Cambria" pitchFamily="34" charset="-122"/>
                 <a:cs typeface="Cambria" pitchFamily="34" charset="-120"/>
               </a:rPr>
-              <a:t>Confirmed from documents</a:t>
-            </a:r>
-            <a:endParaRPr lang="en-US" sz="1800" dirty="0"/>
+              <a:t>Confirmed from code and outputs</a:t>
+            </a:r>
+            <a:endParaRPr lang="en-US" sz="1700" dirty="0"/>
           </a:p>
         </p:txBody>
       </p:sp>
@@ -6961,8 +6951,8 @@
         </p:nvSpPr>
         <p:spPr>
           <a:xfrm>
-            <a:off x="731520" y="2377440"/>
-            <a:ext cx="3291840" cy="2651760"/>
+            <a:off x="731520" y="2423160"/>
+            <a:ext cx="3291840" cy="2834640"/>
           </a:xfrm>
           <a:prstGeom prst="rect">
             <a:avLst/>
@@ -7011,7 +7001,7 @@
                 <a:ea typeface="Calibri" pitchFamily="34" charset="-122"/>
                 <a:cs typeface="Calibri" pitchFamily="34" charset="-120"/>
               </a:rPr>
-              <a:t>Random split; no station/time hold-out</a:t>
+              <a:t>Random split; no station or time hold-out</a:t>
             </a:r>
             <a:endParaRPr lang="en-US" sz="1400" dirty="0"/>
           </a:p>
@@ -7032,7 +7022,7 @@
                 <a:ea typeface="Calibri" pitchFamily="34" charset="-122"/>
                 <a:cs typeface="Calibri" pitchFamily="34" charset="-120"/>
               </a:rPr>
-              <a:t>Validation metrics only; test set unreported</a:t>
+              <a:t>Validation metrics only; test set unscored</a:t>
             </a:r>
             <a:endParaRPr lang="en-US" sz="1400" dirty="0"/>
           </a:p>
@@ -7053,7 +7043,7 @@
                 <a:ea typeface="Calibri" pitchFamily="34" charset="-122"/>
                 <a:cs typeface="Calibri" pitchFamily="34" charset="-120"/>
               </a:rPr>
-              <a:t>Report and repo disagree on tree settings, country counts, importance wording</a:t>
+              <a:t>XGBoost validation numbers differ between artifacts</a:t>
             </a:r>
             <a:endParaRPr lang="en-US" sz="1400" dirty="0"/>
           </a:p>
@@ -7068,7 +7058,7 @@
         <p:spPr>
           <a:xfrm>
             <a:off x="4297680" y="1737360"/>
-            <a:ext cx="3611880" cy="3429000"/>
+            <a:ext cx="3611880" cy="3611880"/>
           </a:xfrm>
           <a:prstGeom prst="rect">
             <a:avLst/>
@@ -7109,7 +7099,7 @@
               <a:buNone/>
             </a:pPr>
             <a:r>
-              <a:rPr lang="en-US" sz="1800" b="1" dirty="0">
+              <a:rPr lang="en-US" sz="1700" b="1" dirty="0">
                 <a:solidFill>
                   <a:srgbClr val="D98A1F"/>
                 </a:solidFill>
@@ -7119,7 +7109,7 @@
               </a:rPr>
               <a:t>Open / not verified</a:t>
             </a:r>
-            <a:endParaRPr lang="en-US" sz="1800" dirty="0"/>
+            <a:endParaRPr lang="en-US" sz="1700" dirty="0"/>
           </a:p>
         </p:txBody>
       </p:sp>
@@ -7131,8 +7121,8 @@
         </p:nvSpPr>
         <p:spPr>
           <a:xfrm>
-            <a:off x="4480560" y="2377440"/>
-            <a:ext cx="3291840" cy="2651760"/>
+            <a:off x="4480560" y="2423160"/>
+            <a:ext cx="3291840" cy="2834640"/>
           </a:xfrm>
           <a:prstGeom prst="rect">
             <a:avLst/>
@@ -7160,7 +7150,7 @@
                 <a:ea typeface="Calibri" pitchFamily="34" charset="-122"/>
                 <a:cs typeface="Calibri" pitchFamily="34" charset="-120"/>
               </a:rPr>
-              <a:t>Whether exceedance_counter inflates scores</a:t>
+              <a:t>Whether the 0-null file reflects upstream filling (clustered values; graph 17)</a:t>
             </a:r>
             <a:endParaRPr lang="en-US" sz="1400" dirty="0"/>
           </a:p>
@@ -7181,7 +7171,7 @@
                 <a:ea typeface="Calibri" pitchFamily="34" charset="-122"/>
                 <a:cs typeface="Calibri" pitchFamily="34" charset="-120"/>
               </a:rPr>
-              <a:t>Latency figures (hardware, batch size)</a:t>
+              <a:t>Effect of dropping exceedance_counter</a:t>
             </a:r>
             <a:endParaRPr lang="en-US" sz="1400" dirty="0"/>
           </a:p>
@@ -7202,7 +7192,7 @@
                 <a:ea typeface="Calibri" pitchFamily="34" charset="-122"/>
                 <a:cs typeface="Calibri" pitchFamily="34" charset="-120"/>
               </a:rPr>
-              <a:t>Duplicates and cross-partition near-duplicates</a:t>
+              <a:t>Duplicates across partitions</a:t>
             </a:r>
             <a:endParaRPr lang="en-US" sz="1400" dirty="0"/>
           </a:p>
@@ -7223,7 +7213,7 @@
                 <a:ea typeface="Calibri" pitchFamily="34" charset="-122"/>
                 <a:cs typeface="Calibri" pitchFamily="34" charset="-120"/>
               </a:rPr>
-              <a:t>Source code and notebooks not reviewed</a:t>
+              <a:t>Inference latency (not measured)</a:t>
             </a:r>
             <a:endParaRPr lang="en-US" sz="1400" dirty="0"/>
           </a:p>
@@ -7238,7 +7228,7 @@
         <p:spPr>
           <a:xfrm>
             <a:off x="8046720" y="1737360"/>
-            <a:ext cx="3611880" cy="3429000"/>
+            <a:ext cx="3611880" cy="3611880"/>
           </a:xfrm>
           <a:prstGeom prst="rect">
             <a:avLst/>
@@ -7279,7 +7269,7 @@
               <a:buNone/>
             </a:pPr>
             <a:r>
-              <a:rPr lang="en-US" sz="1800" b="1" dirty="0">
+              <a:rPr lang="en-US" sz="1700" b="1" dirty="0">
                 <a:solidFill>
                   <a:srgbClr val="0B1F33"/>
                 </a:solidFill>
@@ -7289,7 +7279,7 @@
               </a:rPr>
               <a:t>Planned (not done)</a:t>
             </a:r>
-            <a:endParaRPr lang="en-US" sz="1800" dirty="0"/>
+            <a:endParaRPr lang="en-US" sz="1700" dirty="0"/>
           </a:p>
         </p:txBody>
       </p:sp>
@@ -7301,8 +7291,8 @@
         </p:nvSpPr>
         <p:spPr>
           <a:xfrm>
-            <a:off x="8229600" y="2377440"/>
-            <a:ext cx="3291840" cy="2651760"/>
+            <a:off x="8229600" y="2423160"/>
+            <a:ext cx="3291840" cy="2834640"/>
           </a:xfrm>
           <a:prstGeom prst="rect">
             <a:avLst/>
@@ -7330,7 +7320,7 @@
                 <a:ea typeface="Calibri" pitchFamily="34" charset="-122"/>
                 <a:cs typeface="Calibri" pitchFamily="34" charset="-120"/>
               </a:rPr>
-              <a:t>Ablation without exceedance_counter</a:t>
+              <a:t>Station-held-out and time-forward splits</a:t>
             </a:r>
             <a:endParaRPr lang="en-US" sz="1400" dirty="0"/>
           </a:p>
@@ -7351,7 +7341,7 @@
                 <a:ea typeface="Calibri" pitchFamily="34" charset="-122"/>
                 <a:cs typeface="Calibri" pitchFamily="34" charset="-120"/>
               </a:rPr>
-              <a:t>Station-held-out and time-forward splits</a:t>
+              <a:t>Score the held-out test set</a:t>
             </a:r>
             <a:endParaRPr lang="en-US" sz="1400" dirty="0"/>
           </a:p>
@@ -7372,7 +7362,7 @@
                 <a:ea typeface="Calibri" pitchFamily="34" charset="-122"/>
                 <a:cs typeface="Calibri" pitchFamily="34" charset="-120"/>
               </a:rPr>
-              <a:t>Report held-out test scores</a:t>
+              <a:t>Re-run notebooks 03–04 to align artifacts</a:t>
             </a:r>
             <a:endParaRPr lang="en-US" sz="1400" dirty="0"/>
           </a:p>
@@ -7393,7 +7383,7 @@
                 <a:ea typeface="Calibri" pitchFamily="34" charset="-122"/>
                 <a:cs typeface="Calibri" pitchFamily="34" charset="-120"/>
               </a:rPr>
-              <a:t>External validation; uncertainty beyond MLP calibration</a:t>
+              <a:t>Phase 2: multi-task neural network</a:t>
             </a:r>
             <a:endParaRPr lang="en-US" sz="1400" dirty="0"/>
           </a:p>
@@ -7407,7 +7397,7 @@
         </p:nvSpPr>
         <p:spPr>
           <a:xfrm>
-            <a:off x="548640" y="5440680"/>
+            <a:off x="548640" y="5532120"/>
             <a:ext cx="11064240" cy="548640"/>
           </a:xfrm>
           <a:prstGeom prst="rect">
@@ -7432,7 +7422,7 @@
                 <a:ea typeface="Calibri" pitchFamily="34" charset="-122"/>
                 <a:cs typeface="Calibri" pitchFamily="34" charset="-120"/>
               </a:rPr>
-              <a:t>Implemented (validation only): dual-head MLP — R² 0.9957, MAE 0.706, accuracy 96.09%, ECE 1.27% — per the repository technical report.</a:t>
+              <a:t>Deep learning: no neural-network code or results exist in this repo version, so none are claimed. Phase 2 is planned.</a:t>
             </a:r>
             <a:endParaRPr lang="en-US" sz="1500" dirty="0"/>
           </a:p>
@@ -7542,7 +7532,7 @@
                 <a:ea typeface="Cambria" pitchFamily="34" charset="-122"/>
                 <a:cs typeface="Cambria" pitchFamily="34" charset="-120"/>
               </a:rPr>
-              <a:t>A reproducible, well-tested baseline — with a clear route to a stricter evaluation</a:t>
+              <a:t>A reproducible tree baseline — with a clear route to a stricter evaluation</a:t>
             </a:r>
             <a:endParaRPr lang="en-US" sz="3000" dirty="0"/>
           </a:p>
@@ -7679,7 +7669,7 @@
                 <a:ea typeface="Calibri" pitchFamily="34" charset="-122"/>
                 <a:cs typeface="Calibri" pitchFamily="34" charset="-120"/>
               </a:rPr>
-              <a:t>audited 2.82 M-row dataset, 38 chemistry-driven features, RF/XGBoost/MLP benchmarks, SHAP, 12 tests.</a:t>
+              <a:t>audited 2.82 M-row dataset, 38 chemistry-driven features, RF and XGBoost benchmarks, SHAP, 12 tests.</a:t>
             </a:r>
             <a:endParaRPr lang="en-US" sz="1500" dirty="0"/>
           </a:p>
@@ -7716,7 +7706,7 @@
                 <a:ea typeface="Calibri" pitchFamily="34" charset="-122"/>
                 <a:cs typeface="Calibri" pitchFamily="34" charset="-120"/>
               </a:rPr>
-              <a:t>models re-compute the CCME index with validation MAE ≤ 0.14 (trees).</a:t>
+              <a:t>trees reconstruct the CCME index with validation MAE 0.05 (RF) to 0.14–0.16 (XGBoost).</a:t>
             </a:r>
             <a:endParaRPr lang="en-US" sz="1500" dirty="0"/>
           </a:p>
@@ -7753,7 +7743,7 @@
                 <a:ea typeface="Calibri" pitchFamily="34" charset="-122"/>
                 <a:cs typeface="Calibri" pitchFamily="34" charset="-120"/>
               </a:rPr>
-              <a:t>the target is a formula of the inputs and the split is random, so run leakage-free ablations next.</a:t>
+              <a:t>the target is a formula of the inputs and the split is random; next, station-held-out and time-forward evaluation.</a:t>
             </a:r>
             <a:endParaRPr lang="en-US" sz="1500" dirty="0"/>
           </a:p>
@@ -7767,7 +7757,7 @@
         </p:nvSpPr>
         <p:spPr>
           <a:xfrm>
-            <a:off x="548640" y="4160520"/>
+            <a:off x="548640" y="3931920"/>
             <a:ext cx="5486400" cy="320040"/>
           </a:xfrm>
           <a:prstGeom prst="rect">
@@ -7806,8 +7796,8 @@
         </p:nvSpPr>
         <p:spPr>
           <a:xfrm>
-            <a:off x="548640" y="4526280"/>
-            <a:ext cx="5577840" cy="1463040"/>
+            <a:off x="548640" y="4297680"/>
+            <a:ext cx="5577840" cy="1920240"/>
           </a:xfrm>
           <a:prstGeom prst="rect">
             <a:avLst/>
@@ -7820,10 +7810,13 @@
           <a:lstStyle/>
           <a:p>
             <a:pPr indent="0" marL="0">
-              <a:buNone/>
-            </a:pPr>
-            <a:r>
-              <a:rPr lang="en-US" sz="1200" dirty="0" b="1">
+              <a:spcAft>
+                <a:spcPts val="300"/>
+              </a:spcAft>
+              <a:buNone/>
+            </a:pPr>
+            <a:r>
+              <a:rPr lang="en-US" sz="1200" dirty="0">
                 <a:solidFill>
                   <a:srgbClr val="BFD6E2"/>
                 </a:solidFill>
@@ -7831,8 +7824,17 @@
                 <a:ea typeface="Calibri" pitchFamily="34" charset="-122"/>
                 <a:cs typeface="Calibri" pitchFamily="34" charset="-120"/>
               </a:rPr>
-              <a:t>Mayank Sharma</a:t>
-            </a:r>
+              <a:t>Mayank Sharma – EDA &amp; repository management lead</a:t>
+            </a:r>
+            <a:endParaRPr lang="en-US" sz="1200" dirty="0"/>
+          </a:p>
+          <a:p>
+            <a:pPr indent="0" marL="0">
+              <a:spcAft>
+                <a:spcPts val="300"/>
+              </a:spcAft>
+              <a:buNone/>
+            </a:pPr>
             <a:r>
               <a:rPr lang="en-US" sz="1200" dirty="0">
                 <a:solidFill>
@@ -7842,16 +7844,19 @@
                 <a:ea typeface="Calibri" pitchFamily="34" charset="-122"/>
                 <a:cs typeface="Calibri" pitchFamily="34" charset="-120"/>
               </a:rPr>
-              <a:t> – EDA &amp; repository management lead</a:t>
+              <a:t>Aman Soni – model training lead (baseline, RF, XGBoost)</a:t>
             </a:r>
             <a:endParaRPr lang="en-US" sz="1200" dirty="0"/>
           </a:p>
           <a:p>
             <a:pPr indent="0" marL="0">
-              <a:buNone/>
-            </a:pPr>
-            <a:r>
-              <a:rPr lang="en-US" sz="1200" dirty="0" b="1">
+              <a:spcAft>
+                <a:spcPts val="300"/>
+              </a:spcAft>
+              <a:buNone/>
+            </a:pPr>
+            <a:r>
+              <a:rPr lang="en-US" sz="1200" dirty="0">
                 <a:solidFill>
                   <a:srgbClr val="BFD6E2"/>
                 </a:solidFill>
@@ -7859,8 +7864,17 @@
                 <a:ea typeface="Calibri" pitchFamily="34" charset="-122"/>
                 <a:cs typeface="Calibri" pitchFamily="34" charset="-120"/>
               </a:rPr>
-              <a:t>Aman Soni</a:t>
-            </a:r>
+              <a:t>Aaryan Gera – data preprocessing</a:t>
+            </a:r>
+            <a:endParaRPr lang="en-US" sz="1200" dirty="0"/>
+          </a:p>
+          <a:p>
+            <a:pPr indent="0" marL="0">
+              <a:spcAft>
+                <a:spcPts val="300"/>
+              </a:spcAft>
+              <a:buNone/>
+            </a:pPr>
             <a:r>
               <a:rPr lang="en-US" sz="1200" dirty="0">
                 <a:solidFill>
@@ -7870,16 +7884,19 @@
                 <a:ea typeface="Calibri" pitchFamily="34" charset="-122"/>
                 <a:cs typeface="Calibri" pitchFamily="34" charset="-120"/>
               </a:rPr>
-              <a:t> – model training lead (baseline, RF, XGBoost)</a:t>
+              <a:t>Chaitanya Kumar – feature engineering &amp; pipeline</a:t>
             </a:r>
             <a:endParaRPr lang="en-US" sz="1200" dirty="0"/>
           </a:p>
           <a:p>
             <a:pPr indent="0" marL="0">
-              <a:buNone/>
-            </a:pPr>
-            <a:r>
-              <a:rPr lang="en-US" sz="1200" dirty="0" b="1">
+              <a:spcAft>
+                <a:spcPts val="300"/>
+              </a:spcAft>
+              <a:buNone/>
+            </a:pPr>
+            <a:r>
+              <a:rPr lang="en-US" sz="1200" dirty="0">
                 <a:solidFill>
                   <a:srgbClr val="BFD6E2"/>
                 </a:solidFill>
@@ -7887,8 +7904,17 @@
                 <a:ea typeface="Calibri" pitchFamily="34" charset="-122"/>
                 <a:cs typeface="Calibri" pitchFamily="34" charset="-120"/>
               </a:rPr>
-              <a:t>Aaryan Gera</a:t>
-            </a:r>
+              <a:t>Ankit Kumar Pandey – model evaluation &amp; validation</a:t>
+            </a:r>
+            <a:endParaRPr lang="en-US" sz="1200" dirty="0"/>
+          </a:p>
+          <a:p>
+            <a:pPr indent="0" marL="0">
+              <a:spcAft>
+                <a:spcPts val="300"/>
+              </a:spcAft>
+              <a:buNone/>
+            </a:pPr>
             <a:r>
               <a:rPr lang="en-US" sz="1200" dirty="0">
                 <a:solidFill>
@@ -7898,91 +7924,7 @@
                 <a:ea typeface="Calibri" pitchFamily="34" charset="-122"/>
                 <a:cs typeface="Calibri" pitchFamily="34" charset="-120"/>
               </a:rPr>
-              <a:t> – data preprocessing (cleaning, dataset preparation)</a:t>
-            </a:r>
-            <a:endParaRPr lang="en-US" sz="1200" dirty="0"/>
-          </a:p>
-          <a:p>
-            <a:pPr indent="0" marL="0">
-              <a:buNone/>
-            </a:pPr>
-            <a:r>
-              <a:rPr lang="en-US" sz="1200" dirty="0" b="1">
-                <a:solidFill>
-                  <a:srgbClr val="BFD6E2"/>
-                </a:solidFill>
-                <a:latin typeface="Calibri" pitchFamily="34" charset="0"/>
-                <a:ea typeface="Calibri" pitchFamily="34" charset="-122"/>
-                <a:cs typeface="Calibri" pitchFamily="34" charset="-120"/>
-              </a:rPr>
-              <a:t>Chaitanya Kumar</a:t>
-            </a:r>
-            <a:r>
-              <a:rPr lang="en-US" sz="1200" dirty="0">
-                <a:solidFill>
-                  <a:srgbClr val="BFD6E2"/>
-                </a:solidFill>
-                <a:latin typeface="Calibri" pitchFamily="34" charset="0"/>
-                <a:ea typeface="Calibri" pitchFamily="34" charset="-122"/>
-                <a:cs typeface="Calibri" pitchFamily="34" charset="-120"/>
-              </a:rPr>
-              <a:t> – feature engineering &amp; pipeline</a:t>
-            </a:r>
-            <a:endParaRPr lang="en-US" sz="1200" dirty="0"/>
-          </a:p>
-          <a:p>
-            <a:pPr indent="0" marL="0">
-              <a:buNone/>
-            </a:pPr>
-            <a:r>
-              <a:rPr lang="en-US" sz="1200" dirty="0" b="1">
-                <a:solidFill>
-                  <a:srgbClr val="BFD6E2"/>
-                </a:solidFill>
-                <a:latin typeface="Calibri" pitchFamily="34" charset="0"/>
-                <a:ea typeface="Calibri" pitchFamily="34" charset="-122"/>
-                <a:cs typeface="Calibri" pitchFamily="34" charset="-120"/>
-              </a:rPr>
-              <a:t>Ankit Kumar Pandey</a:t>
-            </a:r>
-            <a:r>
-              <a:rPr lang="en-US" sz="1200" dirty="0">
-                <a:solidFill>
-                  <a:srgbClr val="BFD6E2"/>
-                </a:solidFill>
-                <a:latin typeface="Calibri" pitchFamily="34" charset="0"/>
-                <a:ea typeface="Calibri" pitchFamily="34" charset="-122"/>
-                <a:cs typeface="Calibri" pitchFamily="34" charset="-120"/>
-              </a:rPr>
-              <a:t> – model evaluation &amp; validation (MAE, RMSE, R²)</a:t>
-            </a:r>
-            <a:endParaRPr lang="en-US" sz="1200" dirty="0"/>
-          </a:p>
-          <a:p>
-            <a:pPr indent="0" marL="0">
-              <a:buNone/>
-            </a:pPr>
-            <a:r>
-              <a:rPr lang="en-US" sz="1200" dirty="0" b="1">
-                <a:solidFill>
-                  <a:srgbClr val="BFD6E2"/>
-                </a:solidFill>
-                <a:latin typeface="Calibri" pitchFamily="34" charset="0"/>
-                <a:ea typeface="Calibri" pitchFamily="34" charset="-122"/>
-                <a:cs typeface="Calibri" pitchFamily="34" charset="-120"/>
-              </a:rPr>
-              <a:t>Pranav</a:t>
-            </a:r>
-            <a:r>
-              <a:rPr lang="en-US" sz="1200" dirty="0">
-                <a:solidFill>
-                  <a:srgbClr val="BFD6E2"/>
-                </a:solidFill>
-                <a:latin typeface="Calibri" pitchFamily="34" charset="0"/>
-                <a:ea typeface="Calibri" pitchFamily="34" charset="-122"/>
-                <a:cs typeface="Calibri" pitchFamily="34" charset="-120"/>
-              </a:rPr>
-              <a:t> – research, documentation &amp; presentation</a:t>
+              <a:t>Pranav Sehgal – research, documentation &amp; presentation</a:t>
             </a:r>
             <a:endParaRPr lang="en-US" sz="1200" dirty="0"/>
           </a:p>
@@ -8036,7 +7978,7 @@
         <p:spPr>
           <a:xfrm>
             <a:off x="6583680" y="2057400"/>
-            <a:ext cx="5029200" cy="2743200"/>
+            <a:ext cx="5029200" cy="3017520"/>
           </a:xfrm>
           <a:prstGeom prst="rect">
             <a:avLst/>
@@ -8083,7 +8025,7 @@
                 <a:ea typeface="Calibri" pitchFamily="34" charset="-122"/>
                 <a:cs typeface="Calibri" pitchFamily="34" charset="-120"/>
               </a:rPr>
-              <a:t>Chen &amp; Guestrin (2016) XGBoost. KDD</a:t>
+              <a:t>Goodfellow, Bengio &amp; Courville (2016) Deep Learning. MIT Press (feed-forward networks)</a:t>
             </a:r>
             <a:endParaRPr lang="en-US" sz="1200" dirty="0"/>
           </a:p>
@@ -8103,7 +8045,7 @@
                 <a:ea typeface="Calibri" pitchFamily="34" charset="-122"/>
                 <a:cs typeface="Calibri" pitchFamily="34" charset="-120"/>
               </a:rPr>
-              <a:t>Lundberg &amp; Lee (2017) SHAP. NeurIPS</a:t>
+              <a:t>Chen &amp; Guestrin (2016) XGBoost. KDD</a:t>
             </a:r>
             <a:endParaRPr lang="en-US" sz="1200" dirty="0"/>
           </a:p>
@@ -8123,7 +8065,7 @@
                 <a:ea typeface="Calibri" pitchFamily="34" charset="-122"/>
                 <a:cs typeface="Calibri" pitchFamily="34" charset="-120"/>
               </a:rPr>
-              <a:t>CCME (2001) Water Quality Index 1.0 Technical Report</a:t>
+              <a:t>Lundberg &amp; Lee (2017) SHAP. NeurIPS</a:t>
             </a:r>
             <a:endParaRPr lang="en-US" sz="1200" dirty="0"/>
           </a:p>
@@ -8143,7 +8085,7 @@
                 <a:ea typeface="Calibri" pitchFamily="34" charset="-122"/>
                 <a:cs typeface="Calibri" pitchFamily="34" charset="-120"/>
               </a:rPr>
-              <a:t>Benson &amp; Krause (1984) Limnol. Oceanogr. 29(3)</a:t>
+              <a:t>CCME (2001) Water Quality Index 1.0 Technical Report</a:t>
             </a:r>
             <a:endParaRPr lang="en-US" sz="1200" dirty="0"/>
           </a:p>
@@ -8163,7 +8105,7 @@
                 <a:ea typeface="Calibri" pitchFamily="34" charset="-122"/>
                 <a:cs typeface="Calibri" pitchFamily="34" charset="-120"/>
               </a:rPr>
-              <a:t>Redfield (1958) Am. Scientist 46(3)</a:t>
+              <a:t>Benson &amp; Krause (1984) Limnol. Oceanogr. 29(3)</a:t>
             </a:r>
             <a:endParaRPr lang="en-US" sz="1200" dirty="0"/>
           </a:p>
@@ -8183,6 +8125,26 @@
                 <a:ea typeface="Calibri" pitchFamily="34" charset="-122"/>
                 <a:cs typeface="Calibri" pitchFamily="34" charset="-120"/>
               </a:rPr>
+              <a:t>Redfield (1958) Am. Scientist 46(3)</a:t>
+            </a:r>
+            <a:endParaRPr lang="en-US" sz="1200" dirty="0"/>
+          </a:p>
+          <a:p>
+            <a:pPr indent="0" marL="0">
+              <a:spcAft>
+                <a:spcPts val="500"/>
+              </a:spcAft>
+              <a:buNone/>
+            </a:pPr>
+            <a:r>
+              <a:rPr lang="en-US" sz="1200" dirty="0">
+                <a:solidFill>
+                  <a:srgbClr val="BFD6E2"/>
+                </a:solidFill>
+                <a:latin typeface="Calibri" pitchFamily="34" charset="0"/>
+                <a:ea typeface="Calibri" pitchFamily="34" charset="-122"/>
+                <a:cs typeface="Calibri" pitchFamily="34" charset="-120"/>
+              </a:rPr>
               <a:t>Emerson et al. (1975) J. Fish. Res. Board Can. 32(12)</a:t>
             </a:r>
             <a:endParaRPr lang="en-US" sz="1200" dirty="0"/>
@@ -8197,7 +8159,7 @@
         </p:nvSpPr>
         <p:spPr>
           <a:xfrm>
-            <a:off x="6583680" y="5120640"/>
+            <a:off x="6583680" y="5303520"/>
             <a:ext cx="5029200" cy="822960"/>
           </a:xfrm>
           <a:prstGeom prst="rect">
@@ -8222,7 +8184,7 @@
                 <a:ea typeface="Calibri" pitchFamily="34" charset="-122"/>
                 <a:cs typeface="Calibri" pitchFamily="34" charset="-120"/>
               </a:rPr>
-              <a:t>Data: national agencies as named in the project report (England EA, USGS, EPA Ireland, MEE China, ECCC). Code: github.com/MAYANKSHARMA01010/Semester_5_AML_DL</a:t>
+              <a:t>Data: agencies listed in the repo’s DataCollectionSources sheet (data.gov.uk, USGS/EPA, EPA Ireland, MEE China, ECCC). Code: github.com/MAYANKSHARMA01010/Semester_5_AML_DL</a:t>
             </a:r>
             <a:endParaRPr lang="en-US" sz="1100" dirty="0"/>
           </a:p>
@@ -8875,7 +8837,7 @@
                 <a:ea typeface="Calibri" pitchFamily="34" charset="-122"/>
                 <a:cs typeface="Calibri" pitchFamily="34" charset="-120"/>
               </a:rPr>
-              <a:t>Learn a fast surrogate: measured physico-chemical parameters (pH, temperature, DO, BOD, ammonia, orthophosphate, nitrogen, nitrate) → CCME WQI score and quality tier.</a:t>
+              <a:t>Learn a fast surrogate: eight measured parameters (pH, temperature, DO, BOD, ammonia, orthophosphate, nitrogen, nitrate) plus engineered features → CCME WQI score.</a:t>
             </a:r>
             <a:endParaRPr lang="en-US" sz="1500" dirty="0"/>
           </a:p>
@@ -8929,7 +8891,7 @@
         <p:spPr>
           <a:xfrm>
             <a:off x="6400800" y="4160520"/>
-            <a:ext cx="5212080" cy="1463040"/>
+            <a:ext cx="5212080" cy="1737360"/>
           </a:xfrm>
           <a:prstGeom prst="rect">
             <a:avLst/>
@@ -8957,7 +8919,7 @@
                 <a:ea typeface="Calibri" pitchFamily="34" charset="-122"/>
                 <a:cs typeface="Calibri" pitchFamily="34" charset="-120"/>
               </a:rPr>
-              <a:t>Demonstrated: offline regression and classification on a historical dataset</a:t>
+              <a:t>Demonstrated: offline regression on a historical dataset (Random Forest, XGBoost)</a:t>
             </a:r>
             <a:endParaRPr lang="en-US" sz="1500" dirty="0"/>
           </a:p>
@@ -8978,7 +8940,7 @@
                 <a:ea typeface="Calibri" pitchFamily="34" charset="-122"/>
                 <a:cs typeface="Calibri" pitchFamily="34" charset="-120"/>
               </a:rPr>
-              <a:t>Not demonstrated: real-time sensing, field deployment, replacing laboratory testing</a:t>
+              <a:t>Not demonstrated: real-time sensing, field deployment, replacing laboratory testing, or any neural network (planned Phase 2)</a:t>
             </a:r>
             <a:endParaRPr lang="en-US" sz="1500" dirty="0"/>
           </a:p>
@@ -9887,7 +9849,7 @@
                 <a:ea typeface="Calibri" pitchFamily="34" charset="-122"/>
                 <a:cs typeface="Calibri" pitchFamily="34" charset="-120"/>
               </a:rPr>
-              <a:t>11.3%</a:t>
+              <a:t>11.2%</a:t>
             </a:r>
             <a:endParaRPr lang="en-US" sz="1200" dirty="0"/>
           </a:p>
@@ -9990,7 +9952,7 @@
                 <a:ea typeface="Calibri" pitchFamily="34" charset="-122"/>
                 <a:cs typeface="Calibri" pitchFamily="34" charset="-120"/>
               </a:rPr>
-              <a:t>36.4%</a:t>
+              <a:t>36.6%</a:t>
             </a:r>
             <a:endParaRPr lang="en-US" sz="1200" dirty="0"/>
           </a:p>
@@ -10093,7 +10055,7 @@
                 <a:ea typeface="Calibri" pitchFamily="34" charset="-122"/>
                 <a:cs typeface="Calibri" pitchFamily="34" charset="-120"/>
               </a:rPr>
-              <a:t>36.2%</a:t>
+              <a:t>36.1%</a:t>
             </a:r>
             <a:endParaRPr lang="en-US" sz="1200" dirty="0"/>
           </a:p>
@@ -10132,7 +10094,7 @@
                 <a:ea typeface="Calibri" pitchFamily="34" charset="-122"/>
                 <a:cs typeface="Calibri" pitchFamily="34" charset="-120"/>
               </a:rPr>
-              <a:t>Index values in the data: mean 85.05, median 90.64, range 32.15–100 (strongly left-skewed). Tier shares from the technical report; they sum to ≈100%.</a:t>
+              <a:t>Index in the data: mean ≈ 85, median 90.6, bounded 0–100, strongly left-skewed. Shares from repo graph 11 (EDA).</a:t>
             </a:r>
             <a:endParaRPr lang="en-US" sz="1300" dirty="0"/>
           </a:p>
@@ -10724,7 +10686,7 @@
         </p:nvGraphicFramePr>
         <p:xfrm>
           <a:off x="548640" y="2926080"/>
-          <a:ext cx="6766560" cy="3291840"/>
+          <a:ext cx="5394960" cy="3291840"/>
         </p:xfrm>
         <a:graphic xmlns:a="http://schemas.openxmlformats.org/drawingml/2006/main">
           <a:graphicData uri="http://schemas.openxmlformats.org/drawingml/2006/chart">
@@ -10732,41 +10694,40 @@
           </a:graphicData>
         </a:graphic>
       </p:graphicFrame>
-      <p:sp>
-        <p:nvSpPr>
-          <p:cNvPr id="18" name="Shape 14"/>
-          <p:cNvSpPr/>
-          <p:nvPr/>
-        </p:nvSpPr>
-        <p:spPr>
-          <a:xfrm>
-            <a:off x="7680960" y="3017520"/>
-            <a:ext cx="3959352" cy="3063240"/>
-          </a:xfrm>
-          <a:prstGeom prst="rect">
-            <a:avLst/>
-          </a:prstGeom>
-          <a:solidFill>
-            <a:srgbClr val="EAF4F6"/>
-          </a:solidFill>
-          <a:ln w="12700">
-            <a:solidFill>
-              <a:srgbClr val="EAF4F6"/>
-            </a:solidFill>
-            <a:prstDash val="solid"/>
-          </a:ln>
-        </p:spPr>
-      </p:sp>
-      <p:sp>
-        <p:nvSpPr>
-          <p:cNvPr id="19" name="Text 15"/>
-          <p:cNvSpPr txBox="1"/>
-          <p:nvPr/>
-        </p:nvSpPr>
-        <p:spPr>
-          <a:xfrm>
-            <a:off x="7909560" y="3154680"/>
-            <a:ext cx="3566160" cy="320040"/>
+      <p:pic>
+        <p:nvPicPr>
+          <p:cNvPr id="18" name="Image 0" descr="/home/claude/w/img2/03_EDA_temporal_coverage_1940_2023.png">    </p:cNvPr>
+          <p:cNvPicPr>
+            <a:picLocks noChangeAspect="1"/>
+          </p:cNvPicPr>
+          <p:nvPr/>
+        </p:nvPicPr>
+        <p:blipFill>
+          <a:blip r:embed="rId2"/>
+          <a:stretch>
+            <a:fillRect/>
+          </a:stretch>
+        </p:blipFill>
+        <p:spPr>
+          <a:xfrm>
+            <a:off x="6263640" y="2834640"/>
+            <a:ext cx="5394960" cy="3447288"/>
+          </a:xfrm>
+          <a:prstGeom prst="rect">
+            <a:avLst/>
+          </a:prstGeom>
+        </p:spPr>
+      </p:pic>
+      <p:sp>
+        <p:nvSpPr>
+          <p:cNvPr id="19" name="Text 14"/>
+          <p:cNvSpPr txBox="1"/>
+          <p:nvPr/>
+        </p:nvSpPr>
+        <p:spPr>
+          <a:xfrm>
+            <a:off x="6263640" y="6291072"/>
+            <a:ext cx="5394960" cy="182880"/>
           </a:xfrm>
           <a:prstGeom prst="rect">
             <a:avLst/>
@@ -10782,168 +10743,7 @@
               <a:buNone/>
             </a:pPr>
             <a:r>
-              <a:rPr lang="en-US" sz="1600" b="1" dirty="0">
-                <a:solidFill>
-                  <a:srgbClr val="0B1F33"/>
-                </a:solidFill>
-                <a:latin typeface="Cambria" pitchFamily="34" charset="0"/>
-                <a:ea typeface="Cambria" pitchFamily="34" charset="-122"/>
-                <a:cs typeface="Cambria" pitchFamily="34" charset="-120"/>
-              </a:rPr>
-              <a:t>Clean row counts</a:t>
-            </a:r>
-            <a:endParaRPr lang="en-US" sz="1600" dirty="0"/>
-          </a:p>
-        </p:txBody>
-      </p:sp>
-      <p:sp>
-        <p:nvSpPr>
-          <p:cNvPr id="20" name="Text 16"/>
-          <p:cNvSpPr txBox="1"/>
-          <p:nvPr/>
-        </p:nvSpPr>
-        <p:spPr>
-          <a:xfrm>
-            <a:off x="7909560" y="3520440"/>
-            <a:ext cx="3566160" cy="1554480"/>
-          </a:xfrm>
-          <a:prstGeom prst="rect">
-            <a:avLst/>
-          </a:prstGeom>
-          <a:noFill/>
-          <a:ln/>
-        </p:spPr>
-        <p:txBody>
-          <a:bodyPr wrap="square" lIns="0" tIns="0" rIns="0" bIns="0" rtlCol="0" anchor="t"/>
-          <a:lstStyle/>
-          <a:p>
-            <a:pPr indent="0" marL="0">
-              <a:spcAft>
-                <a:spcPts val="200"/>
-              </a:spcAft>
-              <a:buNone/>
-            </a:pPr>
-            <a:r>
-              <a:rPr lang="en-US" sz="1400" dirty="0">
-                <a:solidFill>
-                  <a:srgbClr val="12202E"/>
-                </a:solidFill>
-                <a:latin typeface="Calibri" pitchFamily="34" charset="0"/>
-                <a:ea typeface="Calibri" pitchFamily="34" charset="-122"/>
-                <a:cs typeface="Calibri" pitchFamily="34" charset="-120"/>
-              </a:rPr>
-              <a:t>England 2,128,128</a:t>
-            </a:r>
-            <a:endParaRPr lang="en-US" sz="1400" dirty="0"/>
-          </a:p>
-          <a:p>
-            <a:pPr indent="0" marL="0">
-              <a:spcAft>
-                <a:spcPts val="200"/>
-              </a:spcAft>
-              <a:buNone/>
-            </a:pPr>
-            <a:r>
-              <a:rPr lang="en-US" sz="1400" dirty="0">
-                <a:solidFill>
-                  <a:srgbClr val="12202E"/>
-                </a:solidFill>
-                <a:latin typeface="Calibri" pitchFamily="34" charset="0"/>
-                <a:ea typeface="Calibri" pitchFamily="34" charset="-122"/>
-                <a:cs typeface="Calibri" pitchFamily="34" charset="-120"/>
-              </a:rPr>
-              <a:t>USA 407,138</a:t>
-            </a:r>
-            <a:endParaRPr lang="en-US" sz="1400" dirty="0"/>
-          </a:p>
-          <a:p>
-            <a:pPr indent="0" marL="0">
-              <a:spcAft>
-                <a:spcPts val="200"/>
-              </a:spcAft>
-              <a:buNone/>
-            </a:pPr>
-            <a:r>
-              <a:rPr lang="en-US" sz="1400" dirty="0">
-                <a:solidFill>
-                  <a:srgbClr val="12202E"/>
-                </a:solidFill>
-                <a:latin typeface="Calibri" pitchFamily="34" charset="0"/>
-                <a:ea typeface="Calibri" pitchFamily="34" charset="-122"/>
-                <a:cs typeface="Calibri" pitchFamily="34" charset="-120"/>
-              </a:rPr>
-              <a:t>Ireland 234,409</a:t>
-            </a:r>
-            <a:endParaRPr lang="en-US" sz="1400" dirty="0"/>
-          </a:p>
-          <a:p>
-            <a:pPr indent="0" marL="0">
-              <a:spcAft>
-                <a:spcPts val="200"/>
-              </a:spcAft>
-              <a:buNone/>
-            </a:pPr>
-            <a:r>
-              <a:rPr lang="en-US" sz="1400" dirty="0">
-                <a:solidFill>
-                  <a:srgbClr val="12202E"/>
-                </a:solidFill>
-                <a:latin typeface="Calibri" pitchFamily="34" charset="0"/>
-                <a:ea typeface="Calibri" pitchFamily="34" charset="-122"/>
-                <a:cs typeface="Calibri" pitchFamily="34" charset="-120"/>
-              </a:rPr>
-              <a:t>China 45,996</a:t>
-            </a:r>
-            <a:endParaRPr lang="en-US" sz="1400" dirty="0"/>
-          </a:p>
-          <a:p>
-            <a:pPr indent="0" marL="0">
-              <a:spcAft>
-                <a:spcPts val="200"/>
-              </a:spcAft>
-              <a:buNone/>
-            </a:pPr>
-            <a:r>
-              <a:rPr lang="en-US" sz="1400" dirty="0">
-                <a:solidFill>
-                  <a:srgbClr val="12202E"/>
-                </a:solidFill>
-                <a:latin typeface="Calibri" pitchFamily="34" charset="0"/>
-                <a:ea typeface="Calibri" pitchFamily="34" charset="-122"/>
-                <a:cs typeface="Calibri" pitchFamily="34" charset="-120"/>
-              </a:rPr>
-              <a:t>Canada 3,946</a:t>
-            </a:r>
-            <a:endParaRPr lang="en-US" sz="1400" dirty="0"/>
-          </a:p>
-        </p:txBody>
-      </p:sp>
-      <p:sp>
-        <p:nvSpPr>
-          <p:cNvPr id="21" name="Text 17"/>
-          <p:cNvSpPr txBox="1"/>
-          <p:nvPr/>
-        </p:nvSpPr>
-        <p:spPr>
-          <a:xfrm>
-            <a:off x="7909560" y="5029200"/>
-            <a:ext cx="3566160" cy="1005840"/>
-          </a:xfrm>
-          <a:prstGeom prst="rect">
-            <a:avLst/>
-          </a:prstGeom>
-          <a:noFill/>
-          <a:ln/>
-        </p:spPr>
-        <p:txBody>
-          <a:bodyPr wrap="square" lIns="0" tIns="0" rIns="0" bIns="0" rtlCol="0" anchor="t"/>
-          <a:lstStyle/>
-          <a:p>
-            <a:pPr indent="0" marL="0">
-              <a:buNone/>
-            </a:pPr>
-            <a:r>
-              <a:rPr lang="en-US" sz="1300" dirty="0">
+              <a:rPr lang="en-US" sz="1000" dirty="0">
                 <a:solidFill>
                   <a:srgbClr val="5B6B7A"/>
                 </a:solidFill>
@@ -10951,9 +10751,9 @@
                 <a:ea typeface="Calibri" pitchFamily="34" charset="-122"/>
                 <a:cs typeface="Calibri" pitchFamily="34" charset="-120"/>
               </a:rPr>
-              <a:t>Rivers are 65% of waterbodies. Results mainly reflect English rivers; Canada and China are too small to support country-level claims.</a:t>
-            </a:r>
-            <a:endParaRPr lang="en-US" sz="1300" dirty="0"/>
+              <a:t>Records per year (repo graph 03): coverage is sparse before ≈2000</a:t>
+            </a:r>
+            <a:endParaRPr lang="en-US" sz="1000" dirty="0"/>
           </a:p>
         </p:txBody>
       </p:sp>
@@ -11061,7 +10861,7 @@
                 <a:ea typeface="Cambria" pitchFamily="34" charset="-122"/>
                 <a:cs typeface="Cambria" pitchFamily="34" charset="-120"/>
               </a:rPr>
-              <a:t>Zero nulls — but 8,360 physically impossible readings were removed</a:t>
+              <a:t>8,360 impossible readings removed; zero nulls in the file, but one completeness question</a:t>
             </a:r>
             <a:endParaRPr lang="en-US" sz="3000" dirty="0"/>
           </a:p>
@@ -11451,84 +11251,6 @@
               <a:t>2,819,617 (99.704%)</a:t>
             </a:r>
             <a:endParaRPr lang="en-US" sz="1600" dirty="0"/>
-          </a:p>
-        </p:txBody>
-      </p:sp>
-      <p:sp>
-        <p:nvSpPr>
-          <p:cNvPr id="16" name="Shape 13"/>
-          <p:cNvSpPr/>
-          <p:nvPr/>
-        </p:nvSpPr>
-        <p:spPr>
-          <a:xfrm>
-            <a:off x="548640" y="4526280"/>
-            <a:ext cx="6675120" cy="1554480"/>
-          </a:xfrm>
-          <a:prstGeom prst="rect">
-            <a:avLst/>
-          </a:prstGeom>
-          <a:solidFill>
-            <a:srgbClr val="EAF4F6"/>
-          </a:solidFill>
-          <a:ln w="12700">
-            <a:solidFill>
-              <a:srgbClr val="EAF4F6"/>
-            </a:solidFill>
-            <a:prstDash val="solid"/>
-          </a:ln>
-        </p:spPr>
-      </p:sp>
-      <p:sp>
-        <p:nvSpPr>
-          <p:cNvPr id="17" name="Text 14"/>
-          <p:cNvSpPr txBox="1"/>
-          <p:nvPr/>
-        </p:nvSpPr>
-        <p:spPr>
-          <a:xfrm>
-            <a:off x="777240" y="4663440"/>
-            <a:ext cx="6217920" cy="1280160"/>
-          </a:xfrm>
-          <a:prstGeom prst="rect">
-            <a:avLst/>
-          </a:prstGeom>
-          <a:noFill/>
-          <a:ln/>
-        </p:spPr>
-        <p:txBody>
-          <a:bodyPr wrap="square" lIns="0" tIns="0" rIns="0" bIns="0" rtlCol="0" anchor="t"/>
-          <a:lstStyle/>
-          <a:p>
-            <a:pPr indent="0" marL="0">
-              <a:buNone/>
-            </a:pPr>
-            <a:r>
-              <a:rPr lang="en-US" sz="1400" b="1" dirty="0">
-                <a:solidFill>
-                  <a:srgbClr val="0E7C86"/>
-                </a:solidFill>
-                <a:latin typeface="Calibri" pitchFamily="34" charset="0"/>
-                <a:ea typeface="Calibri" pitchFamily="34" charset="-122"/>
-                <a:cs typeface="Calibri" pitchFamily="34" charset="-120"/>
-              </a:rPr>
-              <a:t>Missing vs implausible. </a:t>
-            </a:r>
-            <a:pPr indent="0" marL="0">
-              <a:buNone/>
-            </a:pPr>
-            <a:r>
-              <a:rPr lang="en-US" sz="1400" dirty="0">
-                <a:solidFill>
-                  <a:srgbClr val="12202E"/>
-                </a:solidFill>
-                <a:latin typeface="Calibri" pitchFamily="34" charset="0"/>
-                <a:ea typeface="Calibri" pitchFamily="34" charset="-122"/>
-                <a:cs typeface="Calibri" pitchFamily="34" charset="-120"/>
-              </a:rPr>
-              <a:t>The legacy claim of ~35% missing values was disproved: 0 nulls across the 14 source columns, so no imputation was used. Screening removes sensor artefacts (e.g. negative concentrations), not gaps.</a:t>
-            </a:r>
-            <a:endParaRPr lang="en-US" sz="1400" dirty="0"/>
           </a:p>
         </p:txBody>
       </p:sp>
@@ -13007,40 +12729,196 @@
       </p:graphicFrame>
       <p:sp>
         <p:nvSpPr>
+          <p:cNvPr id="17" name="Text 13"/>
+          <p:cNvSpPr txBox="1"/>
+          <p:nvPr/>
+        </p:nvSpPr>
+        <p:spPr>
+          <a:xfrm>
+            <a:off x="7589520" y="4572000"/>
+            <a:ext cx="4050792" cy="548640"/>
+          </a:xfrm>
+          <a:prstGeom prst="rect">
+            <a:avLst/>
+          </a:prstGeom>
+          <a:noFill/>
+          <a:ln/>
+        </p:spPr>
+        <p:txBody>
+          <a:bodyPr wrap="square" lIns="0" tIns="0" rIns="0" bIns="0" rtlCol="0" anchor="t"/>
+          <a:lstStyle/>
+          <a:p>
+            <a:pPr indent="0" marL="0">
+              <a:buNone/>
+            </a:pPr>
+            <a:r>
+              <a:rPr lang="en-US" sz="1200" dirty="0">
+                <a:solidFill>
+                  <a:srgbClr val="5B6B7A"/>
+                </a:solidFill>
+                <a:latin typeface="Calibri" pitchFamily="34" charset="0"/>
+                <a:ea typeface="Calibri" pitchFamily="34" charset="-122"/>
+                <a:cs typeface="Calibri" pitchFamily="34" charset="-120"/>
+              </a:rPr>
+              <a:t>Counts overlap; 8,360 is the unique union of violating rows (executed EDA notebook).</a:t>
+            </a:r>
+            <a:endParaRPr lang="en-US" sz="1200" dirty="0"/>
+          </a:p>
+        </p:txBody>
+      </p:sp>
+      <p:sp>
+        <p:nvSpPr>
+          <p:cNvPr id="18" name="Shape 14"/>
+          <p:cNvSpPr/>
+          <p:nvPr/>
+        </p:nvSpPr>
+        <p:spPr>
+          <a:xfrm>
+            <a:off x="548640" y="4434840"/>
+            <a:ext cx="6675120" cy="822960"/>
+          </a:xfrm>
+          <a:prstGeom prst="rect">
+            <a:avLst/>
+          </a:prstGeom>
+          <a:solidFill>
+            <a:srgbClr val="EAF4F6"/>
+          </a:solidFill>
+          <a:ln w="12700">
+            <a:solidFill>
+              <a:srgbClr val="EAF4F6"/>
+            </a:solidFill>
+            <a:prstDash val="solid"/>
+          </a:ln>
+        </p:spPr>
+      </p:sp>
+      <p:sp>
+        <p:nvSpPr>
           <p:cNvPr id="19" name="Text 15"/>
           <p:cNvSpPr txBox="1"/>
           <p:nvPr/>
         </p:nvSpPr>
         <p:spPr>
           <a:xfrm>
-            <a:off x="7589520" y="4617720"/>
-            <a:ext cx="4050792" cy="548640"/>
-          </a:xfrm>
-          <a:prstGeom prst="rect">
-            <a:avLst/>
-          </a:prstGeom>
-          <a:noFill/>
-          <a:ln/>
-        </p:spPr>
-        <p:txBody>
-          <a:bodyPr wrap="square" lIns="0" tIns="0" rIns="0" bIns="0" rtlCol="0" anchor="t"/>
-          <a:lstStyle/>
-          <a:p>
-            <a:pPr indent="0" marL="0">
-              <a:buNone/>
-            </a:pPr>
-            <a:r>
-              <a:rPr lang="en-US" sz="1200" dirty="0">
-                <a:solidFill>
-                  <a:srgbClr val="5B6B7A"/>
-                </a:solidFill>
-                <a:latin typeface="Calibri" pitchFamily="34" charset="0"/>
-                <a:ea typeface="Calibri" pitchFamily="34" charset="-122"/>
-                <a:cs typeface="Calibri" pitchFamily="34" charset="-120"/>
-              </a:rPr>
-              <a:t>Counts overlap; the 8,360 is the de-duplicated union of violating rows.</a:t>
-            </a:r>
-            <a:endParaRPr lang="en-US" sz="1200" dirty="0"/>
+            <a:off x="777240" y="4480560"/>
+            <a:ext cx="6263640" cy="731520"/>
+          </a:xfrm>
+          <a:prstGeom prst="rect">
+            <a:avLst/>
+          </a:prstGeom>
+          <a:noFill/>
+          <a:ln/>
+        </p:spPr>
+        <p:txBody>
+          <a:bodyPr wrap="square" lIns="0" tIns="0" rIns="0" bIns="0" rtlCol="0" anchor="ctr"/>
+          <a:lstStyle/>
+          <a:p>
+            <a:pPr indent="0" marL="0">
+              <a:buNone/>
+            </a:pPr>
+            <a:r>
+              <a:rPr lang="en-US" sz="1300" b="1" dirty="0">
+                <a:solidFill>
+                  <a:srgbClr val="0E7C86"/>
+                </a:solidFill>
+                <a:latin typeface="Calibri" pitchFamily="34" charset="0"/>
+                <a:ea typeface="Calibri" pitchFamily="34" charset="-122"/>
+                <a:cs typeface="Calibri" pitchFamily="34" charset="-120"/>
+              </a:rPr>
+              <a:t>Missing vs implausible. </a:t>
+            </a:r>
+            <a:pPr indent="0" marL="0">
+              <a:buNone/>
+            </a:pPr>
+            <a:r>
+              <a:rPr lang="en-US" sz="1300" dirty="0">
+                <a:solidFill>
+                  <a:srgbClr val="12202E"/>
+                </a:solidFill>
+                <a:latin typeface="Calibri" pitchFamily="34" charset="0"/>
+                <a:ea typeface="Calibri" pitchFamily="34" charset="-122"/>
+                <a:cs typeface="Calibri" pitchFamily="34" charset="-120"/>
+              </a:rPr>
+              <a:t>No imputation was applied in our pipeline; screening removes sensor artefacts (negative or out-of-range values), not gaps.</a:t>
+            </a:r>
+            <a:endParaRPr lang="en-US" sz="1300" dirty="0"/>
+          </a:p>
+        </p:txBody>
+      </p:sp>
+      <p:sp>
+        <p:nvSpPr>
+          <p:cNvPr id="20" name="Shape 16"/>
+          <p:cNvSpPr/>
+          <p:nvPr/>
+        </p:nvSpPr>
+        <p:spPr>
+          <a:xfrm>
+            <a:off x="548640" y="5440680"/>
+            <a:ext cx="11091672" cy="777240"/>
+          </a:xfrm>
+          <a:prstGeom prst="rect">
+            <a:avLst/>
+          </a:prstGeom>
+          <a:solidFill>
+            <a:srgbClr val="FFF3DC"/>
+          </a:solidFill>
+          <a:ln w="12700">
+            <a:solidFill>
+              <a:srgbClr val="FFF3DC"/>
+            </a:solidFill>
+            <a:prstDash val="solid"/>
+          </a:ln>
+        </p:spPr>
+      </p:sp>
+      <p:sp>
+        <p:nvSpPr>
+          <p:cNvPr id="21" name="Text 17"/>
+          <p:cNvSpPr txBox="1"/>
+          <p:nvPr/>
+        </p:nvSpPr>
+        <p:spPr>
+          <a:xfrm>
+            <a:off x="777240" y="5440680"/>
+            <a:ext cx="10698480" cy="777240"/>
+          </a:xfrm>
+          <a:prstGeom prst="rect">
+            <a:avLst/>
+          </a:prstGeom>
+          <a:noFill/>
+          <a:ln/>
+        </p:spPr>
+        <p:txBody>
+          <a:bodyPr wrap="square" lIns="0" tIns="0" rIns="0" bIns="0" rtlCol="0" anchor="ctr"/>
+          <a:lstStyle/>
+          <a:p>
+            <a:pPr indent="0" marL="0">
+              <a:buNone/>
+            </a:pPr>
+            <a:r>
+              <a:rPr lang="en-US" sz="1300" b="1" dirty="0">
+                <a:solidFill>
+                  <a:srgbClr val="D98A1F"/>
+                </a:solidFill>
+                <a:latin typeface="Calibri" pitchFamily="34" charset="0"/>
+                <a:ea typeface="Calibri" pitchFamily="34" charset="-122"/>
+                <a:cs typeface="Calibri" pitchFamily="34" charset="-120"/>
+              </a:rPr>
+              <a:t>Qualification  </a:t>
+            </a:r>
+            <a:pPr indent="0" marL="0">
+              <a:buNone/>
+            </a:pPr>
+            <a:r>
+              <a:rPr lang="en-US" sz="1300" dirty="0">
+                <a:solidFill>
+                  <a:srgbClr val="12202E"/>
+                </a:solidFill>
+                <a:latin typeface="Calibri" pitchFamily="34" charset="0"/>
+                <a:ea typeface="Calibri" pitchFamily="34" charset="-122"/>
+                <a:cs typeface="Calibri" pitchFamily="34" charset="-120"/>
+              </a:rPr>
+              <a:t>“0 nulls” describes the delivered file. Values cluster (BOD median 2.70, Q3 2.83) and repo graph 17 (earlier version) showed 26–34% missing, so upstream filling is possible and unverified.</a:t>
+            </a:r>
+            <a:endParaRPr lang="en-US" sz="1300" dirty="0"/>
           </a:p>
         </p:txBody>
       </p:sp>
@@ -13234,7 +13112,7 @@
       </p:sp>
       <p:pic>
         <p:nvPicPr>
-          <p:cNvPr id="7" name="Image 0" descr="/home/claude/w/img/r-001.png">    </p:cNvPr>
+          <p:cNvPr id="7" name="Image 0" descr="/home/claude/w/img2/07_EDA_do_temperature_saturation.png">    </p:cNvPr>
           <p:cNvPicPr>
             <a:picLocks noChangeAspect="1"/>
           </p:cNvPicPr>
@@ -13265,7 +13143,7 @@
         <p:spPr>
           <a:xfrm>
             <a:off x="548640" y="5166360"/>
-            <a:ext cx="5394960" cy="548640"/>
+            <a:ext cx="5394960" cy="457200"/>
           </a:xfrm>
           <a:prstGeom prst="rect">
             <a:avLst/>
@@ -13289,7 +13167,7 @@
                 <a:ea typeface="Calibri" pitchFamily="34" charset="-122"/>
                 <a:cs typeface="Calibri" pitchFamily="34" charset="-120"/>
               </a:rPr>
-              <a:t>DO vs temperature (80k sample): saturation falls as water warms (Henry’s law, Benson–Krause). Source: project report Fig. 2.</a:t>
+              <a:t>DO vs temperature (80k sample) with Benson–Krause saturation curves. Source: repository graphs/ folder (graph 07).</a:t>
             </a:r>
             <a:endParaRPr lang="en-US" sz="1200" dirty="0"/>
           </a:p>
@@ -13383,7 +13261,7 @@
                 <a:ea typeface="Calibri" pitchFamily="34" charset="-122"/>
                 <a:cs typeface="Calibri" pitchFamily="34" charset="-120"/>
               </a:rPr>
-              <a:t>A better Pearson r is not better out-of-sample prediction. log(1+x) is monotonic: rank correlation is unchanged and tree splits are invariant to it.</a:t>
+              <a:t>A better Pearson r is not better prediction. Orthophosphate’s Spearman ρ is −0.917 both raw and log(1+x): monotone transforms leave rank correlation, and tree splits, unchanged.</a:t>
             </a:r>
             <a:endParaRPr lang="en-US" sz="1300" dirty="0"/>
           </a:p>
@@ -13855,7 +13733,7 @@
                 <a:ea typeface="Calibri" pitchFamily="34" charset="-122"/>
                 <a:cs typeface="Calibri" pitchFamily="34" charset="-120"/>
               </a:rPr>
-              <a:t>Benson–Krause DO saturation/deficit, Redfield N:P, Emerson un-ionized NH₃, BOD:DO</a:t>
+              <a:t>Benson–Krause DO deficit and % saturation, Redfield-style N:P, Emerson un-ionised NH₃, BOD:DO, pH deviation, nitrate share</a:t>
             </a:r>
             <a:endParaRPr lang="en-US" sz="1200" dirty="0"/>
           </a:p>
@@ -13997,7 +13875,7 @@
                 <a:ea typeface="Calibri" pitchFamily="34" charset="-122"/>
                 <a:cs typeface="Calibri" pitchFamily="34" charset="-120"/>
               </a:rPr>
-              <a:t>Compress nutrient skew spanning orders of magnitude</a:t>
+              <a:t>Compress nutrient skew; help linear models, not trees</a:t>
             </a:r>
             <a:endParaRPr lang="en-US" sz="1200" dirty="0"/>
           </a:p>
@@ -14139,7 +14017,7 @@
                 <a:ea typeface="Calibri" pitchFamily="34" charset="-122"/>
                 <a:cs typeface="Calibri" pitchFamily="34" charset="-120"/>
               </a:rPr>
-              <a:t>Shift-1 lags and rolling-3 means, sorted by Area and Date; backward-looking only</a:t>
+              <a:t>Shift-1 lags and rolling-3 means within each Area, sorted by date; first record filled with global median</a:t>
             </a:r>
             <a:endParaRPr lang="en-US" sz="1200" dirty="0"/>
           </a:p>
@@ -14565,7 +14443,7 @@
                 <a:ea typeface="Calibri" pitchFamily="34" charset="-122"/>
                 <a:cs typeface="Calibri" pitchFamily="34" charset="-120"/>
               </a:rPr>
-              <a:t>Count of guideline violations across parameters</a:t>
+              <a:t>Count of six guideline checks computed from input columns only</a:t>
             </a:r>
             <a:endParaRPr lang="en-US" sz="1200" dirty="0"/>
           </a:p>
@@ -14668,7 +14546,7 @@
                 <a:ea typeface="Calibri" pitchFamily="34" charset="-122"/>
                 <a:cs typeface="Calibri" pitchFamily="34" charset="-120"/>
               </a:rPr>
-              <a:t>Station lag Spearman ρ(hist_ortho_lag1, WQI) = −0.78</a:t>
+              <a:t>ρ(hist_ortho_lag1, WQI) = −0.78 (Spearman, full data)</a:t>
             </a:r>
             <a:endParaRPr lang="en-US" sz="1200" dirty="0"/>
           </a:p>
@@ -14778,7 +14656,7 @@
                 <a:ea typeface="Cambria" pitchFamily="34" charset="-122"/>
                 <a:cs typeface="Cambria" pitchFamily="34" charset="-120"/>
               </a:rPr>
-              <a:t>Features are built before the split; scaling is fitted on training data only</a:t>
+              <a:t>Features are built before the split, so station history can cross partitions</a:t>
             </a:r>
             <a:endParaRPr lang="en-US" sz="3000" dirty="0"/>
           </a:p>
@@ -14920,7 +14798,7 @@
                 <a:ea typeface="Calibri" pitchFamily="34" charset="-122"/>
                 <a:cs typeface="Calibri" pitchFamily="34" charset="-120"/>
               </a:rPr>
-              <a:t>1  Ingest &amp; audit</a:t>
+              <a:t>1  Load cleaned data</a:t>
             </a:r>
             <a:endParaRPr lang="en-US" sz="1500" dirty="0"/>
           </a:p>
@@ -14959,7 +14837,7 @@
                 <a:ea typeface="Calibri" pitchFamily="34" charset="-122"/>
                 <a:cs typeface="Calibri" pitchFamily="34" charset="-120"/>
               </a:rPr>
-              <a:t>5 countries, 0 nulls</a:t>
+              <a:t>2,819,617 rows, 0 nulls</a:t>
             </a:r>
             <a:endParaRPr lang="en-US" sz="1200" dirty="0"/>
           </a:p>
@@ -15023,7 +14901,7 @@
                 <a:ea typeface="Calibri" pitchFamily="34" charset="-122"/>
                 <a:cs typeface="Calibri" pitchFamily="34" charset="-120"/>
               </a:rPr>
-              <a:t>2  Physical bounds</a:t>
+              <a:t>2  38 features</a:t>
             </a:r>
             <a:endParaRPr lang="en-US" sz="1500" dirty="0"/>
           </a:p>
@@ -15062,7 +14940,7 @@
                 <a:ea typeface="Calibri" pitchFamily="34" charset="-122"/>
                 <a:cs typeface="Calibri" pitchFamily="34" charset="-120"/>
               </a:rPr>
-              <a:t>−8,360 rows</a:t>
+              <a:t>lags built on full data</a:t>
             </a:r>
             <a:endParaRPr lang="en-US" sz="1200" dirty="0"/>
           </a:p>
@@ -15077,109 +14955,6 @@
         <p:spPr>
           <a:xfrm>
             <a:off x="6163056" y="1783080"/>
-            <a:ext cx="2606040" cy="1051560"/>
-          </a:xfrm>
-          <a:prstGeom prst="rect">
-            <a:avLst/>
-          </a:prstGeom>
-          <a:solidFill>
-            <a:srgbClr val="0B1F33"/>
-          </a:solidFill>
-          <a:ln w="12700">
-            <a:solidFill>
-              <a:srgbClr val="0B1F33"/>
-            </a:solidFill>
-            <a:prstDash val="solid"/>
-          </a:ln>
-        </p:spPr>
-      </p:sp>
-      <p:sp>
-        <p:nvSpPr>
-          <p:cNvPr id="14" name="Text 11"/>
-          <p:cNvSpPr txBox="1"/>
-          <p:nvPr/>
-        </p:nvSpPr>
-        <p:spPr>
-          <a:xfrm>
-            <a:off x="6300216" y="1892808"/>
-            <a:ext cx="2377440" cy="365760"/>
-          </a:xfrm>
-          <a:prstGeom prst="rect">
-            <a:avLst/>
-          </a:prstGeom>
-          <a:noFill/>
-          <a:ln/>
-        </p:spPr>
-        <p:txBody>
-          <a:bodyPr wrap="square" lIns="0" tIns="0" rIns="0" bIns="0" rtlCol="0" anchor="t"/>
-          <a:lstStyle/>
-          <a:p>
-            <a:pPr indent="0" marL="0">
-              <a:buNone/>
-            </a:pPr>
-            <a:r>
-              <a:rPr lang="en-US" sz="1500" b="1" dirty="0">
-                <a:solidFill>
-                  <a:srgbClr val="FFFFFF"/>
-                </a:solidFill>
-                <a:latin typeface="Calibri" pitchFamily="34" charset="0"/>
-                <a:ea typeface="Calibri" pitchFamily="34" charset="-122"/>
-                <a:cs typeface="Calibri" pitchFamily="34" charset="-120"/>
-              </a:rPr>
-              <a:t>3  38 features</a:t>
-            </a:r>
-            <a:endParaRPr lang="en-US" sz="1500" dirty="0"/>
-          </a:p>
-        </p:txBody>
-      </p:sp>
-      <p:sp>
-        <p:nvSpPr>
-          <p:cNvPr id="15" name="Text 12"/>
-          <p:cNvSpPr txBox="1"/>
-          <p:nvPr/>
-        </p:nvSpPr>
-        <p:spPr>
-          <a:xfrm>
-            <a:off x="6300216" y="2313432"/>
-            <a:ext cx="2377440" cy="411480"/>
-          </a:xfrm>
-          <a:prstGeom prst="rect">
-            <a:avLst/>
-          </a:prstGeom>
-          <a:noFill/>
-          <a:ln/>
-        </p:spPr>
-        <p:txBody>
-          <a:bodyPr wrap="square" lIns="0" tIns="0" rIns="0" bIns="0" rtlCol="0" anchor="t"/>
-          <a:lstStyle/>
-          <a:p>
-            <a:pPr indent="0" marL="0">
-              <a:buNone/>
-            </a:pPr>
-            <a:r>
-              <a:rPr lang="en-US" sz="1200" dirty="0">
-                <a:solidFill>
-                  <a:srgbClr val="FFFFFF"/>
-                </a:solidFill>
-                <a:latin typeface="Calibri" pitchFamily="34" charset="0"/>
-                <a:ea typeface="Calibri" pitchFamily="34" charset="-122"/>
-                <a:cs typeface="Calibri" pitchFamily="34" charset="-120"/>
-              </a:rPr>
-              <a:t>incl. station lags</a:t>
-            </a:r>
-            <a:endParaRPr lang="en-US" sz="1200" dirty="0"/>
-          </a:p>
-        </p:txBody>
-      </p:sp>
-      <p:sp>
-        <p:nvSpPr>
-          <p:cNvPr id="16" name="Shape 13"/>
-          <p:cNvSpPr/>
-          <p:nvPr/>
-        </p:nvSpPr>
-        <p:spPr>
-          <a:xfrm>
-            <a:off x="8970264" y="1783080"/>
             <a:ext cx="2606040" cy="1051560"/>
           </a:xfrm>
           <a:prstGeom prst="rect">
@@ -15198,13 +14973,13 @@
       </p:sp>
       <p:sp>
         <p:nvSpPr>
-          <p:cNvPr id="17" name="Text 14"/>
-          <p:cNvSpPr txBox="1"/>
-          <p:nvPr/>
-        </p:nvSpPr>
-        <p:spPr>
-          <a:xfrm>
-            <a:off x="9107424" y="1892808"/>
+          <p:cNvPr id="14" name="Text 11"/>
+          <p:cNvSpPr txBox="1"/>
+          <p:nvPr/>
+        </p:nvSpPr>
+        <p:spPr>
+          <a:xfrm>
+            <a:off x="6300216" y="1892808"/>
             <a:ext cx="2377440" cy="365760"/>
           </a:xfrm>
           <a:prstGeom prst="rect">
@@ -15229,7 +15004,7 @@
                 <a:ea typeface="Calibri" pitchFamily="34" charset="-122"/>
                 <a:cs typeface="Calibri" pitchFamily="34" charset="-120"/>
               </a:rPr>
-              <a:t>4  Target quarantine</a:t>
+              <a:t>3  Target check</a:t>
             </a:r>
             <a:endParaRPr lang="en-US" sz="1500" dirty="0"/>
           </a:p>
@@ -15237,13 +15012,13 @@
       </p:sp>
       <p:sp>
         <p:nvSpPr>
-          <p:cNvPr id="18" name="Text 15"/>
-          <p:cNvSpPr txBox="1"/>
-          <p:nvPr/>
-        </p:nvSpPr>
-        <p:spPr>
-          <a:xfrm>
-            <a:off x="9107424" y="2313432"/>
+          <p:cNvPr id="15" name="Text 12"/>
+          <p:cNvSpPr txBox="1"/>
+          <p:nvPr/>
+        </p:nvSpPr>
+        <p:spPr>
+          <a:xfrm>
+            <a:off x="6300216" y="2313432"/>
             <a:ext cx="2377440" cy="411480"/>
           </a:xfrm>
           <a:prstGeom prst="rect">
@@ -15268,7 +15043,7 @@
                 <a:ea typeface="Calibri" pitchFamily="34" charset="-122"/>
                 <a:cs typeface="Calibri" pitchFamily="34" charset="-120"/>
               </a:rPr>
-              <a:t>3 columns named in tests</a:t>
+              <a:t>targets not in features</a:t>
             </a:r>
             <a:endParaRPr lang="en-US" sz="1200" dirty="0"/>
           </a:p>
@@ -15276,13 +15051,13 @@
       </p:sp>
       <p:sp>
         <p:nvSpPr>
-          <p:cNvPr id="19" name="Shape 16"/>
+          <p:cNvPr id="16" name="Shape 13"/>
           <p:cNvSpPr/>
           <p:nvPr/>
         </p:nvSpPr>
         <p:spPr>
           <a:xfrm>
-            <a:off x="548640" y="3017520"/>
+            <a:off x="8970264" y="1783080"/>
             <a:ext cx="2606040" cy="1051560"/>
           </a:xfrm>
           <a:prstGeom prst="rect">
@@ -15301,13 +15076,13 @@
       </p:sp>
       <p:sp>
         <p:nvSpPr>
-          <p:cNvPr id="20" name="Text 17"/>
-          <p:cNvSpPr txBox="1"/>
-          <p:nvPr/>
-        </p:nvSpPr>
-        <p:spPr>
-          <a:xfrm>
-            <a:off x="685800" y="3127248"/>
+          <p:cNvPr id="17" name="Text 14"/>
+          <p:cNvSpPr txBox="1"/>
+          <p:nvPr/>
+        </p:nvSpPr>
+        <p:spPr>
+          <a:xfrm>
+            <a:off x="9107424" y="1892808"/>
             <a:ext cx="2377440" cy="365760"/>
           </a:xfrm>
           <a:prstGeom prst="rect">
@@ -15332,7 +15107,7 @@
                 <a:ea typeface="Calibri" pitchFamily="34" charset="-122"/>
                 <a:cs typeface="Calibri" pitchFamily="34" charset="-120"/>
               </a:rPr>
-              <a:t>5  Stratified 70/15/15</a:t>
+              <a:t>4  Stratified split</a:t>
             </a:r>
             <a:endParaRPr lang="en-US" sz="1500" dirty="0"/>
           </a:p>
@@ -15340,13 +15115,13 @@
       </p:sp>
       <p:sp>
         <p:nvSpPr>
-          <p:cNvPr id="21" name="Text 18"/>
-          <p:cNvSpPr txBox="1"/>
-          <p:nvPr/>
-        </p:nvSpPr>
-        <p:spPr>
-          <a:xfrm>
-            <a:off x="685800" y="3547872"/>
+          <p:cNvPr id="18" name="Text 15"/>
+          <p:cNvSpPr txBox="1"/>
+          <p:nvPr/>
+        </p:nvSpPr>
+        <p:spPr>
+          <a:xfrm>
+            <a:off x="9107424" y="2313432"/>
             <a:ext cx="2377440" cy="411480"/>
           </a:xfrm>
           <a:prstGeom prst="rect">
@@ -15379,13 +15154,13 @@
       </p:sp>
       <p:sp>
         <p:nvSpPr>
-          <p:cNvPr id="22" name="Shape 19"/>
+          <p:cNvPr id="19" name="Shape 16"/>
           <p:cNvSpPr/>
           <p:nvPr/>
         </p:nvSpPr>
         <p:spPr>
           <a:xfrm>
-            <a:off x="3355848" y="3017520"/>
+            <a:off x="548640" y="3017520"/>
             <a:ext cx="2606040" cy="1051560"/>
           </a:xfrm>
           <a:prstGeom prst="rect">
@@ -15404,13 +15179,13 @@
       </p:sp>
       <p:sp>
         <p:nvSpPr>
-          <p:cNvPr id="23" name="Text 20"/>
-          <p:cNvSpPr txBox="1"/>
-          <p:nvPr/>
-        </p:nvSpPr>
-        <p:spPr>
-          <a:xfrm>
-            <a:off x="3493008" y="3127248"/>
+          <p:cNvPr id="20" name="Text 17"/>
+          <p:cNvSpPr txBox="1"/>
+          <p:nvPr/>
+        </p:nvSpPr>
+        <p:spPr>
+          <a:xfrm>
+            <a:off x="685800" y="3127248"/>
             <a:ext cx="2377440" cy="365760"/>
           </a:xfrm>
           <a:prstGeom prst="rect">
@@ -15435,7 +15210,7 @@
                 <a:ea typeface="Calibri" pitchFamily="34" charset="-122"/>
                 <a:cs typeface="Calibri" pitchFamily="34" charset="-120"/>
               </a:rPr>
-              <a:t>6  Scale on train</a:t>
+              <a:t>5  Train RF + XGB</a:t>
             </a:r>
             <a:endParaRPr lang="en-US" sz="1500" dirty="0"/>
           </a:p>
@@ -15443,13 +15218,13 @@
       </p:sp>
       <p:sp>
         <p:nvSpPr>
-          <p:cNvPr id="24" name="Text 21"/>
-          <p:cNvSpPr txBox="1"/>
-          <p:nvPr/>
-        </p:nvSpPr>
-        <p:spPr>
-          <a:xfrm>
-            <a:off x="3493008" y="3547872"/>
+          <p:cNvPr id="21" name="Text 18"/>
+          <p:cNvSpPr txBox="1"/>
+          <p:nvPr/>
+        </p:nvSpPr>
+        <p:spPr>
+          <a:xfrm>
+            <a:off x="685800" y="3547872"/>
             <a:ext cx="2377440" cy="411480"/>
           </a:xfrm>
           <a:prstGeom prst="rect">
@@ -15474,7 +15249,7 @@
                 <a:ea typeface="Calibri" pitchFamily="34" charset="-122"/>
                 <a:cs typeface="Calibri" pitchFamily="34" charset="-120"/>
               </a:rPr>
-              <a:t>StandardScaler (MLP)</a:t>
+              <a:t>XGB early-stops on val</a:t>
             </a:r>
             <a:endParaRPr lang="en-US" sz="1200" dirty="0"/>
           </a:p>
@@ -15482,13 +15257,13 @@
       </p:sp>
       <p:sp>
         <p:nvSpPr>
-          <p:cNvPr id="25" name="Shape 22"/>
+          <p:cNvPr id="22" name="Shape 19"/>
           <p:cNvSpPr/>
           <p:nvPr/>
         </p:nvSpPr>
         <p:spPr>
           <a:xfrm>
-            <a:off x="6163056" y="3017520"/>
+            <a:off x="3355848" y="3017520"/>
             <a:ext cx="2606040" cy="1051560"/>
           </a:xfrm>
           <a:prstGeom prst="rect">
@@ -15507,13 +15282,13 @@
       </p:sp>
       <p:sp>
         <p:nvSpPr>
-          <p:cNvPr id="26" name="Text 23"/>
-          <p:cNvSpPr txBox="1"/>
-          <p:nvPr/>
-        </p:nvSpPr>
-        <p:spPr>
-          <a:xfrm>
-            <a:off x="6300216" y="3127248"/>
+          <p:cNvPr id="23" name="Text 20"/>
+          <p:cNvSpPr txBox="1"/>
+          <p:nvPr/>
+        </p:nvSpPr>
+        <p:spPr>
+          <a:xfrm>
+            <a:off x="3493008" y="3127248"/>
             <a:ext cx="2377440" cy="365760"/>
           </a:xfrm>
           <a:prstGeom prst="rect">
@@ -15538,7 +15313,7 @@
                 <a:ea typeface="Calibri" pitchFamily="34" charset="-122"/>
                 <a:cs typeface="Calibri" pitchFamily="34" charset="-120"/>
               </a:rPr>
-              <a:t>7  Train &amp; evaluate</a:t>
+              <a:t>6  Evaluate</a:t>
             </a:r>
             <a:endParaRPr lang="en-US" sz="1500" dirty="0"/>
           </a:p>
@@ -15546,13 +15321,13 @@
       </p:sp>
       <p:sp>
         <p:nvSpPr>
-          <p:cNvPr id="27" name="Text 24"/>
-          <p:cNvSpPr txBox="1"/>
-          <p:nvPr/>
-        </p:nvSpPr>
-        <p:spPr>
-          <a:xfrm>
-            <a:off x="6300216" y="3547872"/>
+          <p:cNvPr id="24" name="Text 21"/>
+          <p:cNvSpPr txBox="1"/>
+          <p:nvPr/>
+        </p:nvSpPr>
+        <p:spPr>
+          <a:xfrm>
+            <a:off x="3493008" y="3547872"/>
             <a:ext cx="2377440" cy="411480"/>
           </a:xfrm>
           <a:prstGeom prst="rect">
@@ -15577,7 +15352,7 @@
                 <a:ea typeface="Calibri" pitchFamily="34" charset="-122"/>
                 <a:cs typeface="Calibri" pitchFamily="34" charset="-120"/>
               </a:rPr>
-              <a:t>RF · XGB · MLP</a:t>
+              <a:t>validation only</a:t>
             </a:r>
             <a:endParaRPr lang="en-US" sz="1200" dirty="0"/>
           </a:p>
@@ -15585,13 +15360,13 @@
       </p:sp>
       <p:sp>
         <p:nvSpPr>
-          <p:cNvPr id="28" name="Shape 25"/>
+          <p:cNvPr id="25" name="Shape 22"/>
           <p:cNvSpPr/>
           <p:nvPr/>
         </p:nvSpPr>
         <p:spPr>
           <a:xfrm>
-            <a:off x="8970264" y="3017520"/>
+            <a:off x="6163056" y="3017520"/>
             <a:ext cx="2606040" cy="1051560"/>
           </a:xfrm>
           <a:prstGeom prst="rect">
@@ -15610,6 +15385,109 @@
       </p:sp>
       <p:sp>
         <p:nvSpPr>
+          <p:cNvPr id="26" name="Text 23"/>
+          <p:cNvSpPr txBox="1"/>
+          <p:nvPr/>
+        </p:nvSpPr>
+        <p:spPr>
+          <a:xfrm>
+            <a:off x="6300216" y="3127248"/>
+            <a:ext cx="2377440" cy="365760"/>
+          </a:xfrm>
+          <a:prstGeom prst="rect">
+            <a:avLst/>
+          </a:prstGeom>
+          <a:noFill/>
+          <a:ln/>
+        </p:spPr>
+        <p:txBody>
+          <a:bodyPr wrap="square" lIns="0" tIns="0" rIns="0" bIns="0" rtlCol="0" anchor="t"/>
+          <a:lstStyle/>
+          <a:p>
+            <a:pPr indent="0" marL="0">
+              <a:buNone/>
+            </a:pPr>
+            <a:r>
+              <a:rPr lang="en-US" sz="1500" b="1" dirty="0">
+                <a:solidFill>
+                  <a:srgbClr val="FFFFFF"/>
+                </a:solidFill>
+                <a:latin typeface="Calibri" pitchFamily="34" charset="0"/>
+                <a:ea typeface="Calibri" pitchFamily="34" charset="-122"/>
+                <a:cs typeface="Calibri" pitchFamily="34" charset="-120"/>
+              </a:rPr>
+              <a:t>7  Importance</a:t>
+            </a:r>
+            <a:endParaRPr lang="en-US" sz="1500" dirty="0"/>
+          </a:p>
+        </p:txBody>
+      </p:sp>
+      <p:sp>
+        <p:nvSpPr>
+          <p:cNvPr id="27" name="Text 24"/>
+          <p:cNvSpPr txBox="1"/>
+          <p:nvPr/>
+        </p:nvSpPr>
+        <p:spPr>
+          <a:xfrm>
+            <a:off x="6300216" y="3547872"/>
+            <a:ext cx="2377440" cy="411480"/>
+          </a:xfrm>
+          <a:prstGeom prst="rect">
+            <a:avLst/>
+          </a:prstGeom>
+          <a:noFill/>
+          <a:ln/>
+        </p:spPr>
+        <p:txBody>
+          <a:bodyPr wrap="square" lIns="0" tIns="0" rIns="0" bIns="0" rtlCol="0" anchor="t"/>
+          <a:lstStyle/>
+          <a:p>
+            <a:pPr indent="0" marL="0">
+              <a:buNone/>
+            </a:pPr>
+            <a:r>
+              <a:rPr lang="en-US" sz="1200" dirty="0">
+                <a:solidFill>
+                  <a:srgbClr val="FFFFFF"/>
+                </a:solidFill>
+                <a:latin typeface="Calibri" pitchFamily="34" charset="0"/>
+                <a:ea typeface="Calibri" pitchFamily="34" charset="-122"/>
+                <a:cs typeface="Calibri" pitchFamily="34" charset="-120"/>
+              </a:rPr>
+              <a:t>built-in + SHAP (250 rows)</a:t>
+            </a:r>
+            <a:endParaRPr lang="en-US" sz="1200" dirty="0"/>
+          </a:p>
+        </p:txBody>
+      </p:sp>
+      <p:sp>
+        <p:nvSpPr>
+          <p:cNvPr id="28" name="Shape 25"/>
+          <p:cNvSpPr/>
+          <p:nvPr/>
+        </p:nvSpPr>
+        <p:spPr>
+          <a:xfrm>
+            <a:off x="8970264" y="3017520"/>
+            <a:ext cx="2606040" cy="1051560"/>
+          </a:xfrm>
+          <a:prstGeom prst="rect">
+            <a:avLst/>
+          </a:prstGeom>
+          <a:solidFill>
+            <a:srgbClr val="5B6B7A"/>
+          </a:solidFill>
+          <a:ln w="12700">
+            <a:solidFill>
+              <a:srgbClr val="5B6B7A"/>
+            </a:solidFill>
+            <a:prstDash val="solid"/>
+          </a:ln>
+        </p:spPr>
+      </p:sp>
+      <p:sp>
+        <p:nvSpPr>
           <p:cNvPr id="29" name="Text 26"/>
           <p:cNvSpPr txBox="1"/>
           <p:nvPr/>
@@ -15641,7 +15519,7 @@
                 <a:ea typeface="Calibri" pitchFamily="34" charset="-122"/>
                 <a:cs typeface="Calibri" pitchFamily="34" charset="-120"/>
               </a:rPr>
-              <a:t>8  TreeSHAP</a:t>
+              <a:t>8  Test set</a:t>
             </a:r>
             <a:endParaRPr lang="en-US" sz="1500" dirty="0"/>
           </a:p>
@@ -15680,7 +15558,7 @@
                 <a:ea typeface="Calibri" pitchFamily="34" charset="-122"/>
                 <a:cs typeface="Calibri" pitchFamily="34" charset="-120"/>
               </a:rPr>
-              <a:t>XGBoost, validation</a:t>
+              <a:t>held out, not yet scored</a:t>
             </a:r>
             <a:endParaRPr lang="en-US" sz="1200" dirty="0"/>
           </a:p>
@@ -15719,7 +15597,7 @@
                 <a:ea typeface="Calibri" pitchFamily="34" charset="-122"/>
                 <a:cs typeface="Calibri" pitchFamily="34" charset="-120"/>
               </a:rPr>
-              <a:t>Navy = before split · Amber = split/leakage-sensitive · Teal = fitted or evaluated after split</a:t>
+              <a:t>Navy = before split · Amber = leakage-sensitive · Teal = after split · Grey = not yet done</a:t>
             </a:r>
             <a:endParaRPr lang="en-US" sz="1100" dirty="0"/>
           </a:p>
@@ -15734,7 +15612,7 @@
         <p:spPr>
           <a:xfrm>
             <a:off x="548640" y="4663440"/>
-            <a:ext cx="11091672" cy="1417320"/>
+            <a:ext cx="11091672" cy="1508760"/>
           </a:xfrm>
           <a:prstGeom prst="rect">
             <a:avLst/>
@@ -15798,7 +15676,7 @@
         <p:spPr>
           <a:xfrm>
             <a:off x="777240" y="5120640"/>
-            <a:ext cx="5029200" cy="868680"/>
+            <a:ext cx="5029200" cy="914400"/>
           </a:xfrm>
           <a:prstGeom prst="rect">
             <a:avLst/>
@@ -15822,7 +15700,7 @@
                 <a:ea typeface="Calibri" pitchFamily="34" charset="-122"/>
                 <a:cs typeface="Calibri" pitchFamily="34" charset="-120"/>
               </a:rPr>
-              <a:t>12 tests in 4 modules: features 4 · models 3 · leakage 2 · metrics 3. Reported 100% pass in 1.65 s (not re-run in this review).</a:t>
+              <a:t>12 test functions: features 4 · leakage 2 · metrics 3 · models 3. Reported 100% pass in 1.65 s (not re-run here).</a:t>
             </a:r>
             <a:endParaRPr lang="en-US" sz="1300" dirty="0"/>
           </a:p>
@@ -15837,7 +15715,7 @@
         <p:spPr>
           <a:xfrm>
             <a:off x="6126480" y="4754880"/>
-            <a:ext cx="5349240" cy="1280160"/>
+            <a:ext cx="5349240" cy="1371600"/>
           </a:xfrm>
           <a:prstGeom prst="rect">
             <a:avLst/>
@@ -15875,7 +15753,7 @@
                 <a:ea typeface="Calibri" pitchFamily="34" charset="-122"/>
                 <a:cs typeface="Calibri" pitchFamily="34" charset="-120"/>
               </a:rPr>
-              <a:t>bound filtering, no look-ahead in lags, named target columns absent from X, metric maths, checkpoint loading.</a:t>
+              <a:t>bound filtering, log1p, shift-1 lags per station, targets absent from X and from the 38-feature list, metric maths, model loading.</a:t>
             </a:r>
             <a:endParaRPr lang="en-US" sz="1300" dirty="0"/>
           </a:p>
@@ -15906,7 +15784,7 @@
                 <a:ea typeface="Calibri" pitchFamily="34" charset="-122"/>
                 <a:cs typeface="Calibri" pitchFamily="34" charset="-120"/>
               </a:rPr>
-              <a:t>that features are free of target-derived information or that scores generalise.</a:t>
+              <a:t>that scores generalise to new stations or dates.</a:t>
             </a:r>
             <a:endParaRPr lang="en-US" sz="1300" dirty="0"/>
           </a:p>
@@ -16016,7 +15894,7 @@
                 <a:ea typeface="Cambria" pitchFamily="34" charset="-122"/>
                 <a:cs typeface="Cambria" pitchFamily="34" charset="-120"/>
               </a:rPr>
-              <a:t>Four regressors, one random stratified split, and conflicting hyper-parameter records</a:t>
+              <a:t>Three regressors on one random stratified split, with the settings taken from the training notebook</a:t>
             </a:r>
             <a:endParaRPr lang="en-US" sz="3000" dirty="0"/>
           </a:p>
@@ -16325,7 +16203,7 @@
                 <a:ea typeface="Calibri" pitchFamily="34" charset="-122"/>
                 <a:cs typeface="Calibri" pitchFamily="34" charset="-120"/>
               </a:rPr>
-              <a:t>Random, class-stratified by WQI tier · no station or time hold-out · reported metrics are on validation; test results are not reported</a:t>
+              <a:t>Random, stratified by WQI tier, seed 42 · no station or time hold-out · reported metrics are on validation; the test set has not been scored</a:t>
             </a:r>
             <a:endParaRPr lang="en-US" sz="1200" dirty="0"/>
           </a:p>
@@ -16404,7 +16282,7 @@
         <p:spPr>
           <a:xfrm>
             <a:off x="731520" y="3611880"/>
-            <a:ext cx="2331720" cy="1371600"/>
+            <a:ext cx="2331720" cy="1463040"/>
           </a:xfrm>
           <a:prstGeom prst="rect">
             <a:avLst/>
@@ -16436,7 +16314,46 @@
       </p:sp>
       <p:sp>
         <p:nvSpPr>
-          <p:cNvPr id="17" name="Shape 14"/>
+          <p:cNvPr id="17" name="Text 14"/>
+          <p:cNvSpPr txBox="1"/>
+          <p:nvPr/>
+        </p:nvSpPr>
+        <p:spPr>
+          <a:xfrm>
+            <a:off x="731520" y="5120640"/>
+            <a:ext cx="2331720" cy="822960"/>
+          </a:xfrm>
+          <a:prstGeom prst="rect">
+            <a:avLst/>
+          </a:prstGeom>
+          <a:noFill/>
+          <a:ln/>
+        </p:spPr>
+        <p:txBody>
+          <a:bodyPr wrap="square" lIns="0" tIns="0" rIns="0" bIns="0" rtlCol="0" anchor="t"/>
+          <a:lstStyle/>
+          <a:p>
+            <a:pPr indent="0" marL="0">
+              <a:buNone/>
+            </a:pPr>
+            <a:r>
+              <a:rPr lang="en-US" sz="1200" b="1" dirty="0">
+                <a:solidFill>
+                  <a:srgbClr val="5B6B7A"/>
+                </a:solidFill>
+                <a:latin typeface="Calibri" pitchFamily="34" charset="0"/>
+                <a:ea typeface="Calibri" pitchFamily="34" charset="-122"/>
+                <a:cs typeface="Calibri" pitchFamily="34" charset="-120"/>
+              </a:rPr>
+              <a:t>No fitting beyond the mean</a:t>
+            </a:r>
+            <a:endParaRPr lang="en-US" sz="1200" dirty="0"/>
+          </a:p>
+        </p:txBody>
+      </p:sp>
+      <p:sp>
+        <p:nvSpPr>
+          <p:cNvPr id="18" name="Shape 15"/>
           <p:cNvSpPr/>
           <p:nvPr/>
         </p:nvSpPr>
@@ -16461,7 +16378,7 @@
       </p:sp>
       <p:sp>
         <p:nvSpPr>
-          <p:cNvPr id="18" name="Text 15"/>
+          <p:cNvPr id="19" name="Text 16"/>
           <p:cNvSpPr txBox="1"/>
           <p:nvPr/>
         </p:nvSpPr>
@@ -16500,14 +16417,14 @@
       </p:sp>
       <p:sp>
         <p:nvSpPr>
-          <p:cNvPr id="19" name="Text 16"/>
+          <p:cNvPr id="20" name="Text 17"/>
           <p:cNvSpPr txBox="1"/>
           <p:nvPr/>
         </p:nvSpPr>
         <p:spPr>
           <a:xfrm>
             <a:off x="3538728" y="3611880"/>
-            <a:ext cx="2331720" cy="1371600"/>
+            <a:ext cx="2331720" cy="1463040"/>
           </a:xfrm>
           <a:prstGeom prst="rect">
             <a:avLst/>
@@ -16531,7 +16448,7 @@
                 <a:ea typeface="Calibri" pitchFamily="34" charset="-122"/>
                 <a:cs typeface="Calibri" pitchFamily="34" charset="-120"/>
               </a:rPr>
-              <a:t>Bagged, de-correlated trees; max_features = √p.</a:t>
+              <a:t>30 trees, max depth 14, min leaf 5, all 38 features considered per split, seed 42.</a:t>
             </a:r>
             <a:endParaRPr lang="en-US" sz="1300" dirty="0"/>
           </a:p>
@@ -16539,14 +16456,14 @@
       </p:sp>
       <p:sp>
         <p:nvSpPr>
-          <p:cNvPr id="20" name="Text 17"/>
-          <p:cNvSpPr txBox="1"/>
-          <p:nvPr/>
-        </p:nvSpPr>
-        <p:spPr>
-          <a:xfrm>
-            <a:off x="3538728" y="5074920"/>
-            <a:ext cx="2331720" cy="868680"/>
+          <p:cNvPr id="21" name="Text 18"/>
+          <p:cNvSpPr txBox="1"/>
+          <p:nvPr/>
+        </p:nvSpPr>
+        <p:spPr>
+          <a:xfrm>
+            <a:off x="3538728" y="5120640"/>
+            <a:ext cx="2331720" cy="822960"/>
           </a:xfrm>
           <a:prstGeom prst="rect">
             <a:avLst/>
@@ -16564,13 +16481,13 @@
             <a:r>
               <a:rPr lang="en-US" sz="1200" b="1" dirty="0">
                 <a:solidFill>
-                  <a:srgbClr val="D98A1F"/>
-                </a:solidFill>
-                <a:latin typeface="Calibri" pitchFamily="34" charset="0"/>
-                <a:ea typeface="Calibri" pitchFamily="34" charset="-122"/>
-                <a:cs typeface="Calibri" pitchFamily="34" charset="-120"/>
-              </a:rPr>
-              <a:t>Config conflict: 100 trees/depth 20 vs 30 trees/depth 14</a:t>
+                  <a:srgbClr val="5B6B7A"/>
+                </a:solidFill>
+                <a:latin typeface="Calibri" pitchFamily="34" charset="0"/>
+                <a:ea typeface="Calibri" pitchFamily="34" charset="-122"/>
+                <a:cs typeface="Calibri" pitchFamily="34" charset="-120"/>
+              </a:rPr>
+              <a:t>Notebook = saved model</a:t>
             </a:r>
             <a:endParaRPr lang="en-US" sz="1200" dirty="0"/>
           </a:p>
@@ -16578,7 +16495,7 @@
       </p:sp>
       <p:sp>
         <p:nvSpPr>
-          <p:cNvPr id="21" name="Shape 18"/>
+          <p:cNvPr id="22" name="Shape 19"/>
           <p:cNvSpPr/>
           <p:nvPr/>
         </p:nvSpPr>
@@ -16603,7 +16520,7 @@
       </p:sp>
       <p:sp>
         <p:nvSpPr>
-          <p:cNvPr id="22" name="Text 19"/>
+          <p:cNvPr id="23" name="Text 20"/>
           <p:cNvSpPr txBox="1"/>
           <p:nvPr/>
         </p:nvSpPr>
@@ -16642,14 +16559,14 @@
       </p:sp>
       <p:sp>
         <p:nvSpPr>
-          <p:cNvPr id="23" name="Text 20"/>
+          <p:cNvPr id="24" name="Text 21"/>
           <p:cNvSpPr txBox="1"/>
           <p:nvPr/>
         </p:nvSpPr>
         <p:spPr>
           <a:xfrm>
             <a:off x="6345936" y="3611880"/>
-            <a:ext cx="2331720" cy="1371600"/>
+            <a:ext cx="2331720" cy="1463040"/>
           </a:xfrm>
           <a:prstGeom prst="rect">
             <a:avLst/>
@@ -16673,7 +16590,7 @@
                 <a:ea typeface="Calibri" pitchFamily="34" charset="-122"/>
                 <a:cs typeface="Calibri" pitchFamily="34" charset="-120"/>
               </a:rPr>
-              <a:t>Boosted trees, squared-error objective.</a:t>
+              <a:t>≤150 rounds, depth 6, η 0.08, subsample 0.8, colsample 0.8; early stopping (20) on validation; best round 149.</a:t>
             </a:r>
             <a:endParaRPr lang="en-US" sz="1300" dirty="0"/>
           </a:p>
@@ -16681,14 +16598,14 @@
       </p:sp>
       <p:sp>
         <p:nvSpPr>
-          <p:cNvPr id="24" name="Text 21"/>
-          <p:cNvSpPr txBox="1"/>
-          <p:nvPr/>
-        </p:nvSpPr>
-        <p:spPr>
-          <a:xfrm>
-            <a:off x="6345936" y="5074920"/>
-            <a:ext cx="2331720" cy="868680"/>
+          <p:cNvPr id="25" name="Text 22"/>
+          <p:cNvSpPr txBox="1"/>
+          <p:nvPr/>
+        </p:nvSpPr>
+        <p:spPr>
+          <a:xfrm>
+            <a:off x="6345936" y="5120640"/>
+            <a:ext cx="2331720" cy="822960"/>
           </a:xfrm>
           <a:prstGeom prst="rect">
             <a:avLst/>
@@ -16706,13 +16623,13 @@
             <a:r>
               <a:rPr lang="en-US" sz="1200" b="1" dirty="0">
                 <a:solidFill>
-                  <a:srgbClr val="D98A1F"/>
-                </a:solidFill>
-                <a:latin typeface="Calibri" pitchFamily="34" charset="0"/>
-                <a:ea typeface="Calibri" pitchFamily="34" charset="-122"/>
-                <a:cs typeface="Calibri" pitchFamily="34" charset="-120"/>
-              </a:rPr>
-              <a:t>Config conflict: 300 rounds/η 0.05/depth 8 vs 150/η 0.08/depth 6</a:t>
+                  <a:srgbClr val="5B6B7A"/>
+                </a:solidFill>
+                <a:latin typeface="Calibri" pitchFamily="34" charset="0"/>
+                <a:ea typeface="Calibri" pitchFamily="34" charset="-122"/>
+                <a:cs typeface="Calibri" pitchFamily="34" charset="-120"/>
+              </a:rPr>
+              <a:t>Early stopping uses the validation set</a:t>
             </a:r>
             <a:endParaRPr lang="en-US" sz="1200" dirty="0"/>
           </a:p>
@@ -16720,7 +16637,7 @@
       </p:sp>
       <p:sp>
         <p:nvSpPr>
-          <p:cNvPr id="25" name="Shape 22"/>
+          <p:cNvPr id="26" name="Shape 23"/>
           <p:cNvSpPr/>
           <p:nvPr/>
         </p:nvSpPr>
@@ -16733,11 +16650,11 @@
             <a:avLst/>
           </a:prstGeom>
           <a:solidFill>
-            <a:srgbClr val="EAF4F6"/>
+            <a:srgbClr val="FFF3DC"/>
           </a:solidFill>
           <a:ln w="12700">
             <a:solidFill>
-              <a:srgbClr val="EAF4F6"/>
+              <a:srgbClr val="FFF3DC"/>
             </a:solidFill>
             <a:prstDash val="solid"/>
           </a:ln>
@@ -16745,7 +16662,7 @@
       </p:sp>
       <p:sp>
         <p:nvSpPr>
-          <p:cNvPr id="26" name="Text 23"/>
+          <p:cNvPr id="27" name="Text 24"/>
           <p:cNvSpPr txBox="1"/>
           <p:nvPr/>
         </p:nvSpPr>
@@ -16770,13 +16687,13 @@
             <a:r>
               <a:rPr lang="en-US" sz="1800" b="1" dirty="0">
                 <a:solidFill>
-                  <a:srgbClr val="0E7C86"/>
+                  <a:srgbClr val="D98A1F"/>
                 </a:solidFill>
                 <a:latin typeface="Cambria" pitchFamily="34" charset="0"/>
                 <a:ea typeface="Cambria" pitchFamily="34" charset="-122"/>
                 <a:cs typeface="Cambria" pitchFamily="34" charset="-120"/>
               </a:rPr>
-              <a:t>Dual-head MLP</a:t>
+              <a:t>Neural network</a:t>
             </a:r>
             <a:endParaRPr lang="en-US" sz="1800" dirty="0"/>
           </a:p>
@@ -16784,14 +16701,14 @@
       </p:sp>
       <p:sp>
         <p:nvSpPr>
-          <p:cNvPr id="27" name="Text 24"/>
+          <p:cNvPr id="28" name="Text 25"/>
           <p:cNvSpPr txBox="1"/>
           <p:nvPr/>
         </p:nvSpPr>
         <p:spPr>
           <a:xfrm>
             <a:off x="9153144" y="3611880"/>
-            <a:ext cx="2331720" cy="1371600"/>
+            <a:ext cx="2331720" cy="1463040"/>
           </a:xfrm>
           <a:prstGeom prst="rect">
             <a:avLst/>
@@ -16815,7 +16732,7 @@
                 <a:ea typeface="Calibri" pitchFamily="34" charset="-122"/>
                 <a:cs typeface="Calibri" pitchFamily="34" charset="-120"/>
               </a:rPr>
-              <a:t>38→256→128→64, then regression head (Smooth-L1) and 5-class head (weighted CE); AdamW, 8 epochs.</a:t>
+              <a:t>Not implemented in this repo version. Planned for Phase 2 (multi-task MLP).</a:t>
             </a:r>
             <a:endParaRPr lang="en-US" sz="1300" dirty="0"/>
           </a:p>
@@ -16823,14 +16740,14 @@
       </p:sp>
       <p:sp>
         <p:nvSpPr>
-          <p:cNvPr id="28" name="Text 25"/>
-          <p:cNvSpPr txBox="1"/>
-          <p:nvPr/>
-        </p:nvSpPr>
-        <p:spPr>
-          <a:xfrm>
-            <a:off x="9153144" y="5074920"/>
-            <a:ext cx="2331720" cy="868680"/>
+          <p:cNvPr id="29" name="Text 26"/>
+          <p:cNvSpPr txBox="1"/>
+          <p:nvPr/>
+        </p:nvSpPr>
+        <p:spPr>
+          <a:xfrm>
+            <a:off x="9153144" y="5120640"/>
+            <a:ext cx="2331720" cy="822960"/>
           </a:xfrm>
           <a:prstGeom prst="rect">
             <a:avLst/>
@@ -16854,7 +16771,7 @@
                 <a:ea typeface="Calibri" pitchFamily="34" charset="-122"/>
                 <a:cs typeface="Calibri" pitchFamily="34" charset="-120"/>
               </a:rPr>
-              <a:t>Reported in repo technical report</a:t>
+              <a:t>No results claimed</a:t>
             </a:r>
             <a:endParaRPr lang="en-US" sz="1200" dirty="0"/>
           </a:p>

</xml_diff>

<commit_message>
update final project report, presentation and add QA summary documentation
</commit_message>
<xml_diff>
--- a/final/Project_Presentation_Final.pptx
+++ b/final/Project_Presentation_Final.pptx
@@ -1944,7 +1944,7 @@
           <a:p>
             <a:r>
               <a:rPr lang="en-US" dirty="0"/>
-              <a:t>RF numbers are identical in model_comparison.csv and training_history.csv (MAE 0.0521, RMSE 0.2081, R2 0.99986; train MAE 0.047, so a small train-val gap). XGBoost has two versions in the repo: model_comparison.csv (from tree_val_predictions.parquet) gives MAE 0.1375, RMSE 0.3740, R2 0.99955, which is what the written report used; the training notebook and the saved model's recorded best_score give MAE 0.1611, RMSE 0.4372, R2 0.99939. The saved predictions file therefore does not match the saved model; re-run notebooks 03 and 04 to settle this. Conclusions are unchanged. Latency numbers are omitted: no timing code or hardware is documented.</a:t>
+              <a:t>RF numbers are identical in model_comparison.csv and training_history.csv (MAE 0.0521, RMSE 0.2081, R2 0.99986; train MAE 0.047, so a small train-val gap). XGBoost has two sets of numbers in the repo: model_comparison.csv (from tree_val_predictions.parquet) gives MAE 0.1375, RMSE 0.3740, R2 0.99955, which is what the written report used; the training notebook and the saved model's recorded best_score give MAE 0.1611, RMSE 0.4372, R2 0.99939. The saved predictions file therefore does not match the saved model; re-run notebooks 03 and 04 to settle this. Conclusions are unchanged. Latency numbers are omitted: no timing code or hardware is documented.</a:t>
             </a:r>
             <a:endParaRPr lang="en-US" dirty="0"/>
           </a:p>
@@ -2032,7 +2032,7 @@
           <a:p>
             <a:r>
               <a:rPr lang="en-US" dirty="0"/>
-              <a:t>Updated after reading the code. (1) The target is supplied with the data and is computed from the same eight parameters; the repo's own evaluation notebook concludes the scores measure reconstruction of the index from same-time measurements. (2) exceedance_counter: we previously treated it as a leakage risk. The code shows it uses six input columns and its own thresholds, not the target or F1-F3 (F1-F3 are not columns in the dataset). It is a legitimate, if redundant, feature. An ablation without it has not been run. (3) The split is random, station lags are built on the full data, XGBoost early-stops on validation, and the test set is unscored. Nothing here shows leakage in a pipeline sense; it shows the evaluation cannot support forecasting claims.</a:t>
+              <a:t>Updated after reading the code. (1) The target is supplied with the data and is computed from the same eight parameters; the repo's own evaluation notebook concludes the scores measure reconstruction of the index from same-time measurements. (2) exceedance_counter: the code shows it uses six input columns and its own thresholds, not the target or F1-F3 (F1-F3 are not columns in the dataset). It is a legitimate, if redundant, feature. An ablation without it has not been run. (3) The split is random, station lags are built on the full data, XGBoost early-stops on validation, and the test set is unscored. Nothing here shows leakage in a pipeline sense; it shows the evaluation cannot support forecasting claims.</a:t>
             </a:r>
             <a:endParaRPr lang="en-US" dirty="0"/>
           </a:p>
@@ -2120,7 +2120,7 @@
           <a:p>
             <a:r>
               <a:rPr lang="en-US" dirty="0"/>
-              <a:t>Random Forest values: built-in impurity importance read from the saved joblib. XGBoost values: average-gain share computed from the saved xgboost_model.json trees. Orthophosphate plus its log variant: 88.5% (RF) and 76.4% (XGBoost). hist_ortho_lag1 is about 0 in RF and 1.5% (rank 6) in XGBoost, so the older claim that it ranks second is wrong. country_code is about 0 in both. The SHAP beeswarm (repo graph 16) was computed on 250 validation rows; mean |SHAP| for orthophosphate is about 8.3 index points. A plausible, unverified reason for orthophosphate's weight: the guideline sits close to its median value.</a:t>
+              <a:t>Random Forest values: built-in impurity importance read from the saved joblib. XGBoost values: average-gain share computed from the saved xgboost_model.json trees. Orthophosphate plus its log variant: 88.5% (RF) and 76.4% (XGBoost). hist_ortho_lag1 is about 0 in RF and 1.5% (rank 6) in XGBoost, so the claim that it ranks second is not supported. country_code is about 0 in both. The SHAP beeswarm (repo graph 16) was computed on 250 validation rows; mean |SHAP| for orthophosphate is about 8.3 index points. A plausible, unverified reason for orthophosphate's weight: the guideline sits close to its median value.</a:t>
             </a:r>
             <a:endParaRPr lang="en-US" dirty="0"/>
           </a:p>
@@ -2208,7 +2208,7 @@
           <a:p>
             <a:r>
               <a:rPr lang="en-US" dirty="0"/>
-              <a:t>Be precise about status. Deep learning: the repo has no neural-network code, notebook or results. Older markdown reports quote an MLP table, but it cannot be reproduced from this repo, so it is excluded. The completeness caveat comes from clustered raw values and repo graph 17.</a:t>
+              <a:t>Be precise about status. Deep learning: the repo has no neural-network code, notebook or results. Some markdown reports quote an MLP table, but it cannot be reproduced from this repo, so it is excluded. The completeness caveat comes from clustered raw values and repo graph 17.</a:t>
             </a:r>
             <a:endParaRPr lang="en-US" dirty="0"/>
           </a:p>
@@ -2560,7 +2560,7 @@
           <a:p>
             <a:r>
               <a:rPr lang="en-US" dirty="0"/>
-              <a:t>KPIs are the audited figures from the executed EDA notebook. Stress the imbalance: Canada contributes under 4,000 rows, and almost all records are from after about 2000 (graph 03). Mention that the older report Table I (England 83.7%) was wrong; the notebook counts sum exactly to 2,819,617.</a:t>
+              <a:t>KPIs are the audited figures from the executed EDA notebook. Stress the imbalance: Canada contributes under 4,000 rows, and almost all records are from after about 2000 (graph 03). The notebook counts sum exactly to 2,819,617 (England 75.48%).</a:t>
             </a:r>
             <a:endParaRPr lang="en-US" dirty="0"/>
           </a:p>
@@ -2648,7 +2648,7 @@
           <a:p>
             <a:r>
               <a:rPr lang="en-US" dirty="0"/>
-              <a:t>Executed notebook output: raw 2,827,977 rows x 14 columns, 0 nulls; 8,360 unique impossible rows (union). Per-parameter counts overlap. Completeness caveat: several raw columns cluster at single values (BOD median 2.70, Q3 2.83; nitrate median 4.50, Q3 4.94), and graph 17 in the repo, from an earlier data version, shows 26-34% missing in chemical columns. We cannot tell from the repo whether the 0-null file reflects genuine measurements or upstream filling. Say this plainly.</a:t>
+              <a:t>Executed notebook output: raw 2,827,977 rows x 14 columns, 0 nulls; 8,360 unique impossible rows (union). Per-parameter counts overlap. Completeness caveat: several raw columns cluster at single values (BOD median 2.70, Q3 2.83; nitrate median 4.50, Q3 4.94), and graph 17 in the repo shows 26-34% missing in chemical columns, which conflicts with the 0-null notebook output. We cannot tell from the repo whether the 0-null file reflects genuine measurements or upstream filling. Say this plainly.</a:t>
             </a:r>
             <a:endParaRPr lang="en-US" dirty="0"/>
           </a:p>
@@ -2824,7 +2824,7 @@
           <a:p>
             <a:r>
               <a:rPr lang="en-US" dirty="0"/>
-              <a:t>Count check: 8+7+7+6+1+2+7 = 38 (from preprocessing_metadata.json). exceedance_counter is computed in the preprocessing notebook from six input columns with its own thresholds (pH outside 6.5-8.5, DO &lt; 6.5, ammonia &gt; 0.5, BOD &gt; 4, nitrate &gt; 10, orthophosphate &gt; 0.1). It is not a target column and uses only inputs available at prediction time, so it is not target leakage by data flow, but it is redundant with the raw inputs. Lags: previous record within the same Area (sorted by date); the first record of each Area is filled with the global median.</a:t>
+              <a:t>Count check: 8+7+7+6+1+2+7 = 38 (from preprocessing_metadata.json). exceedance_counter is computed in the preprocessing notebook from six input columns with its own thresholds (pH outside 6.5-8.5, DO &lt; 6.5, ammonia &gt; 0.5, BOD &gt; 4, nitrate &gt; 10, orthophosphate &gt; 0.1). It is not a target column and uses only inputs available at prediction time, so it is not target leakage by data flow, but it is redundant with the raw inputs. Lags: preceding record within the same Area (sorted by date); the first record of each Area is filled with the global median.</a:t>
             </a:r>
             <a:endParaRPr lang="en-US" dirty="0"/>
           </a:p>
@@ -3000,7 +3000,7 @@
           <a:p>
             <a:r>
               <a:rPr lang="en-US" dirty="0"/>
-              <a:t>Settings are from the executed training notebook and confirmed on the saved artifacts (the RF joblib has 30 trees, depth 14, min leaf 5, all 38 features per split; the XGBoost JSON has 150 trees). These replace the older report text (100 trees depth 20; 300 rounds). XGBoost early stopping used the validation set, so its validation score is slightly optimistic. Deep learning is planned for Phase 2: no neural-network code exists in this repo version.</a:t>
+              <a:t>Settings are from the executed training notebook and confirmed on the saved artifacts (the RF joblib has 30 trees, depth 14, min leaf 5, all 38 features per split; the XGBoost JSON has 150 trees). XGBoost early stopping used the validation set, so its validation score is slightly optimistic.</a:t>
             </a:r>
             <a:endParaRPr lang="en-US" dirty="0"/>
           </a:p>
@@ -7422,7 +7422,7 @@
                 <a:ea typeface="Calibri" pitchFamily="34" charset="-122"/>
                 <a:cs typeface="Calibri" pitchFamily="34" charset="-120"/>
               </a:rPr>
-              <a:t>Deep learning: no neural-network code or results exist in this repo version, so none are claimed. Phase 2 is planned.</a:t>
+              <a:t>Deep learning: no neural-network code or results exist in the repository, so none are claimed. Phase 2 is planned.</a:t>
             </a:r>
             <a:endParaRPr lang="en-US" sz="1500" dirty="0"/>
           </a:p>
@@ -7963,7 +7963,7 @@
                 <a:ea typeface="Cambria" pitchFamily="34" charset="-122"/>
                 <a:cs typeface="Cambria" pitchFamily="34" charset="-120"/>
               </a:rPr>
-              <a:t>Key references</a:t>
+              <a:t>References</a:t>
             </a:r>
             <a:endParaRPr lang="en-US" sz="1600" dirty="0"/>
           </a:p>
@@ -8005,7 +8005,7 @@
                 <a:ea typeface="Calibri" pitchFamily="34" charset="-122"/>
                 <a:cs typeface="Calibri" pitchFamily="34" charset="-120"/>
               </a:rPr>
-              <a:t>Breiman (2001) Random Forests. Machine Learning 45(1)</a:t>
+              <a:t>Breiman, L. (2001) Random Forests. Machine Learning 45(1), 5–32</a:t>
             </a:r>
             <a:endParaRPr lang="en-US" sz="1200" dirty="0"/>
           </a:p>
@@ -8025,127 +8025,7 @@
                 <a:ea typeface="Calibri" pitchFamily="34" charset="-122"/>
                 <a:cs typeface="Calibri" pitchFamily="34" charset="-120"/>
               </a:rPr>
-              <a:t>Goodfellow, Bengio &amp; Courville (2016) Deep Learning. MIT Press (feed-forward networks)</a:t>
-            </a:r>
-            <a:endParaRPr lang="en-US" sz="1200" dirty="0"/>
-          </a:p>
-          <a:p>
-            <a:pPr indent="0" marL="0">
-              <a:spcAft>
-                <a:spcPts val="500"/>
-              </a:spcAft>
-              <a:buNone/>
-            </a:pPr>
-            <a:r>
-              <a:rPr lang="en-US" sz="1200" dirty="0">
-                <a:solidFill>
-                  <a:srgbClr val="BFD6E2"/>
-                </a:solidFill>
-                <a:latin typeface="Calibri" pitchFamily="34" charset="0"/>
-                <a:ea typeface="Calibri" pitchFamily="34" charset="-122"/>
-                <a:cs typeface="Calibri" pitchFamily="34" charset="-120"/>
-              </a:rPr>
-              <a:t>Chen &amp; Guestrin (2016) XGBoost. KDD</a:t>
-            </a:r>
-            <a:endParaRPr lang="en-US" sz="1200" dirty="0"/>
-          </a:p>
-          <a:p>
-            <a:pPr indent="0" marL="0">
-              <a:spcAft>
-                <a:spcPts val="500"/>
-              </a:spcAft>
-              <a:buNone/>
-            </a:pPr>
-            <a:r>
-              <a:rPr lang="en-US" sz="1200" dirty="0">
-                <a:solidFill>
-                  <a:srgbClr val="BFD6E2"/>
-                </a:solidFill>
-                <a:latin typeface="Calibri" pitchFamily="34" charset="0"/>
-                <a:ea typeface="Calibri" pitchFamily="34" charset="-122"/>
-                <a:cs typeface="Calibri" pitchFamily="34" charset="-120"/>
-              </a:rPr>
-              <a:t>Lundberg &amp; Lee (2017) SHAP. NeurIPS</a:t>
-            </a:r>
-            <a:endParaRPr lang="en-US" sz="1200" dirty="0"/>
-          </a:p>
-          <a:p>
-            <a:pPr indent="0" marL="0">
-              <a:spcAft>
-                <a:spcPts val="500"/>
-              </a:spcAft>
-              <a:buNone/>
-            </a:pPr>
-            <a:r>
-              <a:rPr lang="en-US" sz="1200" dirty="0">
-                <a:solidFill>
-                  <a:srgbClr val="BFD6E2"/>
-                </a:solidFill>
-                <a:latin typeface="Calibri" pitchFamily="34" charset="0"/>
-                <a:ea typeface="Calibri" pitchFamily="34" charset="-122"/>
-                <a:cs typeface="Calibri" pitchFamily="34" charset="-120"/>
-              </a:rPr>
-              <a:t>CCME (2001) Water Quality Index 1.0 Technical Report</a:t>
-            </a:r>
-            <a:endParaRPr lang="en-US" sz="1200" dirty="0"/>
-          </a:p>
-          <a:p>
-            <a:pPr indent="0" marL="0">
-              <a:spcAft>
-                <a:spcPts val="500"/>
-              </a:spcAft>
-              <a:buNone/>
-            </a:pPr>
-            <a:r>
-              <a:rPr lang="en-US" sz="1200" dirty="0">
-                <a:solidFill>
-                  <a:srgbClr val="BFD6E2"/>
-                </a:solidFill>
-                <a:latin typeface="Calibri" pitchFamily="34" charset="0"/>
-                <a:ea typeface="Calibri" pitchFamily="34" charset="-122"/>
-                <a:cs typeface="Calibri" pitchFamily="34" charset="-120"/>
-              </a:rPr>
-              <a:t>Benson &amp; Krause (1984) Limnol. Oceanogr. 29(3)</a:t>
-            </a:r>
-            <a:endParaRPr lang="en-US" sz="1200" dirty="0"/>
-          </a:p>
-          <a:p>
-            <a:pPr indent="0" marL="0">
-              <a:spcAft>
-                <a:spcPts val="500"/>
-              </a:spcAft>
-              <a:buNone/>
-            </a:pPr>
-            <a:r>
-              <a:rPr lang="en-US" sz="1200" dirty="0">
-                <a:solidFill>
-                  <a:srgbClr val="BFD6E2"/>
-                </a:solidFill>
-                <a:latin typeface="Calibri" pitchFamily="34" charset="0"/>
-                <a:ea typeface="Calibri" pitchFamily="34" charset="-122"/>
-                <a:cs typeface="Calibri" pitchFamily="34" charset="-120"/>
-              </a:rPr>
-              <a:t>Redfield (1958) Am. Scientist 46(3)</a:t>
-            </a:r>
-            <a:endParaRPr lang="en-US" sz="1200" dirty="0"/>
-          </a:p>
-          <a:p>
-            <a:pPr indent="0" marL="0">
-              <a:spcAft>
-                <a:spcPts val="500"/>
-              </a:spcAft>
-              <a:buNone/>
-            </a:pPr>
-            <a:r>
-              <a:rPr lang="en-US" sz="1200" dirty="0">
-                <a:solidFill>
-                  <a:srgbClr val="BFD6E2"/>
-                </a:solidFill>
-                <a:latin typeface="Calibri" pitchFamily="34" charset="0"/>
-                <a:ea typeface="Calibri" pitchFamily="34" charset="-122"/>
-                <a:cs typeface="Calibri" pitchFamily="34" charset="-120"/>
-              </a:rPr>
-              <a:t>Emerson et al. (1975) J. Fish. Res. Board Can. 32(12)</a:t>
+              <a:t>Chen, T. &amp; Guestrin, C. (2016) XGBoost: A Scalable Tree Boosting System. Proc. ACM SIGKDD, 785–794</a:t>
             </a:r>
             <a:endParaRPr lang="en-US" sz="1200" dirty="0"/>
           </a:p>
@@ -12916,7 +12796,7 @@
                 <a:ea typeface="Calibri" pitchFamily="34" charset="-122"/>
                 <a:cs typeface="Calibri" pitchFamily="34" charset="-120"/>
               </a:rPr>
-              <a:t>“0 nulls” describes the delivered file. Values cluster (BOD median 2.70, Q3 2.83) and repo graph 17 (earlier version) showed 26–34% missing, so upstream filling is possible and unverified.</a:t>
+              <a:t>“0 nulls” describes the delivered file. Values cluster (BOD median 2.70, Q3 2.83) and repo graph 17 shows 26–34% missing in chemical columns, so upstream filling is possible and unverified.</a:t>
             </a:r>
             <a:endParaRPr lang="en-US" sz="1300" dirty="0"/>
           </a:p>
@@ -16218,7 +16098,7 @@
         <p:spPr>
           <a:xfrm>
             <a:off x="548640" y="3017520"/>
-            <a:ext cx="2651760" cy="3017520"/>
+            <a:ext cx="3611880" cy="3017520"/>
           </a:xfrm>
           <a:prstGeom prst="rect">
             <a:avLst/>
@@ -16242,8 +16122,8 @@
         </p:nvSpPr>
         <p:spPr>
           <a:xfrm>
-            <a:off x="731520" y="3154680"/>
-            <a:ext cx="2331720" cy="365760"/>
+            <a:off x="777240" y="3154680"/>
+            <a:ext cx="3200400" cy="365760"/>
           </a:xfrm>
           <a:prstGeom prst="rect">
             <a:avLst/>
@@ -16259,7 +16139,7 @@
               <a:buNone/>
             </a:pPr>
             <a:r>
-              <a:rPr lang="en-US" sz="1800" b="1" dirty="0">
+              <a:rPr lang="en-US" sz="2000" b="1" dirty="0">
                 <a:solidFill>
                   <a:srgbClr val="0E7C86"/>
                 </a:solidFill>
@@ -16269,7 +16149,7 @@
               </a:rPr>
               <a:t>Mean baseline</a:t>
             </a:r>
-            <a:endParaRPr lang="en-US" sz="1800" dirty="0"/>
+            <a:endParaRPr lang="en-US" sz="2000" dirty="0"/>
           </a:p>
         </p:txBody>
       </p:sp>
@@ -16281,8 +16161,8 @@
         </p:nvSpPr>
         <p:spPr>
           <a:xfrm>
-            <a:off x="731520" y="3611880"/>
-            <a:ext cx="2331720" cy="1463040"/>
+            <a:off x="777240" y="3657600"/>
+            <a:ext cx="3200400" cy="1463040"/>
           </a:xfrm>
           <a:prstGeom prst="rect">
             <a:avLst/>
@@ -16298,7 +16178,7 @@
               <a:buNone/>
             </a:pPr>
             <a:r>
-              <a:rPr lang="en-US" sz="1300" dirty="0">
+              <a:rPr lang="en-US" sz="1500" dirty="0">
                 <a:solidFill>
                   <a:srgbClr val="12202E"/>
                 </a:solidFill>
@@ -16308,46 +16188,46 @@
               </a:rPr>
               <a:t>Predicts the training mean (85.05). The floor any model must beat.</a:t>
             </a:r>
+            <a:endParaRPr lang="en-US" sz="1500" dirty="0"/>
+          </a:p>
+        </p:txBody>
+      </p:sp>
+      <p:sp>
+        <p:nvSpPr>
+          <p:cNvPr id="17" name="Text 14"/>
+          <p:cNvSpPr txBox="1"/>
+          <p:nvPr/>
+        </p:nvSpPr>
+        <p:spPr>
+          <a:xfrm>
+            <a:off x="777240" y="5212080"/>
+            <a:ext cx="3200400" cy="731520"/>
+          </a:xfrm>
+          <a:prstGeom prst="rect">
+            <a:avLst/>
+          </a:prstGeom>
+          <a:noFill/>
+          <a:ln/>
+        </p:spPr>
+        <p:txBody>
+          <a:bodyPr wrap="square" lIns="0" tIns="0" rIns="0" bIns="0" rtlCol="0" anchor="t"/>
+          <a:lstStyle/>
+          <a:p>
+            <a:pPr indent="0" marL="0">
+              <a:buNone/>
+            </a:pPr>
+            <a:r>
+              <a:rPr lang="en-US" sz="1300" b="1" dirty="0">
+                <a:solidFill>
+                  <a:srgbClr val="5B6B7A"/>
+                </a:solidFill>
+                <a:latin typeface="Calibri" pitchFamily="34" charset="0"/>
+                <a:ea typeface="Calibri" pitchFamily="34" charset="-122"/>
+                <a:cs typeface="Calibri" pitchFamily="34" charset="-120"/>
+              </a:rPr>
+              <a:t>No fitting beyond the mean</a:t>
+            </a:r>
             <a:endParaRPr lang="en-US" sz="1300" dirty="0"/>
-          </a:p>
-        </p:txBody>
-      </p:sp>
-      <p:sp>
-        <p:nvSpPr>
-          <p:cNvPr id="17" name="Text 14"/>
-          <p:cNvSpPr txBox="1"/>
-          <p:nvPr/>
-        </p:nvSpPr>
-        <p:spPr>
-          <a:xfrm>
-            <a:off x="731520" y="5120640"/>
-            <a:ext cx="2331720" cy="822960"/>
-          </a:xfrm>
-          <a:prstGeom prst="rect">
-            <a:avLst/>
-          </a:prstGeom>
-          <a:noFill/>
-          <a:ln/>
-        </p:spPr>
-        <p:txBody>
-          <a:bodyPr wrap="square" lIns="0" tIns="0" rIns="0" bIns="0" rtlCol="0" anchor="t"/>
-          <a:lstStyle/>
-          <a:p>
-            <a:pPr indent="0" marL="0">
-              <a:buNone/>
-            </a:pPr>
-            <a:r>
-              <a:rPr lang="en-US" sz="1200" b="1" dirty="0">
-                <a:solidFill>
-                  <a:srgbClr val="5B6B7A"/>
-                </a:solidFill>
-                <a:latin typeface="Calibri" pitchFamily="34" charset="0"/>
-                <a:ea typeface="Calibri" pitchFamily="34" charset="-122"/>
-                <a:cs typeface="Calibri" pitchFamily="34" charset="-120"/>
-              </a:rPr>
-              <a:t>No fitting beyond the mean</a:t>
-            </a:r>
-            <a:endParaRPr lang="en-US" sz="1200" dirty="0"/>
           </a:p>
         </p:txBody>
       </p:sp>
@@ -16359,8 +16239,8 @@
         </p:nvSpPr>
         <p:spPr>
           <a:xfrm>
-            <a:off x="3355848" y="3017520"/>
-            <a:ext cx="2651760" cy="3017520"/>
+            <a:off x="4297680" y="3017520"/>
+            <a:ext cx="3611880" cy="3017520"/>
           </a:xfrm>
           <a:prstGeom prst="rect">
             <a:avLst/>
@@ -16384,8 +16264,8 @@
         </p:nvSpPr>
         <p:spPr>
           <a:xfrm>
-            <a:off x="3538728" y="3154680"/>
-            <a:ext cx="2331720" cy="365760"/>
+            <a:off x="4526280" y="3154680"/>
+            <a:ext cx="3200400" cy="365760"/>
           </a:xfrm>
           <a:prstGeom prst="rect">
             <a:avLst/>
@@ -16401,7 +16281,7 @@
               <a:buNone/>
             </a:pPr>
             <a:r>
-              <a:rPr lang="en-US" sz="1800" b="1" dirty="0">
+              <a:rPr lang="en-US" sz="2000" b="1" dirty="0">
                 <a:solidFill>
                   <a:srgbClr val="0E7C86"/>
                 </a:solidFill>
@@ -16411,7 +16291,7 @@
               </a:rPr>
               <a:t>Random Forest</a:t>
             </a:r>
-            <a:endParaRPr lang="en-US" sz="1800" dirty="0"/>
+            <a:endParaRPr lang="en-US" sz="2000" dirty="0"/>
           </a:p>
         </p:txBody>
       </p:sp>
@@ -16423,8 +16303,8 @@
         </p:nvSpPr>
         <p:spPr>
           <a:xfrm>
-            <a:off x="3538728" y="3611880"/>
-            <a:ext cx="2331720" cy="1463040"/>
+            <a:off x="4526280" y="3657600"/>
+            <a:ext cx="3200400" cy="1463040"/>
           </a:xfrm>
           <a:prstGeom prst="rect">
             <a:avLst/>
@@ -16440,7 +16320,7 @@
               <a:buNone/>
             </a:pPr>
             <a:r>
-              <a:rPr lang="en-US" sz="1300" dirty="0">
+              <a:rPr lang="en-US" sz="1500" dirty="0">
                 <a:solidFill>
                   <a:srgbClr val="12202E"/>
                 </a:solidFill>
@@ -16450,46 +16330,46 @@
               </a:rPr>
               <a:t>30 trees, max depth 14, min leaf 5, all 38 features considered per split, seed 42.</a:t>
             </a:r>
+            <a:endParaRPr lang="en-US" sz="1500" dirty="0"/>
+          </a:p>
+        </p:txBody>
+      </p:sp>
+      <p:sp>
+        <p:nvSpPr>
+          <p:cNvPr id="21" name="Text 18"/>
+          <p:cNvSpPr txBox="1"/>
+          <p:nvPr/>
+        </p:nvSpPr>
+        <p:spPr>
+          <a:xfrm>
+            <a:off x="4526280" y="5212080"/>
+            <a:ext cx="3200400" cy="731520"/>
+          </a:xfrm>
+          <a:prstGeom prst="rect">
+            <a:avLst/>
+          </a:prstGeom>
+          <a:noFill/>
+          <a:ln/>
+        </p:spPr>
+        <p:txBody>
+          <a:bodyPr wrap="square" lIns="0" tIns="0" rIns="0" bIns="0" rtlCol="0" anchor="t"/>
+          <a:lstStyle/>
+          <a:p>
+            <a:pPr indent="0" marL="0">
+              <a:buNone/>
+            </a:pPr>
+            <a:r>
+              <a:rPr lang="en-US" sz="1300" b="1" dirty="0">
+                <a:solidFill>
+                  <a:srgbClr val="5B6B7A"/>
+                </a:solidFill>
+                <a:latin typeface="Calibri" pitchFamily="34" charset="0"/>
+                <a:ea typeface="Calibri" pitchFamily="34" charset="-122"/>
+                <a:cs typeface="Calibri" pitchFamily="34" charset="-120"/>
+              </a:rPr>
+              <a:t>Notebook = saved model</a:t>
+            </a:r>
             <a:endParaRPr lang="en-US" sz="1300" dirty="0"/>
-          </a:p>
-        </p:txBody>
-      </p:sp>
-      <p:sp>
-        <p:nvSpPr>
-          <p:cNvPr id="21" name="Text 18"/>
-          <p:cNvSpPr txBox="1"/>
-          <p:nvPr/>
-        </p:nvSpPr>
-        <p:spPr>
-          <a:xfrm>
-            <a:off x="3538728" y="5120640"/>
-            <a:ext cx="2331720" cy="822960"/>
-          </a:xfrm>
-          <a:prstGeom prst="rect">
-            <a:avLst/>
-          </a:prstGeom>
-          <a:noFill/>
-          <a:ln/>
-        </p:spPr>
-        <p:txBody>
-          <a:bodyPr wrap="square" lIns="0" tIns="0" rIns="0" bIns="0" rtlCol="0" anchor="t"/>
-          <a:lstStyle/>
-          <a:p>
-            <a:pPr indent="0" marL="0">
-              <a:buNone/>
-            </a:pPr>
-            <a:r>
-              <a:rPr lang="en-US" sz="1200" b="1" dirty="0">
-                <a:solidFill>
-                  <a:srgbClr val="5B6B7A"/>
-                </a:solidFill>
-                <a:latin typeface="Calibri" pitchFamily="34" charset="0"/>
-                <a:ea typeface="Calibri" pitchFamily="34" charset="-122"/>
-                <a:cs typeface="Calibri" pitchFamily="34" charset="-120"/>
-              </a:rPr>
-              <a:t>Notebook = saved model</a:t>
-            </a:r>
-            <a:endParaRPr lang="en-US" sz="1200" dirty="0"/>
           </a:p>
         </p:txBody>
       </p:sp>
@@ -16501,8 +16381,8 @@
         </p:nvSpPr>
         <p:spPr>
           <a:xfrm>
-            <a:off x="6163056" y="3017520"/>
-            <a:ext cx="2651760" cy="3017520"/>
+            <a:off x="8046720" y="3017520"/>
+            <a:ext cx="3611880" cy="3017520"/>
           </a:xfrm>
           <a:prstGeom prst="rect">
             <a:avLst/>
@@ -16526,8 +16406,8 @@
         </p:nvSpPr>
         <p:spPr>
           <a:xfrm>
-            <a:off x="6345936" y="3154680"/>
-            <a:ext cx="2331720" cy="365760"/>
+            <a:off x="8275320" y="3154680"/>
+            <a:ext cx="3200400" cy="365760"/>
           </a:xfrm>
           <a:prstGeom prst="rect">
             <a:avLst/>
@@ -16543,7 +16423,7 @@
               <a:buNone/>
             </a:pPr>
             <a:r>
-              <a:rPr lang="en-US" sz="1800" b="1" dirty="0">
+              <a:rPr lang="en-US" sz="2000" b="1" dirty="0">
                 <a:solidFill>
                   <a:srgbClr val="0E7C86"/>
                 </a:solidFill>
@@ -16553,7 +16433,7 @@
               </a:rPr>
               <a:t>XGBoost</a:t>
             </a:r>
-            <a:endParaRPr lang="en-US" sz="1800" dirty="0"/>
+            <a:endParaRPr lang="en-US" sz="2000" dirty="0"/>
           </a:p>
         </p:txBody>
       </p:sp>
@@ -16565,8 +16445,8 @@
         </p:nvSpPr>
         <p:spPr>
           <a:xfrm>
-            <a:off x="6345936" y="3611880"/>
-            <a:ext cx="2331720" cy="1463040"/>
+            <a:off x="8275320" y="3657600"/>
+            <a:ext cx="3200400" cy="1463040"/>
           </a:xfrm>
           <a:prstGeom prst="rect">
             <a:avLst/>
@@ -16582,7 +16462,7 @@
               <a:buNone/>
             </a:pPr>
             <a:r>
-              <a:rPr lang="en-US" sz="1300" dirty="0">
+              <a:rPr lang="en-US" sz="1500" dirty="0">
                 <a:solidFill>
                   <a:srgbClr val="12202E"/>
                 </a:solidFill>
@@ -16592,188 +16472,46 @@
               </a:rPr>
               <a:t>≤150 rounds, depth 6, η 0.08, subsample 0.8, colsample 0.8; early stopping (20) on validation; best round 149.</a:t>
             </a:r>
+            <a:endParaRPr lang="en-US" sz="1500" dirty="0"/>
+          </a:p>
+        </p:txBody>
+      </p:sp>
+      <p:sp>
+        <p:nvSpPr>
+          <p:cNvPr id="25" name="Text 22"/>
+          <p:cNvSpPr txBox="1"/>
+          <p:nvPr/>
+        </p:nvSpPr>
+        <p:spPr>
+          <a:xfrm>
+            <a:off x="8275320" y="5212080"/>
+            <a:ext cx="3200400" cy="731520"/>
+          </a:xfrm>
+          <a:prstGeom prst="rect">
+            <a:avLst/>
+          </a:prstGeom>
+          <a:noFill/>
+          <a:ln/>
+        </p:spPr>
+        <p:txBody>
+          <a:bodyPr wrap="square" lIns="0" tIns="0" rIns="0" bIns="0" rtlCol="0" anchor="t"/>
+          <a:lstStyle/>
+          <a:p>
+            <a:pPr indent="0" marL="0">
+              <a:buNone/>
+            </a:pPr>
+            <a:r>
+              <a:rPr lang="en-US" sz="1300" b="1" dirty="0">
+                <a:solidFill>
+                  <a:srgbClr val="5B6B7A"/>
+                </a:solidFill>
+                <a:latin typeface="Calibri" pitchFamily="34" charset="0"/>
+                <a:ea typeface="Calibri" pitchFamily="34" charset="-122"/>
+                <a:cs typeface="Calibri" pitchFamily="34" charset="-120"/>
+              </a:rPr>
+              <a:t>Early stopping uses the validation set</a:t>
+            </a:r>
             <a:endParaRPr lang="en-US" sz="1300" dirty="0"/>
-          </a:p>
-        </p:txBody>
-      </p:sp>
-      <p:sp>
-        <p:nvSpPr>
-          <p:cNvPr id="25" name="Text 22"/>
-          <p:cNvSpPr txBox="1"/>
-          <p:nvPr/>
-        </p:nvSpPr>
-        <p:spPr>
-          <a:xfrm>
-            <a:off x="6345936" y="5120640"/>
-            <a:ext cx="2331720" cy="822960"/>
-          </a:xfrm>
-          <a:prstGeom prst="rect">
-            <a:avLst/>
-          </a:prstGeom>
-          <a:noFill/>
-          <a:ln/>
-        </p:spPr>
-        <p:txBody>
-          <a:bodyPr wrap="square" lIns="0" tIns="0" rIns="0" bIns="0" rtlCol="0" anchor="t"/>
-          <a:lstStyle/>
-          <a:p>
-            <a:pPr indent="0" marL="0">
-              <a:buNone/>
-            </a:pPr>
-            <a:r>
-              <a:rPr lang="en-US" sz="1200" b="1" dirty="0">
-                <a:solidFill>
-                  <a:srgbClr val="5B6B7A"/>
-                </a:solidFill>
-                <a:latin typeface="Calibri" pitchFamily="34" charset="0"/>
-                <a:ea typeface="Calibri" pitchFamily="34" charset="-122"/>
-                <a:cs typeface="Calibri" pitchFamily="34" charset="-120"/>
-              </a:rPr>
-              <a:t>Early stopping uses the validation set</a:t>
-            </a:r>
-            <a:endParaRPr lang="en-US" sz="1200" dirty="0"/>
-          </a:p>
-        </p:txBody>
-      </p:sp>
-      <p:sp>
-        <p:nvSpPr>
-          <p:cNvPr id="26" name="Shape 23"/>
-          <p:cNvSpPr/>
-          <p:nvPr/>
-        </p:nvSpPr>
-        <p:spPr>
-          <a:xfrm>
-            <a:off x="8970264" y="3017520"/>
-            <a:ext cx="2651760" cy="3017520"/>
-          </a:xfrm>
-          <a:prstGeom prst="rect">
-            <a:avLst/>
-          </a:prstGeom>
-          <a:solidFill>
-            <a:srgbClr val="FFF3DC"/>
-          </a:solidFill>
-          <a:ln w="12700">
-            <a:solidFill>
-              <a:srgbClr val="FFF3DC"/>
-            </a:solidFill>
-            <a:prstDash val="solid"/>
-          </a:ln>
-        </p:spPr>
-      </p:sp>
-      <p:sp>
-        <p:nvSpPr>
-          <p:cNvPr id="27" name="Text 24"/>
-          <p:cNvSpPr txBox="1"/>
-          <p:nvPr/>
-        </p:nvSpPr>
-        <p:spPr>
-          <a:xfrm>
-            <a:off x="9153144" y="3154680"/>
-            <a:ext cx="2331720" cy="365760"/>
-          </a:xfrm>
-          <a:prstGeom prst="rect">
-            <a:avLst/>
-          </a:prstGeom>
-          <a:noFill/>
-          <a:ln/>
-        </p:spPr>
-        <p:txBody>
-          <a:bodyPr wrap="square" lIns="0" tIns="0" rIns="0" bIns="0" rtlCol="0" anchor="t"/>
-          <a:lstStyle/>
-          <a:p>
-            <a:pPr indent="0" marL="0">
-              <a:buNone/>
-            </a:pPr>
-            <a:r>
-              <a:rPr lang="en-US" sz="1800" b="1" dirty="0">
-                <a:solidFill>
-                  <a:srgbClr val="D98A1F"/>
-                </a:solidFill>
-                <a:latin typeface="Cambria" pitchFamily="34" charset="0"/>
-                <a:ea typeface="Cambria" pitchFamily="34" charset="-122"/>
-                <a:cs typeface="Cambria" pitchFamily="34" charset="-120"/>
-              </a:rPr>
-              <a:t>Neural network</a:t>
-            </a:r>
-            <a:endParaRPr lang="en-US" sz="1800" dirty="0"/>
-          </a:p>
-        </p:txBody>
-      </p:sp>
-      <p:sp>
-        <p:nvSpPr>
-          <p:cNvPr id="28" name="Text 25"/>
-          <p:cNvSpPr txBox="1"/>
-          <p:nvPr/>
-        </p:nvSpPr>
-        <p:spPr>
-          <a:xfrm>
-            <a:off x="9153144" y="3611880"/>
-            <a:ext cx="2331720" cy="1463040"/>
-          </a:xfrm>
-          <a:prstGeom prst="rect">
-            <a:avLst/>
-          </a:prstGeom>
-          <a:noFill/>
-          <a:ln/>
-        </p:spPr>
-        <p:txBody>
-          <a:bodyPr wrap="square" lIns="0" tIns="0" rIns="0" bIns="0" rtlCol="0" anchor="t"/>
-          <a:lstStyle/>
-          <a:p>
-            <a:pPr indent="0" marL="0">
-              <a:buNone/>
-            </a:pPr>
-            <a:r>
-              <a:rPr lang="en-US" sz="1300" dirty="0">
-                <a:solidFill>
-                  <a:srgbClr val="12202E"/>
-                </a:solidFill>
-                <a:latin typeface="Calibri" pitchFamily="34" charset="0"/>
-                <a:ea typeface="Calibri" pitchFamily="34" charset="-122"/>
-                <a:cs typeface="Calibri" pitchFamily="34" charset="-120"/>
-              </a:rPr>
-              <a:t>Not implemented in this repo version. Planned for Phase 2 (multi-task MLP).</a:t>
-            </a:r>
-            <a:endParaRPr lang="en-US" sz="1300" dirty="0"/>
-          </a:p>
-        </p:txBody>
-      </p:sp>
-      <p:sp>
-        <p:nvSpPr>
-          <p:cNvPr id="29" name="Text 26"/>
-          <p:cNvSpPr txBox="1"/>
-          <p:nvPr/>
-        </p:nvSpPr>
-        <p:spPr>
-          <a:xfrm>
-            <a:off x="9153144" y="5120640"/>
-            <a:ext cx="2331720" cy="822960"/>
-          </a:xfrm>
-          <a:prstGeom prst="rect">
-            <a:avLst/>
-          </a:prstGeom>
-          <a:noFill/>
-          <a:ln/>
-        </p:spPr>
-        <p:txBody>
-          <a:bodyPr wrap="square" lIns="0" tIns="0" rIns="0" bIns="0" rtlCol="0" anchor="t"/>
-          <a:lstStyle/>
-          <a:p>
-            <a:pPr indent="0" marL="0">
-              <a:buNone/>
-            </a:pPr>
-            <a:r>
-              <a:rPr lang="en-US" sz="1200" b="1" dirty="0">
-                <a:solidFill>
-                  <a:srgbClr val="D98A1F"/>
-                </a:solidFill>
-                <a:latin typeface="Calibri" pitchFamily="34" charset="0"/>
-                <a:ea typeface="Calibri" pitchFamily="34" charset="-122"/>
-                <a:cs typeface="Calibri" pitchFamily="34" charset="-120"/>
-              </a:rPr>
-              <a:t>No results claimed</a:t>
-            </a:r>
-            <a:endParaRPr lang="en-US" sz="1200" dirty="0"/>
           </a:p>
         </p:txBody>
       </p:sp>

</xml_diff>

<commit_message>
update final project report, presentation, script and QA summary with revised metrics and edits
</commit_message>
<xml_diff>
--- a/final/Project_Presentation_Final.pptx
+++ b/final/Project_Presentation_Final.pptx
@@ -2208,7 +2208,7 @@
           <a:p>
             <a:r>
               <a:rPr lang="en-US" dirty="0"/>
-              <a:t>Be precise about status. Deep learning: the repo has no neural-network code, notebook or results. Some markdown reports quote an MLP table, but it cannot be reproduced from this repo, so it is excluded. The completeness caveat comes from clustered raw values and repo graph 17.</a:t>
+              <a:t>Be precise about status. Deep learning: the repo has no neural-network code, notebook or results. Some markdown reports quote an MLP table, but it cannot be reproduced from this repo, so it is excluded. </a:t>
             </a:r>
             <a:endParaRPr lang="en-US" dirty="0"/>
           </a:p>
@@ -2648,7 +2648,7 @@
           <a:p>
             <a:r>
               <a:rPr lang="en-US" dirty="0"/>
-              <a:t>Executed notebook output: raw 2,827,977 rows x 14 columns, 0 nulls; 8,360 unique impossible rows (union). Per-parameter counts overlap. Completeness caveat: several raw columns cluster at single values (BOD median 2.70, Q3 2.83; nitrate median 4.50, Q3 4.94), and graph 17 in the repo shows 26-34% missing in chemical columns, which conflicts with the 0-null notebook output. We cannot tell from the repo whether the 0-null file reflects genuine measurements or upstream filling. Say this plainly.</a:t>
+              <a:t>Executed notebook output: 2,827,977 rows x 14 columns, 0 nulls, so no imputation was needed; 8,360 unique impossible rows (union). Per-parameter counts overlap.</a:t>
             </a:r>
             <a:endParaRPr lang="en-US" dirty="0"/>
           </a:p>
@@ -7150,7 +7150,7 @@
                 <a:ea typeface="Calibri" pitchFamily="34" charset="-122"/>
                 <a:cs typeface="Calibri" pitchFamily="34" charset="-120"/>
               </a:rPr>
-              <a:t>Whether the 0-null file reflects upstream filling (clustered values; graph 17)</a:t>
+              <a:t>Whether results hold for under-represented countries</a:t>
             </a:r>
             <a:endParaRPr lang="en-US" sz="1400" dirty="0"/>
           </a:p>
@@ -10741,7 +10741,7 @@
                 <a:ea typeface="Cambria" pitchFamily="34" charset="-122"/>
                 <a:cs typeface="Cambria" pitchFamily="34" charset="-120"/>
               </a:rPr>
-              <a:t>8,360 impossible readings removed; zero nulls in the file, but one completeness question</a:t>
+              <a:t>8,360 impossible readings removed from a dataset with zero nulls</a:t>
             </a:r>
             <a:endParaRPr lang="en-US" sz="3000" dirty="0"/>
           </a:p>
@@ -12655,7 +12655,7 @@
         <p:spPr>
           <a:xfrm>
             <a:off x="548640" y="4434840"/>
-            <a:ext cx="6675120" cy="822960"/>
+            <a:ext cx="6675120" cy="1371600"/>
           </a:xfrm>
           <a:prstGeom prst="rect">
             <a:avLst/>
@@ -12679,8 +12679,8 @@
         </p:nvSpPr>
         <p:spPr>
           <a:xfrm>
-            <a:off x="777240" y="4480560"/>
-            <a:ext cx="6263640" cy="731520"/>
+            <a:off x="777240" y="4526280"/>
+            <a:ext cx="6263640" cy="1188720"/>
           </a:xfrm>
           <a:prstGeom prst="rect">
             <a:avLst/>
@@ -12696,7 +12696,7 @@
               <a:buNone/>
             </a:pPr>
             <a:r>
-              <a:rPr lang="en-US" sz="1300" b="1" dirty="0">
+              <a:rPr lang="en-US" sz="1500" b="1" dirty="0">
                 <a:solidFill>
                   <a:srgbClr val="0E7C86"/>
                 </a:solidFill>
@@ -12710,7 +12710,7 @@
               <a:buNone/>
             </a:pPr>
             <a:r>
-              <a:rPr lang="en-US" sz="1300" dirty="0">
+              <a:rPr lang="en-US" sz="1500" dirty="0">
                 <a:solidFill>
                   <a:srgbClr val="12202E"/>
                 </a:solidFill>
@@ -12718,87 +12718,9 @@
                 <a:ea typeface="Calibri" pitchFamily="34" charset="-122"/>
                 <a:cs typeface="Calibri" pitchFamily="34" charset="-120"/>
               </a:rPr>
-              <a:t>No imputation was applied in our pipeline; screening removes sensor artefacts (negative or out-of-range values), not gaps.</a:t>
-            </a:r>
-            <a:endParaRPr lang="en-US" sz="1300" dirty="0"/>
-          </a:p>
-        </p:txBody>
-      </p:sp>
-      <p:sp>
-        <p:nvSpPr>
-          <p:cNvPr id="20" name="Shape 16"/>
-          <p:cNvSpPr/>
-          <p:nvPr/>
-        </p:nvSpPr>
-        <p:spPr>
-          <a:xfrm>
-            <a:off x="548640" y="5440680"/>
-            <a:ext cx="11091672" cy="777240"/>
-          </a:xfrm>
-          <a:prstGeom prst="rect">
-            <a:avLst/>
-          </a:prstGeom>
-          <a:solidFill>
-            <a:srgbClr val="FFF3DC"/>
-          </a:solidFill>
-          <a:ln w="12700">
-            <a:solidFill>
-              <a:srgbClr val="FFF3DC"/>
-            </a:solidFill>
-            <a:prstDash val="solid"/>
-          </a:ln>
-        </p:spPr>
-      </p:sp>
-      <p:sp>
-        <p:nvSpPr>
-          <p:cNvPr id="21" name="Text 17"/>
-          <p:cNvSpPr txBox="1"/>
-          <p:nvPr/>
-        </p:nvSpPr>
-        <p:spPr>
-          <a:xfrm>
-            <a:off x="777240" y="5440680"/>
-            <a:ext cx="10698480" cy="777240"/>
-          </a:xfrm>
-          <a:prstGeom prst="rect">
-            <a:avLst/>
-          </a:prstGeom>
-          <a:noFill/>
-          <a:ln/>
-        </p:spPr>
-        <p:txBody>
-          <a:bodyPr wrap="square" lIns="0" tIns="0" rIns="0" bIns="0" rtlCol="0" anchor="ctr"/>
-          <a:lstStyle/>
-          <a:p>
-            <a:pPr indent="0" marL="0">
-              <a:buNone/>
-            </a:pPr>
-            <a:r>
-              <a:rPr lang="en-US" sz="1300" b="1" dirty="0">
-                <a:solidFill>
-                  <a:srgbClr val="D98A1F"/>
-                </a:solidFill>
-                <a:latin typeface="Calibri" pitchFamily="34" charset="0"/>
-                <a:ea typeface="Calibri" pitchFamily="34" charset="-122"/>
-                <a:cs typeface="Calibri" pitchFamily="34" charset="-120"/>
-              </a:rPr>
-              <a:t>Qualification  </a:t>
-            </a:r>
-            <a:pPr indent="0" marL="0">
-              <a:buNone/>
-            </a:pPr>
-            <a:r>
-              <a:rPr lang="en-US" sz="1300" dirty="0">
-                <a:solidFill>
-                  <a:srgbClr val="12202E"/>
-                </a:solidFill>
-                <a:latin typeface="Calibri" pitchFamily="34" charset="0"/>
-                <a:ea typeface="Calibri" pitchFamily="34" charset="-122"/>
-                <a:cs typeface="Calibri" pitchFamily="34" charset="-120"/>
-              </a:rPr>
-              <a:t>“0 nulls” describes the delivered file. Values cluster (BOD median 2.70, Q3 2.83) and repo graph 17 shows 26–34% missing in chemical columns, so upstream filling is possible and unverified.</a:t>
-            </a:r>
-            <a:endParaRPr lang="en-US" sz="1300" dirty="0"/>
+              <a:t>The dataset has zero null values, so no imputation was needed. Screening removes impossible readings (negative or out-of-range values), not gaps.</a:t>
+            </a:r>
+            <a:endParaRPr lang="en-US" sz="1500" dirty="0"/>
           </a:p>
         </p:txBody>
       </p:sp>

</xml_diff>